<commit_message>
Agregar link del sitio en video (intro/simulador/conclusion + pie) y en diapositiva de producto del PPT
</commit_message>
<xml_diff>
--- a/Presentación Proyecto.pptx
+++ b/Presentación Proyecto.pptx
@@ -3939,6 +3939,48 @@
               <a:latin typeface="Calibri" panose="020F0502020204030204" pitchFamily="34" charset="0"/>
               <a:ea typeface="Calibri" panose="020F0502020204030204" pitchFamily="34" charset="0"/>
             </a:endParaRPr>
+          </a:p>
+        </p:txBody>
+      </p:sp>
+      <p:sp>
+        <p:nvSpPr>
+          <p:cNvPr id="5" name="TextBox 4"/>
+          <p:cNvSpPr txBox="1"/>
+          <p:nvPr/>
+        </p:nvSpPr>
+        <p:spPr>
+          <a:xfrm>
+            <a:off x="1258957" y="1900567"/>
+            <a:ext cx="5327484" cy="500000"/>
+          </a:xfrm>
+          <a:prstGeom prst="rect">
+            <a:avLst/>
+          </a:prstGeom>
+          <a:noFill/>
+        </p:spPr>
+        <p:txBody>
+          <a:bodyPr wrap="square">
+            <a:spAutoFit/>
+          </a:bodyPr>
+          <a:lstStyle/>
+          <a:p>
+            <a:r>
+              <a:rPr sz="1400">
+                <a:solidFill>
+                  <a:srgbClr val="333333"/>
+                </a:solidFill>
+              </a:rPr>
+              <a:t>Sitio web del proyecto (incluye simulador interactivo): </a:t>
+            </a:r>
+            <a:r>
+              <a:rPr sz="1400" b="1">
+                <a:solidFill>
+                  <a:srgbClr val="2263EB"/>
+                </a:solidFill>
+                <a:hlinkClick r:id="rId2"/>
+              </a:rPr>
+              <a:t>https://proyecto-calculo-optimizacion-cloud.vercel.app</a:t>
+            </a:r>
           </a:p>
         </p:txBody>
       </p:sp>

</xml_diff>

<commit_message>
Completar contenido de las 14 diapositivas del PPT (respetando su estructura original) y agregar script generador
</commit_message>
<xml_diff>
--- a/Presentación Proyecto.pptx
+++ b/Presentación Proyecto.pptx
@@ -3378,20 +3378,93 @@
         </p:nvSpPr>
         <p:spPr/>
         <p:txBody>
-          <a:bodyPr/>
+          <a:bodyPr wrap="square">
+            <a:noAutofit/>
+          </a:bodyPr>
           <a:lstStyle/>
           <a:p>
-            <a:r>
-              <a:rPr lang="es-ES" sz="1800" b="0" i="0" dirty="0">
-                <a:solidFill>
-                  <a:srgbClr val="000000"/>
-                </a:solidFill>
-                <a:effectLst/>
-                <a:latin typeface="Calibri" panose="020F0502020204030204" pitchFamily="34" charset="0"/>
-              </a:rPr>
-              <a:t>Diapositiva 1: Nombre del proyecto, integrantes, profesor, asignatura y carrera </a:t>
+            <a:pPr algn="ctr"/>
+            <a:r>
+              <a:rPr sz="3400" b="1">
+                <a:solidFill>
+                  <a:srgbClr val="222222"/>
+                </a:solidFill>
+                <a:latin typeface="Calibri"/>
+              </a:rPr>
+              <a:t>Minimización del costo de alojamiento en la nube</a:t>
             </a:r>
             <a:endParaRPr lang="es-CL" dirty="0"/>
+          </a:p>
+        </p:txBody>
+      </p:sp>
+      <p:sp>
+        <p:nvSpPr>
+          <p:cNvPr id="3" name="TextBox 2"/>
+          <p:cNvSpPr txBox="1"/>
+          <p:nvPr/>
+        </p:nvSpPr>
+        <p:spPr>
+          <a:xfrm>
+            <a:off x="1524000" y="3609963"/>
+            <a:ext cx="9144000" cy="1800000"/>
+          </a:xfrm>
+          <a:prstGeom prst="rect">
+            <a:avLst/>
+          </a:prstGeom>
+          <a:noFill/>
+        </p:spPr>
+        <p:txBody>
+          <a:bodyPr wrap="square">
+            <a:spAutoFit/>
+          </a:bodyPr>
+          <a:lstStyle/>
+          <a:p>
+            <a:pPr algn="ctr"/>
+            <a:r>
+              <a:rPr sz="2000">
+                <a:solidFill>
+                  <a:srgbClr val="555555"/>
+                </a:solidFill>
+                <a:latin typeface="Calibri"/>
+              </a:rPr>
+              <a:t>Andrés Carrasco Valdés</a:t>
+            </a:r>
+          </a:p>
+          <a:p>
+            <a:pPr algn="ctr"/>
+            <a:r>
+              <a:rPr sz="2000">
+                <a:solidFill>
+                  <a:srgbClr val="555555"/>
+                </a:solidFill>
+                <a:latin typeface="Calibri"/>
+              </a:rPr>
+              <a:t>Profesor: Carlos Castro Maldonado</a:t>
+            </a:r>
+          </a:p>
+          <a:p>
+            <a:pPr algn="ctr"/>
+            <a:r>
+              <a:rPr sz="2000">
+                <a:solidFill>
+                  <a:srgbClr val="555555"/>
+                </a:solidFill>
+                <a:latin typeface="Calibri"/>
+              </a:rPr>
+              <a:t>Asignatura: Cálculo Diferencial</a:t>
+            </a:r>
+          </a:p>
+          <a:p>
+            <a:pPr algn="ctr"/>
+            <a:r>
+              <a:rPr sz="2000">
+                <a:solidFill>
+                  <a:srgbClr val="555555"/>
+                </a:solidFill>
+                <a:latin typeface="Calibri"/>
+              </a:rPr>
+              <a:t>Carrera: Ingeniería en Informática</a:t>
+            </a:r>
           </a:p>
         </p:txBody>
       </p:sp>
@@ -3439,8 +3512,8 @@
         </p:nvSpPr>
         <p:spPr>
           <a:xfrm>
-            <a:off x="655093" y="1470991"/>
-            <a:ext cx="9630695" cy="923330"/>
+            <a:off x="838200" y="365125"/>
+            <a:ext cx="10515600" cy="6192875"/>
           </a:xfrm>
           <a:prstGeom prst="rect">
             <a:avLst/>
@@ -3449,257 +3522,18 @@
         </p:spPr>
         <p:txBody>
           <a:bodyPr wrap="square" rtlCol="0">
-            <a:spAutoFit/>
+            <a:noAutofit/>
           </a:bodyPr>
           <a:lstStyle/>
           <a:p>
             <a:r>
-              <a:rPr lang="es-ES" sz="1800" dirty="0">
-                <a:effectLst/>
-                <a:latin typeface="Calibri" panose="020F0502020204030204" pitchFamily="34" charset="0"/>
-                <a:ea typeface="Calibri" panose="020F0502020204030204" pitchFamily="34" charset="0"/>
-              </a:rPr>
-              <a:t>Diapositivas</a:t>
-            </a:r>
-            <a:r>
-              <a:rPr lang="es-ES" sz="1800" spc="-50" dirty="0">
-                <a:effectLst/>
-                <a:latin typeface="Calibri" panose="020F0502020204030204" pitchFamily="34" charset="0"/>
-                <a:ea typeface="Calibri" panose="020F0502020204030204" pitchFamily="34" charset="0"/>
-              </a:rPr>
-              <a:t> </a:t>
-            </a:r>
-            <a:r>
-              <a:rPr lang="es-ES" sz="1800" dirty="0">
-                <a:effectLst/>
-                <a:latin typeface="Calibri" panose="020F0502020204030204" pitchFamily="34" charset="0"/>
-                <a:ea typeface="Calibri" panose="020F0502020204030204" pitchFamily="34" charset="0"/>
-              </a:rPr>
-              <a:t>8,</a:t>
-            </a:r>
-            <a:r>
-              <a:rPr lang="es-ES" sz="1800" spc="-40" dirty="0">
-                <a:effectLst/>
-                <a:latin typeface="Calibri" panose="020F0502020204030204" pitchFamily="34" charset="0"/>
-                <a:ea typeface="Calibri" panose="020F0502020204030204" pitchFamily="34" charset="0"/>
-              </a:rPr>
-              <a:t> </a:t>
-            </a:r>
-            <a:r>
-              <a:rPr lang="es-ES" sz="1800" dirty="0">
-                <a:effectLst/>
-                <a:latin typeface="Calibri" panose="020F0502020204030204" pitchFamily="34" charset="0"/>
-                <a:ea typeface="Calibri" panose="020F0502020204030204" pitchFamily="34" charset="0"/>
-              </a:rPr>
-              <a:t>9</a:t>
-            </a:r>
-            <a:r>
-              <a:rPr lang="es-ES" sz="1800" spc="-45" dirty="0">
-                <a:effectLst/>
-                <a:latin typeface="Calibri" panose="020F0502020204030204" pitchFamily="34" charset="0"/>
-                <a:ea typeface="Calibri" panose="020F0502020204030204" pitchFamily="34" charset="0"/>
-              </a:rPr>
-              <a:t> </a:t>
-            </a:r>
-            <a:r>
-              <a:rPr lang="es-ES" sz="1800" dirty="0">
-                <a:effectLst/>
-                <a:latin typeface="Calibri" panose="020F0502020204030204" pitchFamily="34" charset="0"/>
-                <a:ea typeface="Calibri" panose="020F0502020204030204" pitchFamily="34" charset="0"/>
-              </a:rPr>
-              <a:t>y</a:t>
-            </a:r>
-            <a:r>
-              <a:rPr lang="es-ES" sz="1800" spc="-35" dirty="0">
-                <a:effectLst/>
-                <a:latin typeface="Calibri" panose="020F0502020204030204" pitchFamily="34" charset="0"/>
-                <a:ea typeface="Calibri" panose="020F0502020204030204" pitchFamily="34" charset="0"/>
-              </a:rPr>
-              <a:t> </a:t>
-            </a:r>
-            <a:r>
-              <a:rPr lang="es-ES" sz="1800" dirty="0">
-                <a:effectLst/>
-                <a:latin typeface="Calibri" panose="020F0502020204030204" pitchFamily="34" charset="0"/>
-                <a:ea typeface="Calibri" panose="020F0502020204030204" pitchFamily="34" charset="0"/>
-              </a:rPr>
-              <a:t>10:</a:t>
-            </a:r>
-            <a:r>
-              <a:rPr lang="es-ES" sz="1800" spc="-45" dirty="0">
-                <a:effectLst/>
-                <a:latin typeface="Calibri" panose="020F0502020204030204" pitchFamily="34" charset="0"/>
-                <a:ea typeface="Calibri" panose="020F0502020204030204" pitchFamily="34" charset="0"/>
-              </a:rPr>
-              <a:t> </a:t>
-            </a:r>
-            <a:r>
-              <a:rPr lang="es-ES" sz="1800" dirty="0">
-                <a:effectLst/>
-                <a:latin typeface="Calibri" panose="020F0502020204030204" pitchFamily="34" charset="0"/>
-                <a:ea typeface="Calibri" panose="020F0502020204030204" pitchFamily="34" charset="0"/>
-              </a:rPr>
-              <a:t>Resumen</a:t>
-            </a:r>
-            <a:r>
-              <a:rPr lang="es-ES" sz="1800" spc="-35" dirty="0">
-                <a:effectLst/>
-                <a:latin typeface="Calibri" panose="020F0502020204030204" pitchFamily="34" charset="0"/>
-                <a:ea typeface="Calibri" panose="020F0502020204030204" pitchFamily="34" charset="0"/>
-              </a:rPr>
-              <a:t> </a:t>
-            </a:r>
-            <a:r>
-              <a:rPr lang="es-ES" sz="1800" dirty="0">
-                <a:effectLst/>
-                <a:latin typeface="Calibri" panose="020F0502020204030204" pitchFamily="34" charset="0"/>
-                <a:ea typeface="Calibri" panose="020F0502020204030204" pitchFamily="34" charset="0"/>
-              </a:rPr>
-              <a:t>información</a:t>
-            </a:r>
-            <a:r>
-              <a:rPr lang="es-ES" sz="1800" spc="-40" dirty="0">
-                <a:effectLst/>
-                <a:latin typeface="Calibri" panose="020F0502020204030204" pitchFamily="34" charset="0"/>
-                <a:ea typeface="Calibri" panose="020F0502020204030204" pitchFamily="34" charset="0"/>
-              </a:rPr>
-              <a:t> </a:t>
-            </a:r>
-            <a:r>
-              <a:rPr lang="es-ES" sz="1800" dirty="0">
-                <a:effectLst/>
-                <a:latin typeface="Calibri" panose="020F0502020204030204" pitchFamily="34" charset="0"/>
-                <a:ea typeface="Calibri" panose="020F0502020204030204" pitchFamily="34" charset="0"/>
-              </a:rPr>
-              <a:t>de</a:t>
-            </a:r>
-            <a:r>
-              <a:rPr lang="es-ES" sz="1800" spc="-55" dirty="0">
-                <a:effectLst/>
-                <a:latin typeface="Calibri" panose="020F0502020204030204" pitchFamily="34" charset="0"/>
-                <a:ea typeface="Calibri" panose="020F0502020204030204" pitchFamily="34" charset="0"/>
-              </a:rPr>
-              <a:t> </a:t>
-            </a:r>
-            <a:r>
-              <a:rPr lang="es-ES" sz="1800" dirty="0">
-                <a:effectLst/>
-                <a:latin typeface="Calibri" panose="020F0502020204030204" pitchFamily="34" charset="0"/>
-                <a:ea typeface="Calibri" panose="020F0502020204030204" pitchFamily="34" charset="0"/>
-              </a:rPr>
-              <a:t>diversas</a:t>
-            </a:r>
-            <a:r>
-              <a:rPr lang="es-ES" sz="1800" spc="-35" dirty="0">
-                <a:effectLst/>
-                <a:latin typeface="Calibri" panose="020F0502020204030204" pitchFamily="34" charset="0"/>
-                <a:ea typeface="Calibri" panose="020F0502020204030204" pitchFamily="34" charset="0"/>
-              </a:rPr>
-              <a:t> </a:t>
-            </a:r>
-            <a:r>
-              <a:rPr lang="es-ES" sz="1800" dirty="0">
-                <a:effectLst/>
-                <a:latin typeface="Calibri" panose="020F0502020204030204" pitchFamily="34" charset="0"/>
-                <a:ea typeface="Calibri" panose="020F0502020204030204" pitchFamily="34" charset="0"/>
-              </a:rPr>
-              <a:t>fuentes</a:t>
-            </a:r>
-            <a:r>
-              <a:rPr lang="es-ES" sz="1800" spc="-40" dirty="0">
-                <a:effectLst/>
-                <a:latin typeface="Calibri" panose="020F0502020204030204" pitchFamily="34" charset="0"/>
-                <a:ea typeface="Calibri" panose="020F0502020204030204" pitchFamily="34" charset="0"/>
-              </a:rPr>
-              <a:t> </a:t>
-            </a:r>
-            <a:r>
-              <a:rPr lang="es-ES" sz="1800" dirty="0">
-                <a:effectLst/>
-                <a:latin typeface="Calibri" panose="020F0502020204030204" pitchFamily="34" charset="0"/>
-                <a:ea typeface="Calibri" panose="020F0502020204030204" pitchFamily="34" charset="0"/>
-              </a:rPr>
-              <a:t>que</a:t>
-            </a:r>
-            <a:r>
-              <a:rPr lang="es-ES" sz="1800" spc="-40" dirty="0">
-                <a:effectLst/>
-                <a:latin typeface="Calibri" panose="020F0502020204030204" pitchFamily="34" charset="0"/>
-                <a:ea typeface="Calibri" panose="020F0502020204030204" pitchFamily="34" charset="0"/>
-              </a:rPr>
-              <a:t> </a:t>
-            </a:r>
-            <a:r>
-              <a:rPr lang="es-ES" sz="1800" dirty="0">
-                <a:effectLst/>
-                <a:latin typeface="Calibri" panose="020F0502020204030204" pitchFamily="34" charset="0"/>
-                <a:ea typeface="Calibri" panose="020F0502020204030204" pitchFamily="34" charset="0"/>
-              </a:rPr>
-              <a:t>permiten</a:t>
-            </a:r>
-            <a:r>
-              <a:rPr lang="es-ES" sz="1800" spc="-40" dirty="0">
-                <a:effectLst/>
-                <a:latin typeface="Calibri" panose="020F0502020204030204" pitchFamily="34" charset="0"/>
-                <a:ea typeface="Calibri" panose="020F0502020204030204" pitchFamily="34" charset="0"/>
-              </a:rPr>
-              <a:t> </a:t>
-            </a:r>
-            <a:r>
-              <a:rPr lang="es-ES" sz="1800" dirty="0">
-                <a:effectLst/>
-                <a:latin typeface="Calibri" panose="020F0502020204030204" pitchFamily="34" charset="0"/>
-                <a:ea typeface="Calibri" panose="020F0502020204030204" pitchFamily="34" charset="0"/>
-              </a:rPr>
-              <a:t>responder</a:t>
-            </a:r>
-            <a:r>
-              <a:rPr lang="es-ES" sz="1800" spc="-40" dirty="0">
-                <a:effectLst/>
-                <a:latin typeface="Calibri" panose="020F0502020204030204" pitchFamily="34" charset="0"/>
-                <a:ea typeface="Calibri" panose="020F0502020204030204" pitchFamily="34" charset="0"/>
-              </a:rPr>
-              <a:t> </a:t>
-            </a:r>
-            <a:r>
-              <a:rPr lang="es-ES" sz="1800" dirty="0">
-                <a:effectLst/>
-                <a:latin typeface="Calibri" panose="020F0502020204030204" pitchFamily="34" charset="0"/>
-                <a:ea typeface="Calibri" panose="020F0502020204030204" pitchFamily="34" charset="0"/>
-              </a:rPr>
-              <a:t>las</a:t>
-            </a:r>
-            <a:r>
-              <a:rPr lang="es-ES" sz="1800" spc="-260" dirty="0">
-                <a:effectLst/>
-                <a:latin typeface="Calibri" panose="020F0502020204030204" pitchFamily="34" charset="0"/>
-                <a:ea typeface="Calibri" panose="020F0502020204030204" pitchFamily="34" charset="0"/>
-              </a:rPr>
-              <a:t> </a:t>
-            </a:r>
-            <a:r>
-              <a:rPr lang="es-ES" sz="1800" dirty="0">
-                <a:effectLst/>
-                <a:latin typeface="Calibri" panose="020F0502020204030204" pitchFamily="34" charset="0"/>
-                <a:ea typeface="Calibri" panose="020F0502020204030204" pitchFamily="34" charset="0"/>
-              </a:rPr>
-              <a:t>preguntas, integrando los conceptos matemáticos involucrados de la cuarta unidad u otras</a:t>
-            </a:r>
-            <a:r>
-              <a:rPr lang="es-ES" sz="1800" spc="5" dirty="0">
-                <a:effectLst/>
-                <a:latin typeface="Calibri" panose="020F0502020204030204" pitchFamily="34" charset="0"/>
-                <a:ea typeface="Calibri" panose="020F0502020204030204" pitchFamily="34" charset="0"/>
-              </a:rPr>
-              <a:t> </a:t>
-            </a:r>
-            <a:r>
-              <a:rPr lang="es-ES" sz="1800" dirty="0">
-                <a:effectLst/>
-                <a:latin typeface="Calibri" panose="020F0502020204030204" pitchFamily="34" charset="0"/>
-                <a:ea typeface="Calibri" panose="020F0502020204030204" pitchFamily="34" charset="0"/>
-              </a:rPr>
-              <a:t>nociones.</a:t>
+              <a:rPr sz="2600" b="1">
+                <a:solidFill>
+                  <a:srgbClr val="222222"/>
+                </a:solidFill>
+                <a:latin typeface="Calibri"/>
+              </a:rPr>
+              <a:t>Marco teórico III: Cloud computing y costos</a:t>
             </a:r>
             <a:endParaRPr lang="es-CL" sz="1800" dirty="0">
               <a:effectLst/>
@@ -3708,7 +3542,37 @@
             </a:endParaRPr>
           </a:p>
           <a:p>
-            <a:endParaRPr lang="es-CL" dirty="0"/>
+            <a:r>
+              <a:rPr sz="1800" b="0">
+                <a:solidFill>
+                  <a:srgbClr val="222222"/>
+                </a:solidFill>
+                <a:latin typeface="Calibri"/>
+              </a:rPr>
+              <a:t>•  Los proveedores cloud (AWS, Azure, Vercel) cobran según los recursos utilizados (instancias, cómputo, almacenamiento).</a:t>
+            </a:r>
+          </a:p>
+          <a:p>
+            <a:r>
+              <a:rPr sz="1800" b="0">
+                <a:solidFill>
+                  <a:srgbClr val="222222"/>
+                </a:solidFill>
+                <a:latin typeface="Calibri"/>
+              </a:rPr>
+              <a:t>•  Un mal dimensionamiento de recursos es un problema real de la industria: sobrecostos o baja disponibilidad del servicio.</a:t>
+            </a:r>
+          </a:p>
+          <a:p>
+            <a:r>
+              <a:rPr sz="1800" b="0">
+                <a:solidFill>
+                  <a:srgbClr val="222222"/>
+                </a:solidFill>
+                <a:latin typeface="Calibri"/>
+              </a:rPr>
+              <a:t>•  Fuentes: documentación de precios de AWS y Azure, y buenas prácticas de "cost optimization" en la nube.</a:t>
+            </a:r>
           </a:p>
         </p:txBody>
       </p:sp>
@@ -3756,8 +3620,8 @@
         </p:nvSpPr>
         <p:spPr>
           <a:xfrm>
-            <a:off x="1258957" y="1431235"/>
-            <a:ext cx="5327484" cy="369332"/>
+            <a:off x="838200" y="365125"/>
+            <a:ext cx="10515600" cy="6192875"/>
           </a:xfrm>
           <a:prstGeom prst="rect">
             <a:avLst/>
@@ -3765,97 +3629,65 @@
           <a:noFill/>
         </p:spPr>
         <p:txBody>
-          <a:bodyPr wrap="none" rtlCol="0">
-            <a:spAutoFit/>
+          <a:bodyPr wrap="square" rtlCol="0">
+            <a:noAutofit/>
           </a:bodyPr>
           <a:lstStyle/>
           <a:p>
             <a:r>
-              <a:rPr lang="es-CL" dirty="0"/>
-              <a:t>Diapositiva 11: </a:t>
-            </a:r>
-            <a:r>
-              <a:rPr lang="es-CL" sz="1800" dirty="0">
-                <a:effectLst/>
-                <a:latin typeface="Calibri" panose="020F0502020204030204" pitchFamily="34" charset="0"/>
-                <a:ea typeface="Calibri" panose="020F0502020204030204" pitchFamily="34" charset="0"/>
-                <a:cs typeface="Times New Roman" panose="02020603050405020304" pitchFamily="18" charset="0"/>
-              </a:rPr>
-              <a:t>Desarrollo, revisión</a:t>
-            </a:r>
-            <a:r>
-              <a:rPr lang="es-CL" sz="1800" spc="5" dirty="0">
-                <a:effectLst/>
-                <a:latin typeface="Calibri" panose="020F0502020204030204" pitchFamily="34" charset="0"/>
-                <a:ea typeface="Calibri" panose="020F0502020204030204" pitchFamily="34" charset="0"/>
-                <a:cs typeface="Times New Roman" panose="02020603050405020304" pitchFamily="18" charset="0"/>
-              </a:rPr>
-              <a:t> </a:t>
-            </a:r>
-            <a:r>
-              <a:rPr lang="es-CL" sz="1800" dirty="0">
-                <a:effectLst/>
-                <a:latin typeface="Calibri" panose="020F0502020204030204" pitchFamily="34" charset="0"/>
-                <a:ea typeface="Calibri" panose="020F0502020204030204" pitchFamily="34" charset="0"/>
-                <a:cs typeface="Times New Roman" panose="02020603050405020304" pitchFamily="18" charset="0"/>
-              </a:rPr>
-              <a:t>de</a:t>
-            </a:r>
-            <a:r>
-              <a:rPr lang="es-CL" sz="1800" spc="5" dirty="0">
-                <a:effectLst/>
-                <a:latin typeface="Calibri" panose="020F0502020204030204" pitchFamily="34" charset="0"/>
-                <a:ea typeface="Calibri" panose="020F0502020204030204" pitchFamily="34" charset="0"/>
-                <a:cs typeface="Times New Roman" panose="02020603050405020304" pitchFamily="18" charset="0"/>
-              </a:rPr>
-              <a:t> </a:t>
-            </a:r>
-            <a:r>
-              <a:rPr lang="es-CL" sz="1800" dirty="0">
-                <a:effectLst/>
-                <a:latin typeface="Calibri" panose="020F0502020204030204" pitchFamily="34" charset="0"/>
-                <a:ea typeface="Calibri" panose="020F0502020204030204" pitchFamily="34" charset="0"/>
-                <a:cs typeface="Times New Roman" panose="02020603050405020304" pitchFamily="18" charset="0"/>
-              </a:rPr>
-              <a:t>ideas</a:t>
-            </a:r>
-            <a:r>
-              <a:rPr lang="es-CL" sz="1800" spc="-5" dirty="0">
-                <a:effectLst/>
-                <a:latin typeface="Calibri" panose="020F0502020204030204" pitchFamily="34" charset="0"/>
-                <a:ea typeface="Calibri" panose="020F0502020204030204" pitchFamily="34" charset="0"/>
-                <a:cs typeface="Times New Roman" panose="02020603050405020304" pitchFamily="18" charset="0"/>
-              </a:rPr>
-              <a:t> </a:t>
-            </a:r>
-            <a:r>
-              <a:rPr lang="es-CL" sz="1800" dirty="0">
-                <a:effectLst/>
-                <a:latin typeface="Calibri" panose="020F0502020204030204" pitchFamily="34" charset="0"/>
-                <a:ea typeface="Calibri" panose="020F0502020204030204" pitchFamily="34" charset="0"/>
-                <a:cs typeface="Times New Roman" panose="02020603050405020304" pitchFamily="18" charset="0"/>
-              </a:rPr>
-              <a:t>y</a:t>
-            </a:r>
-            <a:r>
-              <a:rPr lang="es-CL" sz="1800" spc="-10" dirty="0">
-                <a:effectLst/>
-                <a:latin typeface="Calibri" panose="020F0502020204030204" pitchFamily="34" charset="0"/>
-                <a:ea typeface="Calibri" panose="020F0502020204030204" pitchFamily="34" charset="0"/>
-                <a:cs typeface="Times New Roman" panose="02020603050405020304" pitchFamily="18" charset="0"/>
-              </a:rPr>
-              <a:t> </a:t>
-            </a:r>
-            <a:r>
-              <a:rPr lang="es-CL" sz="1800" dirty="0">
-                <a:effectLst/>
-                <a:latin typeface="Calibri" panose="020F0502020204030204" pitchFamily="34" charset="0"/>
-                <a:ea typeface="Calibri" panose="020F0502020204030204" pitchFamily="34" charset="0"/>
-                <a:cs typeface="Times New Roman" panose="02020603050405020304" pitchFamily="18" charset="0"/>
-              </a:rPr>
-              <a:t>producto</a:t>
+              <a:rPr sz="2600" b="1">
+                <a:solidFill>
+                  <a:srgbClr val="222222"/>
+                </a:solidFill>
+                <a:latin typeface="Calibri"/>
+              </a:rPr>
+              <a:t>Desarrollo, revisión de ideas y producto</a:t>
             </a:r>
             <a:endParaRPr lang="es-CL" dirty="0"/>
+          </a:p>
+          <a:p>
+            <a:r>
+              <a:rPr sz="1800" b="0">
+                <a:solidFill>
+                  <a:srgbClr val="222222"/>
+                </a:solidFill>
+                <a:latin typeface="Calibri"/>
+              </a:rPr>
+              <a:t>•  Se evaluaron distintos modelos de costo (lineal y cuadrático), optando por un modelo cuadrático simplificado que resume infraestructura + operación.</a:t>
+            </a:r>
+          </a:p>
+          <a:p>
+            <a:r>
+              <a:rPr sz="1800" b="0">
+                <a:solidFill>
+                  <a:srgbClr val="222222"/>
+                </a:solidFill>
+                <a:latin typeface="Calibri"/>
+              </a:rPr>
+              <a:t>•  Se derivó el modelo, se resolvió C'(x) = 0 y se verificó el mínimo con la segunda derivada.</a:t>
+            </a:r>
+          </a:p>
+          <a:p>
+            <a:r>
+              <a:rPr sz="1800" b="0">
+                <a:solidFill>
+                  <a:srgbClr val="222222"/>
+                </a:solidFill>
+                <a:latin typeface="Calibri"/>
+              </a:rPr>
+              <a:t>•  Se decidió comunicar el resultado mediante un producto tecnológico -un sitio web con simulador interactivo- en vez de solo un informe estático.</a:t>
+            </a:r>
+          </a:p>
+          <a:p>
+            <a:r>
+              <a:rPr sz="1800" b="0">
+                <a:solidFill>
+                  <a:srgbClr val="222222"/>
+                </a:solidFill>
+                <a:latin typeface="Calibri"/>
+              </a:rPr>
+              <a:t>•  El simulador permite ingresar distintos parámetros (a, b+c, d) y observar cómo cambia el punto óptimo.</a:t>
+            </a:r>
           </a:p>
         </p:txBody>
       </p:sp>
@@ -3912,27 +3744,20 @@
           <a:noFill/>
         </p:spPr>
         <p:txBody>
-          <a:bodyPr wrap="none" rtlCol="0">
-            <a:spAutoFit/>
+          <a:bodyPr wrap="square" rtlCol="0">
+            <a:noAutofit/>
           </a:bodyPr>
           <a:lstStyle/>
           <a:p>
             <a:pPr marR="31115"/>
             <a:r>
-              <a:rPr lang="es-ES" sz="1800" dirty="0">
-                <a:effectLst/>
-                <a:latin typeface="Calibri" panose="020F0502020204030204" pitchFamily="34" charset="0"/>
-                <a:ea typeface="Calibri" panose="020F0502020204030204" pitchFamily="34" charset="0"/>
-              </a:rPr>
-              <a:t>Diapositiva 12: Presentación de producto o prototipo</a:t>
-            </a:r>
-            <a:r>
-              <a:rPr lang="es-ES" sz="1800" spc="-260" dirty="0">
-                <a:effectLst/>
-                <a:latin typeface="Calibri" panose="020F0502020204030204" pitchFamily="34" charset="0"/>
-                <a:ea typeface="Calibri" panose="020F0502020204030204" pitchFamily="34" charset="0"/>
-              </a:rPr>
-              <a:t> </a:t>
+              <a:rPr sz="2400" b="1">
+                <a:solidFill>
+                  <a:srgbClr val="222222"/>
+                </a:solidFill>
+                <a:latin typeface="Calibri"/>
+              </a:rPr>
+              <a:t>Presentación de producto o prototipo</a:t>
             </a:r>
             <a:endParaRPr lang="es-CL" sz="1800" dirty="0">
               <a:effectLst/>
@@ -3980,6 +3805,63 @@
                 <a:hlinkClick r:id="rId2"/>
               </a:rPr>
               <a:t>https://proyecto-calculo-optimizacion-cloud.vercel.app</a:t>
+            </a:r>
+          </a:p>
+        </p:txBody>
+      </p:sp>
+      <p:sp>
+        <p:nvSpPr>
+          <p:cNvPr id="6" name="TextBox 5"/>
+          <p:cNvSpPr txBox="1"/>
+          <p:nvPr/>
+        </p:nvSpPr>
+        <p:spPr>
+          <a:xfrm>
+            <a:off x="1258957" y="2550567"/>
+            <a:ext cx="9500000" cy="2500000"/>
+          </a:xfrm>
+          <a:prstGeom prst="rect">
+            <a:avLst/>
+          </a:prstGeom>
+          <a:noFill/>
+        </p:spPr>
+        <p:txBody>
+          <a:bodyPr wrap="square">
+            <a:spAutoFit/>
+          </a:bodyPr>
+          <a:lstStyle/>
+          <a:p/>
+          <a:p>
+            <a:r>
+              <a:rPr sz="1800" b="0">
+                <a:solidFill>
+                  <a:srgbClr val="222222"/>
+                </a:solidFill>
+                <a:latin typeface="Calibri"/>
+              </a:rPr>
+              <a:t>•  Producto: sitio web (HTML, CSS, JavaScript) con un simulador interactivo construido con Plotly.js.</a:t>
+            </a:r>
+          </a:p>
+          <a:p>
+            <a:r>
+              <a:rPr sz="1800" b="0">
+                <a:solidFill>
+                  <a:srgbClr val="222222"/>
+                </a:solidFill>
+                <a:latin typeface="Calibri"/>
+              </a:rPr>
+              <a:t>•  Grafica en tiempo real la función de costo C(x) y su derivada C'(x), marcando el punto donde C'(x) = 0.</a:t>
+            </a:r>
+          </a:p>
+          <a:p>
+            <a:r>
+              <a:rPr sz="1800" b="0">
+                <a:solidFill>
+                  <a:srgbClr val="222222"/>
+                </a:solidFill>
+                <a:latin typeface="Calibri"/>
+              </a:rPr>
+              <a:t>•  Publicado en la nube mediante Vercel, con despliegue continuo desde GitHub.</a:t>
             </a:r>
           </a:p>
         </p:txBody>
@@ -4028,8 +3910,8 @@
         </p:nvSpPr>
         <p:spPr>
           <a:xfrm>
-            <a:off x="1258957" y="1431235"/>
-            <a:ext cx="4084131" cy="369332"/>
+            <a:off x="838200" y="365125"/>
+            <a:ext cx="10515600" cy="6192875"/>
           </a:xfrm>
           <a:prstGeom prst="rect">
             <a:avLst/>
@@ -4037,73 +3919,108 @@
           <a:noFill/>
         </p:spPr>
         <p:txBody>
-          <a:bodyPr wrap="none" rtlCol="0">
-            <a:spAutoFit/>
+          <a:bodyPr wrap="square" rtlCol="0">
+            <a:noAutofit/>
           </a:bodyPr>
           <a:lstStyle/>
           <a:p>
             <a:pPr marR="31115"/>
             <a:r>
-              <a:rPr lang="es-ES" sz="1800" dirty="0">
-                <a:effectLst/>
-                <a:latin typeface="Calibri" panose="020F0502020204030204" pitchFamily="34" charset="0"/>
-                <a:ea typeface="Calibri" panose="020F0502020204030204" pitchFamily="34" charset="0"/>
-              </a:rPr>
-              <a:t>Diapositiva</a:t>
-            </a:r>
-            <a:r>
-              <a:rPr lang="es-ES" sz="1800" spc="-5" dirty="0">
-                <a:effectLst/>
-                <a:latin typeface="Calibri" panose="020F0502020204030204" pitchFamily="34" charset="0"/>
-                <a:ea typeface="Calibri" panose="020F0502020204030204" pitchFamily="34" charset="0"/>
-              </a:rPr>
-              <a:t> </a:t>
-            </a:r>
-            <a:r>
-              <a:rPr lang="es-ES" sz="1800" dirty="0">
-                <a:effectLst/>
-                <a:latin typeface="Calibri" panose="020F0502020204030204" pitchFamily="34" charset="0"/>
-                <a:ea typeface="Calibri" panose="020F0502020204030204" pitchFamily="34" charset="0"/>
-              </a:rPr>
-              <a:t>13: Resultados</a:t>
-            </a:r>
-            <a:r>
-              <a:rPr lang="es-ES" sz="1800" spc="5" dirty="0">
-                <a:effectLst/>
-                <a:latin typeface="Calibri" panose="020F0502020204030204" pitchFamily="34" charset="0"/>
-                <a:ea typeface="Calibri" panose="020F0502020204030204" pitchFamily="34" charset="0"/>
-              </a:rPr>
-              <a:t> </a:t>
-            </a:r>
-            <a:r>
-              <a:rPr lang="es-ES" sz="1800" dirty="0">
-                <a:effectLst/>
-                <a:latin typeface="Calibri" panose="020F0502020204030204" pitchFamily="34" charset="0"/>
-                <a:ea typeface="Calibri" panose="020F0502020204030204" pitchFamily="34" charset="0"/>
-              </a:rPr>
-              <a:t>y</a:t>
-            </a:r>
-            <a:r>
-              <a:rPr lang="es-ES" sz="1800" spc="-5" dirty="0">
-                <a:effectLst/>
-                <a:latin typeface="Calibri" panose="020F0502020204030204" pitchFamily="34" charset="0"/>
-                <a:ea typeface="Calibri" panose="020F0502020204030204" pitchFamily="34" charset="0"/>
-              </a:rPr>
-              <a:t> </a:t>
-            </a:r>
-            <a:r>
-              <a:rPr lang="es-ES" sz="1800" dirty="0">
-                <a:effectLst/>
-                <a:latin typeface="Calibri" panose="020F0502020204030204" pitchFamily="34" charset="0"/>
-                <a:ea typeface="Calibri" panose="020F0502020204030204" pitchFamily="34" charset="0"/>
-              </a:rPr>
-              <a:t>conclusiones</a:t>
+              <a:rPr sz="2600" b="1">
+                <a:solidFill>
+                  <a:srgbClr val="222222"/>
+                </a:solidFill>
+                <a:latin typeface="Calibri"/>
+              </a:rPr>
+              <a:t>Resultados y conclusiones</a:t>
             </a:r>
             <a:endParaRPr lang="es-CL" sz="1800" dirty="0">
               <a:effectLst/>
               <a:latin typeface="Calibri" panose="020F0502020204030204" pitchFamily="34" charset="0"/>
               <a:ea typeface="Calibri" panose="020F0502020204030204" pitchFamily="34" charset="0"/>
             </a:endParaRPr>
+          </a:p>
+          <a:p>
+            <a:r>
+              <a:rPr sz="1800" b="1">
+                <a:solidFill>
+                  <a:srgbClr val="222222"/>
+                </a:solidFill>
+                <a:latin typeface="Calibri"/>
+              </a:rPr>
+              <a:t>Resultados:</a:t>
+            </a:r>
+          </a:p>
+          <a:p>
+            <a:r>
+              <a:rPr sz="1800" b="0">
+                <a:solidFill>
+                  <a:srgbClr val="222222"/>
+                </a:solidFill>
+                <a:latin typeface="Calibri"/>
+              </a:rPr>
+              <a:t>•  Modelo: C(x) = 0.5x² − 20x + 500  ;  C'(x) = x − 20</a:t>
+            </a:r>
+          </a:p>
+          <a:p>
+            <a:r>
+              <a:rPr sz="1800" b="0">
+                <a:solidFill>
+                  <a:srgbClr val="222222"/>
+                </a:solidFill>
+                <a:latin typeface="Calibri"/>
+              </a:rPr>
+              <a:t>•  Punto crítico: x = 20  ;  C''(x) = 1 &gt; 0 → mínimo</a:t>
+            </a:r>
+          </a:p>
+          <a:p>
+            <a:r>
+              <a:rPr sz="1800" b="0">
+                <a:solidFill>
+                  <a:srgbClr val="222222"/>
+                </a:solidFill>
+                <a:latin typeface="Calibri"/>
+              </a:rPr>
+              <a:t>•  Costo mínimo: C(20) = 300 USD/mes</a:t>
+            </a:r>
+          </a:p>
+          <a:p>
+            <a:r>
+              <a:rPr sz="1800" b="0">
+                <a:solidFill>
+                  <a:srgbClr val="222222"/>
+                </a:solidFill>
+                <a:latin typeface="Calibri"/>
+              </a:rPr>
+              <a:t>•  Comparación: 5 instancias → 412,5 USD ; 20 instancias (óptimo) → 300 USD ; 35 instancias → 412,5 USD (ahorro ≈ 27%)</a:t>
+            </a:r>
+          </a:p>
+          <a:p>
+            <a:pPr>
+              <a:spcBef>
+                <a:spcPts val="1000"/>
+              </a:spcBef>
+            </a:pPr>
+            <a:r>
+              <a:rPr sz="1800" b="1">
+                <a:solidFill>
+                  <a:srgbClr val="222222"/>
+                </a:solidFill>
+                <a:latin typeface="Calibri"/>
+              </a:rPr>
+              <a:t>Conclusión:</a:t>
+            </a:r>
+          </a:p>
+          <a:p>
+            <a:r>
+              <a:rPr sz="1800" b="0">
+                <a:solidFill>
+                  <a:srgbClr val="222222"/>
+                </a:solidFill>
+                <a:latin typeface="Calibri"/>
+              </a:rPr>
+              <a:t>•  La derivada permite tomar decisiones de arquitectura de software basadas en evidencia matemática, y no en estimaciones arbitrarias.</a:t>
+            </a:r>
           </a:p>
         </p:txBody>
       </p:sp>
@@ -4151,8 +4068,8 @@
         </p:nvSpPr>
         <p:spPr>
           <a:xfrm>
-            <a:off x="1258957" y="1431235"/>
-            <a:ext cx="5089407" cy="297517"/>
+            <a:off x="838200" y="365125"/>
+            <a:ext cx="10515600" cy="6192875"/>
           </a:xfrm>
           <a:prstGeom prst="rect">
             <a:avLst/>
@@ -4160,8 +4077,8 @@
           <a:noFill/>
         </p:spPr>
         <p:txBody>
-          <a:bodyPr wrap="none" rtlCol="0">
-            <a:spAutoFit/>
+          <a:bodyPr wrap="square" rtlCol="0">
+            <a:noAutofit/>
           </a:bodyPr>
           <a:lstStyle/>
           <a:p>
@@ -4171,114 +4088,85 @@
               </a:lnSpc>
             </a:pPr>
             <a:r>
-              <a:rPr lang="es-ES" sz="1800" dirty="0">
-                <a:effectLst/>
-                <a:latin typeface="Calibri" panose="020F0502020204030204" pitchFamily="34" charset="0"/>
-                <a:ea typeface="Calibri" panose="020F0502020204030204" pitchFamily="34" charset="0"/>
-              </a:rPr>
-              <a:t>Diapositiva</a:t>
-            </a:r>
-            <a:r>
-              <a:rPr lang="es-ES" sz="1800" spc="-15" dirty="0">
-                <a:effectLst/>
-                <a:latin typeface="Calibri" panose="020F0502020204030204" pitchFamily="34" charset="0"/>
-                <a:ea typeface="Calibri" panose="020F0502020204030204" pitchFamily="34" charset="0"/>
-              </a:rPr>
-              <a:t> </a:t>
-            </a:r>
-            <a:r>
-              <a:rPr lang="es-ES" sz="1800" dirty="0">
-                <a:effectLst/>
-                <a:latin typeface="Calibri" panose="020F0502020204030204" pitchFamily="34" charset="0"/>
-                <a:ea typeface="Calibri" panose="020F0502020204030204" pitchFamily="34" charset="0"/>
-              </a:rPr>
-              <a:t>14:</a:t>
-            </a:r>
-            <a:r>
-              <a:rPr lang="es-ES" sz="1800" spc="-5" dirty="0">
-                <a:effectLst/>
-                <a:latin typeface="Calibri" panose="020F0502020204030204" pitchFamily="34" charset="0"/>
-                <a:ea typeface="Calibri" panose="020F0502020204030204" pitchFamily="34" charset="0"/>
-              </a:rPr>
-              <a:t> </a:t>
-            </a:r>
-            <a:r>
-              <a:rPr lang="es-ES" sz="1800" dirty="0">
-                <a:effectLst/>
-                <a:latin typeface="Calibri" panose="020F0502020204030204" pitchFamily="34" charset="0"/>
-                <a:ea typeface="Calibri" panose="020F0502020204030204" pitchFamily="34" charset="0"/>
-              </a:rPr>
-              <a:t>Bibliografía</a:t>
-            </a:r>
-            <a:r>
-              <a:rPr lang="es-ES" sz="1800" spc="-10" dirty="0">
-                <a:effectLst/>
-                <a:latin typeface="Calibri" panose="020F0502020204030204" pitchFamily="34" charset="0"/>
-                <a:ea typeface="Calibri" panose="020F0502020204030204" pitchFamily="34" charset="0"/>
-              </a:rPr>
-              <a:t> </a:t>
-            </a:r>
-            <a:r>
-              <a:rPr lang="es-ES" sz="1800" dirty="0">
-                <a:effectLst/>
-                <a:latin typeface="Calibri" panose="020F0502020204030204" pitchFamily="34" charset="0"/>
-                <a:ea typeface="Calibri" panose="020F0502020204030204" pitchFamily="34" charset="0"/>
-              </a:rPr>
-              <a:t>y</a:t>
-            </a:r>
-            <a:r>
-              <a:rPr lang="es-ES" sz="1800" spc="-10" dirty="0">
-                <a:effectLst/>
-                <a:latin typeface="Calibri" panose="020F0502020204030204" pitchFamily="34" charset="0"/>
-                <a:ea typeface="Calibri" panose="020F0502020204030204" pitchFamily="34" charset="0"/>
-              </a:rPr>
-              <a:t> </a:t>
-            </a:r>
-            <a:r>
-              <a:rPr lang="es-ES" sz="1800" dirty="0">
-                <a:effectLst/>
-                <a:latin typeface="Calibri" panose="020F0502020204030204" pitchFamily="34" charset="0"/>
-                <a:ea typeface="Calibri" panose="020F0502020204030204" pitchFamily="34" charset="0"/>
-              </a:rPr>
-              <a:t>fuentes</a:t>
-            </a:r>
-            <a:r>
-              <a:rPr lang="es-ES" sz="1800" spc="-15" dirty="0">
-                <a:effectLst/>
-                <a:latin typeface="Calibri" panose="020F0502020204030204" pitchFamily="34" charset="0"/>
-                <a:ea typeface="Calibri" panose="020F0502020204030204" pitchFamily="34" charset="0"/>
-              </a:rPr>
-              <a:t> </a:t>
-            </a:r>
-            <a:r>
-              <a:rPr lang="es-ES" sz="1800" dirty="0">
-                <a:effectLst/>
-                <a:latin typeface="Calibri" panose="020F0502020204030204" pitchFamily="34" charset="0"/>
-                <a:ea typeface="Calibri" panose="020F0502020204030204" pitchFamily="34" charset="0"/>
-              </a:rPr>
-              <a:t>de</a:t>
-            </a:r>
-            <a:r>
-              <a:rPr lang="es-ES" sz="1800" spc="-10" dirty="0">
-                <a:effectLst/>
-                <a:latin typeface="Calibri" panose="020F0502020204030204" pitchFamily="34" charset="0"/>
-                <a:ea typeface="Calibri" panose="020F0502020204030204" pitchFamily="34" charset="0"/>
-              </a:rPr>
-              <a:t> </a:t>
-            </a:r>
-            <a:r>
-              <a:rPr lang="es-ES" sz="1800" dirty="0">
-                <a:effectLst/>
-                <a:latin typeface="Calibri" panose="020F0502020204030204" pitchFamily="34" charset="0"/>
-                <a:ea typeface="Calibri" panose="020F0502020204030204" pitchFamily="34" charset="0"/>
-              </a:rPr>
-              <a:t>información</a:t>
+              <a:rPr sz="2600" b="1">
+                <a:solidFill>
+                  <a:srgbClr val="222222"/>
+                </a:solidFill>
+                <a:latin typeface="Calibri"/>
+              </a:rPr>
+              <a:t>Bibliografía y fuentes de información</a:t>
             </a:r>
             <a:endParaRPr lang="es-CL" sz="1800" dirty="0">
               <a:effectLst/>
               <a:latin typeface="Calibri" panose="020F0502020204030204" pitchFamily="34" charset="0"/>
               <a:ea typeface="Calibri" panose="020F0502020204030204" pitchFamily="34" charset="0"/>
             </a:endParaRPr>
+          </a:p>
+          <a:p>
+            <a:r>
+              <a:rPr sz="1600" b="0">
+                <a:solidFill>
+                  <a:srgbClr val="222222"/>
+                </a:solidFill>
+                <a:latin typeface="Calibri"/>
+              </a:rPr>
+              <a:t>•  Stewart, J. (2018). Cálculo de una variable: Trascendentes tempranas (8ª ed.). Cengage Learning.</a:t>
+            </a:r>
+          </a:p>
+          <a:p>
+            <a:r>
+              <a:rPr sz="1600" b="0">
+                <a:solidFill>
+                  <a:srgbClr val="222222"/>
+                </a:solidFill>
+                <a:latin typeface="Calibri"/>
+              </a:rPr>
+              <a:t>•  Larson, R., &amp; Edwards, B. (2018). Cálculo (10ª ed.). McGraw-Hill.</a:t>
+            </a:r>
+          </a:p>
+          <a:p>
+            <a:r>
+              <a:rPr sz="1600" b="0">
+                <a:solidFill>
+                  <a:srgbClr val="222222"/>
+                </a:solidFill>
+                <a:latin typeface="Calibri"/>
+              </a:rPr>
+              <a:t>•  Amazon Web Services. (2024). Cloud economics and pricing. https://aws.amazon.com/economics/</a:t>
+            </a:r>
+          </a:p>
+          <a:p>
+            <a:r>
+              <a:rPr sz="1600" b="0">
+                <a:solidFill>
+                  <a:srgbClr val="222222"/>
+                </a:solidFill>
+                <a:latin typeface="Calibri"/>
+              </a:rPr>
+              <a:t>•  Microsoft Azure. (2024). Pricing calculator y documentación de cost management. https://azure.microsoft.com/pricing/</a:t>
+            </a:r>
+          </a:p>
+          <a:p>
+            <a:r>
+              <a:rPr sz="1600" b="0">
+                <a:solidFill>
+                  <a:srgbClr val="222222"/>
+                </a:solidFill>
+                <a:latin typeface="Calibri"/>
+              </a:rPr>
+              <a:t>•  Vercel Inc. (2024). Vercel pricing documentation. https://vercel.com/pricing</a:t>
+            </a:r>
+          </a:p>
+          <a:p>
+            <a:r>
+              <a:rPr sz="1600" b="0">
+                <a:solidFill>
+                  <a:srgbClr val="222222"/>
+                </a:solidFill>
+                <a:latin typeface="Calibri"/>
+              </a:rPr>
+              <a:t>•  Sitio del proyecto: https://proyecto-calculo-optimizacion-cloud.vercel.app</a:t>
+            </a:r>
           </a:p>
         </p:txBody>
       </p:sp>
@@ -4328,31 +4216,72 @@
             <p:ph type="title"/>
           </p:nvPr>
         </p:nvSpPr>
-        <p:spPr/>
-        <p:txBody>
-          <a:bodyPr/>
+        <p:spPr>
+          <a:xfrm>
+            <a:off x="838200" y="365125"/>
+            <a:ext cx="10515600" cy="1325563"/>
+          </a:xfrm>
+        </p:spPr>
+        <p:txBody>
+          <a:bodyPr wrap="square">
+            <a:noAutofit/>
+          </a:bodyPr>
           <a:lstStyle/>
           <a:p>
             <a:r>
-              <a:rPr lang="es-ES" sz="1800" b="0" i="0" dirty="0">
-                <a:solidFill>
-                  <a:srgbClr val="000000"/>
-                </a:solidFill>
-                <a:effectLst/>
-                <a:latin typeface="Calibri" panose="020F0502020204030204" pitchFamily="34" charset="0"/>
-              </a:rPr>
-              <a:t>Diapositiva 2: </a:t>
-            </a:r>
-            <a:r>
-              <a:rPr lang="es-ES" sz="1800" dirty="0">
-                <a:solidFill>
-                  <a:srgbClr val="000000"/>
-                </a:solidFill>
-                <a:latin typeface="Calibri" panose="020F0502020204030204" pitchFamily="34" charset="0"/>
+              <a:rPr sz="2600" b="1">
+                <a:solidFill>
+                  <a:srgbClr val="222222"/>
+                </a:solidFill>
+                <a:latin typeface="Calibri"/>
               </a:rPr>
               <a:t>Definición del proyecto</a:t>
             </a:r>
             <a:endParaRPr lang="es-CL" dirty="0"/>
+          </a:p>
+          <a:p>
+            <a:r>
+              <a:rPr sz="1800" b="0">
+                <a:solidFill>
+                  <a:srgbClr val="222222"/>
+                </a:solidFill>
+                <a:latin typeface="Calibri"/>
+              </a:rPr>
+              <a:t>•  Proyecto de Aprendizaje Basado en Proyectos (ABPro) que aplica la derivada a un problema real de ingeniería de software.</a:t>
+            </a:r>
+          </a:p>
+          <a:p>
+            <a:r>
+              <a:rPr sz="1800" b="0">
+                <a:solidFill>
+                  <a:srgbClr val="222222"/>
+                </a:solidFill>
+                <a:latin typeface="Calibri"/>
+              </a:rPr>
+              <a:t>•  Consiste en modelar el costo mensual de alojamiento en la nube en función del número de instancias contratadas.</a:t>
+            </a:r>
+          </a:p>
+          <a:p>
+            <a:r>
+              <a:rPr sz="1800" b="0">
+                <a:solidFill>
+                  <a:srgbClr val="222222"/>
+                </a:solidFill>
+                <a:latin typeface="Calibri"/>
+              </a:rPr>
+              <a:t>•  Mediante la derivada de esa función se determina el punto exacto donde el costo es mínimo.</a:t>
+            </a:r>
+          </a:p>
+          <a:p>
+            <a:r>
+              <a:rPr sz="1800" b="0">
+                <a:solidFill>
+                  <a:srgbClr val="222222"/>
+                </a:solidFill>
+                <a:latin typeface="Calibri"/>
+              </a:rPr>
+              <a:t>•  El resultado se comunica a través de un sitio web con un simulador interactivo.</a:t>
+            </a:r>
           </a:p>
         </p:txBody>
       </p:sp>
@@ -4402,41 +4331,115 @@
             <p:ph type="title"/>
           </p:nvPr>
         </p:nvSpPr>
-        <p:spPr/>
-        <p:txBody>
-          <a:bodyPr/>
+        <p:spPr>
+          <a:xfrm>
+            <a:off x="838200" y="365125"/>
+            <a:ext cx="10515600" cy="1325563"/>
+          </a:xfrm>
+        </p:spPr>
+        <p:txBody>
+          <a:bodyPr wrap="square">
+            <a:noAutofit/>
+          </a:bodyPr>
           <a:lstStyle/>
           <a:p>
             <a:r>
-              <a:rPr lang="es-ES" sz="1800" b="0" i="0" dirty="0">
-                <a:solidFill>
-                  <a:srgbClr val="000000"/>
-                </a:solidFill>
-                <a:effectLst/>
-                <a:latin typeface="Calibri" panose="020F0502020204030204" pitchFamily="34" charset="0"/>
-              </a:rPr>
-              <a:t>Diapositiva 3: </a:t>
-            </a:r>
-            <a:r>
-              <a:rPr lang="es-ES" sz="1800" dirty="0">
-                <a:solidFill>
-                  <a:srgbClr val="000000"/>
-                </a:solidFill>
-                <a:latin typeface="Calibri" panose="020F0502020204030204" pitchFamily="34" charset="0"/>
-              </a:rPr>
-              <a:t>Tema de investigación, nociones matemáticas y problemática a abordar</a:t>
-            </a:r>
-            <a:r>
-              <a:rPr lang="es-ES" sz="1800" b="0" i="0" dirty="0">
-                <a:solidFill>
-                  <a:srgbClr val="000000"/>
-                </a:solidFill>
-                <a:effectLst/>
-                <a:latin typeface="Calibri" panose="020F0502020204030204" pitchFamily="34" charset="0"/>
-              </a:rPr>
-              <a:t> </a:t>
+              <a:rPr sz="2600" b="1">
+                <a:solidFill>
+                  <a:srgbClr val="222222"/>
+                </a:solidFill>
+                <a:latin typeface="Calibri"/>
+              </a:rPr>
+              <a:t>Tema, nociones matemáticas y problemática</a:t>
             </a:r>
             <a:endParaRPr lang="es-CL" dirty="0"/>
+          </a:p>
+          <a:p>
+            <a:r>
+              <a:rPr sz="1800" b="1">
+                <a:solidFill>
+                  <a:srgbClr val="222222"/>
+                </a:solidFill>
+                <a:latin typeface="Calibri"/>
+              </a:rPr>
+              <a:t>Tema:</a:t>
+            </a:r>
+          </a:p>
+          <a:p>
+            <a:r>
+              <a:rPr sz="1800" b="0">
+                <a:solidFill>
+                  <a:srgbClr val="222222"/>
+                </a:solidFill>
+                <a:latin typeface="Calibri"/>
+              </a:rPr>
+              <a:t>•  Optimización de costos de infraestructura cloud mediante cálculo diferencial.</a:t>
+            </a:r>
+          </a:p>
+          <a:p>
+            <a:pPr>
+              <a:spcBef>
+                <a:spcPts val="1000"/>
+              </a:spcBef>
+            </a:pPr>
+            <a:r>
+              <a:rPr sz="1800" b="1">
+                <a:solidFill>
+                  <a:srgbClr val="222222"/>
+                </a:solidFill>
+                <a:latin typeface="Calibri"/>
+              </a:rPr>
+              <a:t>Nociones matemáticas:</a:t>
+            </a:r>
+          </a:p>
+          <a:p>
+            <a:r>
+              <a:rPr sz="1800" b="0">
+                <a:solidFill>
+                  <a:srgbClr val="222222"/>
+                </a:solidFill>
+                <a:latin typeface="Calibri"/>
+              </a:rPr>
+              <a:t>•  Funciones cuadráticas, derivada, puntos críticos y criterio de la segunda derivada.</a:t>
+            </a:r>
+          </a:p>
+          <a:p>
+            <a:pPr>
+              <a:spcBef>
+                <a:spcPts val="1000"/>
+              </a:spcBef>
+            </a:pPr>
+            <a:r>
+              <a:rPr sz="1800" b="1">
+                <a:solidFill>
+                  <a:srgbClr val="222222"/>
+                </a:solidFill>
+                <a:latin typeface="Calibri"/>
+              </a:rPr>
+              <a:t>Problemática:</a:t>
+            </a:r>
+          </a:p>
+          <a:p>
+            <a:r>
+              <a:rPr sz="1800" b="0">
+                <a:solidFill>
+                  <a:srgbClr val="222222"/>
+                </a:solidFill>
+                <a:latin typeface="Calibri"/>
+              </a:rPr>
+              <a:t>•  Sobredimensionar recursos implica pagar de más; subdimensionarlos afecta el rendimiento del servicio.</a:t>
+            </a:r>
+          </a:p>
+          <a:p>
+            <a:r>
+              <a:rPr sz="1800" b="0">
+                <a:solidFill>
+                  <a:srgbClr val="222222"/>
+                </a:solidFill>
+                <a:latin typeface="Calibri"/>
+              </a:rPr>
+              <a:t>•  Pregunta central: ¿cómo determinar matemáticamente el número de instancias que minimiza el costo?</a:t>
+            </a:r>
           </a:p>
         </p:txBody>
       </p:sp>
@@ -4486,22 +4489,137 @@
             <p:ph type="title"/>
           </p:nvPr>
         </p:nvSpPr>
-        <p:spPr/>
-        <p:txBody>
-          <a:bodyPr/>
+        <p:spPr>
+          <a:xfrm>
+            <a:off x="838200" y="365125"/>
+            <a:ext cx="10515600" cy="1325563"/>
+          </a:xfrm>
+        </p:spPr>
+        <p:txBody>
+          <a:bodyPr wrap="square">
+            <a:noAutofit/>
+          </a:bodyPr>
           <a:lstStyle/>
           <a:p>
             <a:r>
-              <a:rPr lang="es-ES" sz="1800" b="0" i="0" dirty="0">
-                <a:solidFill>
-                  <a:srgbClr val="000000"/>
-                </a:solidFill>
-                <a:effectLst/>
-                <a:latin typeface="Calibri" panose="020F0502020204030204" pitchFamily="34" charset="0"/>
-              </a:rPr>
-              <a:t>Diapositiva 4: Objetivos y preguntas de investigación  </a:t>
+              <a:rPr sz="2600" b="1">
+                <a:solidFill>
+                  <a:srgbClr val="222222"/>
+                </a:solidFill>
+                <a:latin typeface="Calibri"/>
+              </a:rPr>
+              <a:t>Objetivos y preguntas de investigación</a:t>
             </a:r>
             <a:endParaRPr lang="es-CL" dirty="0"/>
+          </a:p>
+          <a:p>
+            <a:r>
+              <a:rPr sz="1800" b="1">
+                <a:solidFill>
+                  <a:srgbClr val="222222"/>
+                </a:solidFill>
+                <a:latin typeface="Calibri"/>
+              </a:rPr>
+              <a:t>Objetivo general:</a:t>
+            </a:r>
+          </a:p>
+          <a:p>
+            <a:r>
+              <a:rPr sz="1800" b="0">
+                <a:solidFill>
+                  <a:srgbClr val="222222"/>
+                </a:solidFill>
+                <a:latin typeface="Calibri"/>
+              </a:rPr>
+              <a:t>•  Modelar el costo de infraestructura cloud como función del número de instancias y aplicar la derivada para hallar el costo mínimo.</a:t>
+            </a:r>
+          </a:p>
+          <a:p>
+            <a:pPr>
+              <a:spcBef>
+                <a:spcPts val="1000"/>
+              </a:spcBef>
+            </a:pPr>
+            <a:r>
+              <a:rPr sz="1800" b="1">
+                <a:solidFill>
+                  <a:srgbClr val="222222"/>
+                </a:solidFill>
+                <a:latin typeface="Calibri"/>
+              </a:rPr>
+              <a:t>Objetivos específicos:</a:t>
+            </a:r>
+          </a:p>
+          <a:p>
+            <a:r>
+              <a:rPr sz="1800" b="0">
+                <a:solidFill>
+                  <a:srgbClr val="222222"/>
+                </a:solidFill>
+                <a:latin typeface="Calibri"/>
+              </a:rPr>
+              <a:t>•  Construir la función de costo C(x).</a:t>
+            </a:r>
+          </a:p>
+          <a:p>
+            <a:r>
+              <a:rPr sz="1800" b="0">
+                <a:solidFill>
+                  <a:srgbClr val="222222"/>
+                </a:solidFill>
+                <a:latin typeface="Calibri"/>
+              </a:rPr>
+              <a:t>•  Calcular C'(x) e identificar sus puntos críticos.</a:t>
+            </a:r>
+          </a:p>
+          <a:p>
+            <a:r>
+              <a:rPr sz="1800" b="0">
+                <a:solidFill>
+                  <a:srgbClr val="222222"/>
+                </a:solidFill>
+                <a:latin typeface="Calibri"/>
+              </a:rPr>
+              <a:t>•  Verificar el mínimo con el criterio de la segunda derivada.</a:t>
+            </a:r>
+          </a:p>
+          <a:p>
+            <a:r>
+              <a:rPr sz="1800" b="0">
+                <a:solidFill>
+                  <a:srgbClr val="222222"/>
+                </a:solidFill>
+                <a:latin typeface="Calibri"/>
+              </a:rPr>
+              <a:t>•  Desarrollar un simulador interactivo que visualice C(x) y C'(x).</a:t>
+            </a:r>
+          </a:p>
+          <a:p>
+            <a:pPr>
+              <a:spcBef>
+                <a:spcPts val="1000"/>
+              </a:spcBef>
+            </a:pPr>
+            <a:r>
+              <a:rPr sz="1800" b="1">
+                <a:solidFill>
+                  <a:srgbClr val="222222"/>
+                </a:solidFill>
+                <a:latin typeface="Calibri"/>
+              </a:rPr>
+              <a:t>Pregunta de investigación:</a:t>
+            </a:r>
+          </a:p>
+          <a:p>
+            <a:r>
+              <a:rPr sz="1800" b="0">
+                <a:solidFill>
+                  <a:srgbClr val="222222"/>
+                </a:solidFill>
+                <a:latin typeface="Calibri"/>
+              </a:rPr>
+              <a:t>•  ¿Cuál es el número óptimo de instancias que minimiza el costo mensual, y cómo se determina usando la derivada?</a:t>
+            </a:r>
           </a:p>
         </p:txBody>
       </p:sp>
@@ -4551,22 +4669,83 @@
             <p:ph type="title"/>
           </p:nvPr>
         </p:nvSpPr>
-        <p:spPr/>
-        <p:txBody>
-          <a:bodyPr/>
+        <p:spPr>
+          <a:xfrm>
+            <a:off x="838200" y="365125"/>
+            <a:ext cx="10515600" cy="1325563"/>
+          </a:xfrm>
+        </p:spPr>
+        <p:txBody>
+          <a:bodyPr wrap="square">
+            <a:noAutofit/>
+          </a:bodyPr>
           <a:lstStyle/>
           <a:p>
             <a:r>
-              <a:rPr lang="es-ES" sz="1800" b="0" i="0" dirty="0">
-                <a:solidFill>
-                  <a:srgbClr val="000000"/>
-                </a:solidFill>
-                <a:effectLst/>
-                <a:latin typeface="Calibri" panose="020F0502020204030204" pitchFamily="34" charset="0"/>
-              </a:rPr>
-              <a:t>Diapositiva 5: Temas iniciales involucrados</a:t>
+              <a:rPr sz="2600" b="1">
+                <a:solidFill>
+                  <a:srgbClr val="222222"/>
+                </a:solidFill>
+                <a:latin typeface="Calibri"/>
+              </a:rPr>
+              <a:t>Temas iniciales involucrados</a:t>
             </a:r>
             <a:endParaRPr lang="es-CL" dirty="0"/>
+          </a:p>
+          <a:p>
+            <a:r>
+              <a:rPr sz="1800" b="0">
+                <a:solidFill>
+                  <a:srgbClr val="222222"/>
+                </a:solidFill>
+                <a:latin typeface="Calibri"/>
+              </a:rPr>
+              <a:t>•  Funciones polinomiales (función cuadrática de costo).</a:t>
+            </a:r>
+          </a:p>
+          <a:p>
+            <a:r>
+              <a:rPr sz="1800" b="0">
+                <a:solidFill>
+                  <a:srgbClr val="222222"/>
+                </a:solidFill>
+                <a:latin typeface="Calibri"/>
+              </a:rPr>
+              <a:t>•  Límites y continuidad.</a:t>
+            </a:r>
+          </a:p>
+          <a:p>
+            <a:r>
+              <a:rPr sz="1800" b="0">
+                <a:solidFill>
+                  <a:srgbClr val="222222"/>
+                </a:solidFill>
+                <a:latin typeface="Calibri"/>
+              </a:rPr>
+              <a:t>•  Reglas de derivación.</a:t>
+            </a:r>
+          </a:p>
+          <a:p>
+            <a:r>
+              <a:rPr sz="1800" b="0">
+                <a:solidFill>
+                  <a:srgbClr val="222222"/>
+                </a:solidFill>
+                <a:latin typeface="Calibri"/>
+              </a:rPr>
+              <a:t>•  Puntos críticos y criterio de la primera y segunda derivada.</a:t>
+            </a:r>
+          </a:p>
+          <a:p>
+            <a:r>
+              <a:rPr sz="1800" b="0">
+                <a:solidFill>
+                  <a:srgbClr val="222222"/>
+                </a:solidFill>
+                <a:latin typeface="Calibri"/>
+              </a:rPr>
+              <a:t>•  Optimización aplicada a problemas de ingeniería.</a:t>
+            </a:r>
           </a:p>
         </p:txBody>
       </p:sp>
@@ -4616,65 +4795,689 @@
             <p:ph type="title"/>
           </p:nvPr>
         </p:nvSpPr>
-        <p:spPr/>
-        <p:txBody>
-          <a:bodyPr/>
-          <a:lstStyle/>
-          <a:p>
-            <a:r>
-              <a:rPr lang="es-ES" sz="1800" b="0" i="0" dirty="0">
-                <a:solidFill>
-                  <a:srgbClr val="000000"/>
-                </a:solidFill>
-                <a:effectLst/>
-                <a:latin typeface="Calibri" panose="020F0502020204030204" pitchFamily="34" charset="0"/>
-              </a:rPr>
-              <a:t>Diapositiva 6: Cronograma y materiales </a:t>
-            </a:r>
-            <a:r>
-              <a:rPr lang="es-ES" sz="1800" b="0" i="0">
-                <a:solidFill>
-                  <a:srgbClr val="000000"/>
-                </a:solidFill>
-                <a:effectLst/>
-                <a:latin typeface="Calibri" panose="020F0502020204030204" pitchFamily="34" charset="0"/>
-              </a:rPr>
-              <a:t>a utilizar</a:t>
-            </a:r>
-            <a:endParaRPr lang="es-CL" dirty="0"/>
-          </a:p>
-        </p:txBody>
-      </p:sp>
-      <p:pic>
-        <p:nvPicPr>
-          <p:cNvPr id="3" name="Imagen 2">
-            <a:extLst>
-              <a:ext uri="{FF2B5EF4-FFF2-40B4-BE49-F238E27FC236}">
-                <a16:creationId xmlns:a16="http://schemas.microsoft.com/office/drawing/2014/main" id="{AD263F61-AD2D-2070-D2C7-194E417FF022}"/>
-              </a:ext>
-            </a:extLst>
-          </p:cNvPr>
-          <p:cNvPicPr>
-            <a:picLocks noChangeAspect="1"/>
-          </p:cNvPicPr>
-          <p:nvPr/>
-        </p:nvPicPr>
-        <p:blipFill>
-          <a:blip r:embed="rId2"/>
-          <a:stretch>
-            <a:fillRect/>
-          </a:stretch>
-        </p:blipFill>
         <p:spPr>
           <a:xfrm>
-            <a:off x="838201" y="1577779"/>
-            <a:ext cx="10515600" cy="3493782"/>
+            <a:off x="838200" y="365125"/>
+            <a:ext cx="10515600" cy="1325563"/>
           </a:xfrm>
-          <a:prstGeom prst="rect">
-            <a:avLst/>
-          </a:prstGeom>
         </p:spPr>
-      </p:pic>
+        <p:txBody>
+          <a:bodyPr wrap="square">
+            <a:noAutofit/>
+          </a:bodyPr>
+          <a:lstStyle/>
+          <a:p>
+            <a:r>
+              <a:rPr sz="2600" b="1">
+                <a:solidFill>
+                  <a:srgbClr val="222222"/>
+                </a:solidFill>
+                <a:latin typeface="Calibri"/>
+              </a:rPr>
+              <a:t>Cronograma y materiales a utilizar</a:t>
+            </a:r>
+            <a:endParaRPr lang="es-CL" dirty="0"/>
+          </a:p>
+        </p:txBody>
+      </p:sp>
+      <p:graphicFrame>
+        <p:nvGraphicFramePr>
+          <p:cNvPr id="3" name="Table 2"/>
+          <p:cNvGraphicFramePr>
+            <a:graphicFrameLocks noGrp="1"/>
+          </p:cNvGraphicFramePr>
+          <p:nvPr/>
+        </p:nvGraphicFramePr>
+        <p:xfrm>
+          <a:off x="838200" y="1790688"/>
+          <a:ext cx="10515600" cy="3600000"/>
+        </p:xfrm>
+        <a:graphic>
+          <a:graphicData uri="http://schemas.openxmlformats.org/drawingml/2006/table">
+            <a:tbl>
+              <a:tblPr firstRow="1" bandRow="1">
+                <a:tableStyleId>{5C22544A-7EE6-4342-B048-85BDC9FD1C3A}</a:tableStyleId>
+              </a:tblPr>
+              <a:tblGrid>
+                <a:gridCol w="2103120"/>
+                <a:gridCol w="2103120"/>
+                <a:gridCol w="2103120"/>
+                <a:gridCol w="2103120"/>
+                <a:gridCol w="2103120"/>
+              </a:tblGrid>
+              <a:tr h="514285">
+                <a:tc>
+                  <a:txBody>
+                    <a:bodyPr/>
+                    <a:lstStyle/>
+                    <a:p>
+                      <a:r>
+                        <a:rPr b="1" sz="1300">
+                          <a:latin typeface="Calibri"/>
+                        </a:rPr>
+                        <a:t>Tareas</a:t>
+                      </a:r>
+                    </a:p>
+                  </a:txBody>
+                  <a:tcPr/>
+                </a:tc>
+                <a:tc>
+                  <a:txBody>
+                    <a:bodyPr/>
+                    <a:lstStyle/>
+                    <a:p>
+                      <a:r>
+                        <a:rPr b="1" sz="1300">
+                          <a:latin typeface="Calibri"/>
+                        </a:rPr>
+                        <a:t>Productos</a:t>
+                      </a:r>
+                    </a:p>
+                  </a:txBody>
+                  <a:tcPr/>
+                </a:tc>
+                <a:tc>
+                  <a:txBody>
+                    <a:bodyPr/>
+                    <a:lstStyle/>
+                    <a:p>
+                      <a:r>
+                        <a:rPr b="1" sz="1300">
+                          <a:latin typeface="Calibri"/>
+                        </a:rPr>
+                        <a:t>Plazos</a:t>
+                      </a:r>
+                    </a:p>
+                  </a:txBody>
+                  <a:tcPr/>
+                </a:tc>
+                <a:tc>
+                  <a:txBody>
+                    <a:bodyPr/>
+                    <a:lstStyle/>
+                    <a:p>
+                      <a:r>
+                        <a:rPr b="1" sz="1300">
+                          <a:latin typeface="Calibri"/>
+                        </a:rPr>
+                        <a:t>Responsable(s)</a:t>
+                      </a:r>
+                    </a:p>
+                  </a:txBody>
+                  <a:tcPr/>
+                </a:tc>
+                <a:tc>
+                  <a:txBody>
+                    <a:bodyPr/>
+                    <a:lstStyle/>
+                    <a:p>
+                      <a:r>
+                        <a:rPr b="1" sz="1300">
+                          <a:latin typeface="Calibri"/>
+                        </a:rPr>
+                        <a:t>Insumos</a:t>
+                      </a:r>
+                    </a:p>
+                  </a:txBody>
+                  <a:tcPr/>
+                </a:tc>
+              </a:tr>
+              <a:tr h="514285">
+                <a:tc>
+                  <a:txBody>
+                    <a:bodyPr/>
+                    <a:lstStyle/>
+                    <a:p>
+                      <a:pPr>
+                        <a:defRPr sz="1100"/>
+                      </a:pPr>
+                      <a:r>
+                        <a:rPr sz="1100">
+                          <a:latin typeface="Calibri"/>
+                        </a:rPr>
+                        <a:t>Investigar problemática y definir tema</a:t>
+                      </a:r>
+                    </a:p>
+                  </a:txBody>
+                  <a:tcPr/>
+                </a:tc>
+                <a:tc>
+                  <a:txBody>
+                    <a:bodyPr/>
+                    <a:lstStyle/>
+                    <a:p>
+                      <a:pPr>
+                        <a:defRPr sz="1100"/>
+                      </a:pPr>
+                      <a:r>
+                        <a:rPr sz="1100">
+                          <a:latin typeface="Calibri"/>
+                        </a:rPr>
+                        <a:t>Problemática y tema definidos</a:t>
+                      </a:r>
+                    </a:p>
+                  </a:txBody>
+                  <a:tcPr/>
+                </a:tc>
+                <a:tc>
+                  <a:txBody>
+                    <a:bodyPr/>
+                    <a:lstStyle/>
+                    <a:p>
+                      <a:pPr>
+                        <a:defRPr sz="1100"/>
+                      </a:pPr>
+                      <a:r>
+                        <a:rPr sz="1100">
+                          <a:latin typeface="Calibri"/>
+                        </a:rPr>
+                        <a:t>Semana 1-2</a:t>
+                      </a:r>
+                    </a:p>
+                  </a:txBody>
+                  <a:tcPr/>
+                </a:tc>
+                <a:tc>
+                  <a:txBody>
+                    <a:bodyPr/>
+                    <a:lstStyle/>
+                    <a:p>
+                      <a:pPr>
+                        <a:defRPr sz="1100"/>
+                      </a:pPr>
+                      <a:r>
+                        <a:rPr sz="1100">
+                          <a:latin typeface="Calibri"/>
+                        </a:rPr>
+                        <a:t>Andrés Carrasco</a:t>
+                      </a:r>
+                    </a:p>
+                  </a:txBody>
+                  <a:tcPr/>
+                </a:tc>
+                <a:tc>
+                  <a:txBody>
+                    <a:bodyPr/>
+                    <a:lstStyle/>
+                    <a:p>
+                      <a:pPr>
+                        <a:defRPr sz="1100"/>
+                      </a:pPr>
+                      <a:r>
+                        <a:rPr sz="1100">
+                          <a:latin typeface="Calibri"/>
+                        </a:rPr>
+                        <a:t>Bibliografía de cálculo</a:t>
+                      </a:r>
+                    </a:p>
+                  </a:txBody>
+                  <a:tcPr/>
+                </a:tc>
+              </a:tr>
+              <a:tr h="514285">
+                <a:tc>
+                  <a:txBody>
+                    <a:bodyPr/>
+                    <a:lstStyle/>
+                    <a:p>
+                      <a:pPr>
+                        <a:defRPr sz="1100"/>
+                      </a:pPr>
+                      <a:r>
+                        <a:rPr sz="1100">
+                          <a:latin typeface="Calibri"/>
+                        </a:rPr>
+                        <a:t>Formular objetivos y modelo matemático inicial</a:t>
+                      </a:r>
+                    </a:p>
+                  </a:txBody>
+                  <a:tcPr/>
+                </a:tc>
+                <a:tc>
+                  <a:txBody>
+                    <a:bodyPr/>
+                    <a:lstStyle/>
+                    <a:p>
+                      <a:pPr>
+                        <a:defRPr sz="1100"/>
+                      </a:pPr>
+                      <a:r>
+                        <a:rPr sz="1100">
+                          <a:latin typeface="Calibri"/>
+                        </a:rPr>
+                        <a:t>Función de costo C(x) planteada</a:t>
+                      </a:r>
+                    </a:p>
+                  </a:txBody>
+                  <a:tcPr/>
+                </a:tc>
+                <a:tc>
+                  <a:txBody>
+                    <a:bodyPr/>
+                    <a:lstStyle/>
+                    <a:p>
+                      <a:pPr>
+                        <a:defRPr sz="1100"/>
+                      </a:pPr>
+                      <a:r>
+                        <a:rPr sz="1100">
+                          <a:latin typeface="Calibri"/>
+                        </a:rPr>
+                        <a:t>Semana 3-4</a:t>
+                      </a:r>
+                    </a:p>
+                  </a:txBody>
+                  <a:tcPr/>
+                </a:tc>
+                <a:tc>
+                  <a:txBody>
+                    <a:bodyPr/>
+                    <a:lstStyle/>
+                    <a:p>
+                      <a:pPr>
+                        <a:defRPr sz="1100"/>
+                      </a:pPr>
+                      <a:r>
+                        <a:rPr sz="1100">
+                          <a:latin typeface="Calibri"/>
+                        </a:rPr>
+                        <a:t>Andrés Carrasco</a:t>
+                      </a:r>
+                    </a:p>
+                  </a:txBody>
+                  <a:tcPr/>
+                </a:tc>
+                <a:tc>
+                  <a:txBody>
+                    <a:bodyPr/>
+                    <a:lstStyle/>
+                    <a:p>
+                      <a:pPr>
+                        <a:defRPr sz="1100"/>
+                      </a:pPr>
+                      <a:r>
+                        <a:rPr sz="1100">
+                          <a:latin typeface="Calibri"/>
+                        </a:rPr>
+                        <a:t>Apuntes de cálculo</a:t>
+                      </a:r>
+                    </a:p>
+                  </a:txBody>
+                  <a:tcPr/>
+                </a:tc>
+              </a:tr>
+              <a:tr h="514285">
+                <a:tc>
+                  <a:txBody>
+                    <a:bodyPr/>
+                    <a:lstStyle/>
+                    <a:p>
+                      <a:pPr>
+                        <a:defRPr sz="1100"/>
+                      </a:pPr>
+                      <a:r>
+                        <a:rPr sz="1100">
+                          <a:latin typeface="Calibri"/>
+                        </a:rPr>
+                        <a:t>Aplicar la derivada y validar el mínimo</a:t>
+                      </a:r>
+                    </a:p>
+                  </a:txBody>
+                  <a:tcPr/>
+                </a:tc>
+                <a:tc>
+                  <a:txBody>
+                    <a:bodyPr/>
+                    <a:lstStyle/>
+                    <a:p>
+                      <a:pPr>
+                        <a:defRPr sz="1100"/>
+                      </a:pPr>
+                      <a:r>
+                        <a:rPr sz="1100">
+                          <a:latin typeface="Calibri"/>
+                        </a:rPr>
+                        <a:t>Punto crítico verificado con C''(x)</a:t>
+                      </a:r>
+                    </a:p>
+                  </a:txBody>
+                  <a:tcPr/>
+                </a:tc>
+                <a:tc>
+                  <a:txBody>
+                    <a:bodyPr/>
+                    <a:lstStyle/>
+                    <a:p>
+                      <a:pPr>
+                        <a:defRPr sz="1100"/>
+                      </a:pPr>
+                      <a:r>
+                        <a:rPr sz="1100">
+                          <a:latin typeface="Calibri"/>
+                        </a:rPr>
+                        <a:t>Semana 5-6</a:t>
+                      </a:r>
+                    </a:p>
+                  </a:txBody>
+                  <a:tcPr/>
+                </a:tc>
+                <a:tc>
+                  <a:txBody>
+                    <a:bodyPr/>
+                    <a:lstStyle/>
+                    <a:p>
+                      <a:pPr>
+                        <a:defRPr sz="1100"/>
+                      </a:pPr>
+                      <a:r>
+                        <a:rPr sz="1100">
+                          <a:latin typeface="Calibri"/>
+                        </a:rPr>
+                        <a:t>Andrés Carrasco</a:t>
+                      </a:r>
+                    </a:p>
+                  </a:txBody>
+                  <a:tcPr/>
+                </a:tc>
+                <a:tc>
+                  <a:txBody>
+                    <a:bodyPr/>
+                    <a:lstStyle/>
+                    <a:p>
+                      <a:pPr>
+                        <a:defRPr sz="1100"/>
+                      </a:pPr>
+                      <a:r>
+                        <a:rPr sz="1100">
+                          <a:latin typeface="Calibri"/>
+                        </a:rPr>
+                        <a:t>Software de cálculo (GeoGebra/Python)</a:t>
+                      </a:r>
+                    </a:p>
+                  </a:txBody>
+                  <a:tcPr/>
+                </a:tc>
+              </a:tr>
+              <a:tr h="514285">
+                <a:tc>
+                  <a:txBody>
+                    <a:bodyPr/>
+                    <a:lstStyle/>
+                    <a:p>
+                      <a:pPr>
+                        <a:defRPr sz="1100"/>
+                      </a:pPr>
+                      <a:r>
+                        <a:rPr sz="1100">
+                          <a:latin typeface="Calibri"/>
+                        </a:rPr>
+                        <a:t>Diseñar y programar el simulador web</a:t>
+                      </a:r>
+                    </a:p>
+                  </a:txBody>
+                  <a:tcPr/>
+                </a:tc>
+                <a:tc>
+                  <a:txBody>
+                    <a:bodyPr/>
+                    <a:lstStyle/>
+                    <a:p>
+                      <a:pPr>
+                        <a:defRPr sz="1100"/>
+                      </a:pPr>
+                      <a:r>
+                        <a:rPr sz="1100">
+                          <a:latin typeface="Calibri"/>
+                        </a:rPr>
+                        <a:t>Sitio web + simulador interactivo</a:t>
+                      </a:r>
+                    </a:p>
+                  </a:txBody>
+                  <a:tcPr/>
+                </a:tc>
+                <a:tc>
+                  <a:txBody>
+                    <a:bodyPr/>
+                    <a:lstStyle/>
+                    <a:p>
+                      <a:pPr>
+                        <a:defRPr sz="1100"/>
+                      </a:pPr>
+                      <a:r>
+                        <a:rPr sz="1100">
+                          <a:latin typeface="Calibri"/>
+                        </a:rPr>
+                        <a:t>Semana 7-9</a:t>
+                      </a:r>
+                    </a:p>
+                  </a:txBody>
+                  <a:tcPr/>
+                </a:tc>
+                <a:tc>
+                  <a:txBody>
+                    <a:bodyPr/>
+                    <a:lstStyle/>
+                    <a:p>
+                      <a:pPr>
+                        <a:defRPr sz="1100"/>
+                      </a:pPr>
+                      <a:r>
+                        <a:rPr sz="1100">
+                          <a:latin typeface="Calibri"/>
+                        </a:rPr>
+                        <a:t>Andrés Carrasco</a:t>
+                      </a:r>
+                    </a:p>
+                  </a:txBody>
+                  <a:tcPr/>
+                </a:tc>
+                <a:tc>
+                  <a:txBody>
+                    <a:bodyPr/>
+                    <a:lstStyle/>
+                    <a:p>
+                      <a:pPr>
+                        <a:defRPr sz="1100"/>
+                      </a:pPr>
+                      <a:r>
+                        <a:rPr sz="1100">
+                          <a:latin typeface="Calibri"/>
+                        </a:rPr>
+                        <a:t>HTML/CSS/JS, Plotly.js, Vercel</a:t>
+                      </a:r>
+                    </a:p>
+                  </a:txBody>
+                  <a:tcPr/>
+                </a:tc>
+              </a:tr>
+              <a:tr h="514285">
+                <a:tc>
+                  <a:txBody>
+                    <a:bodyPr/>
+                    <a:lstStyle/>
+                    <a:p>
+                      <a:pPr>
+                        <a:defRPr sz="1100"/>
+                      </a:pPr>
+                      <a:r>
+                        <a:rPr sz="1100">
+                          <a:latin typeface="Calibri"/>
+                        </a:rPr>
+                        <a:t>Redactar resultados, conclusiones y bibliografía</a:t>
+                      </a:r>
+                    </a:p>
+                  </a:txBody>
+                  <a:tcPr/>
+                </a:tc>
+                <a:tc>
+                  <a:txBody>
+                    <a:bodyPr/>
+                    <a:lstStyle/>
+                    <a:p>
+                      <a:pPr>
+                        <a:defRPr sz="1100"/>
+                      </a:pPr>
+                      <a:r>
+                        <a:rPr sz="1100">
+                          <a:latin typeface="Calibri"/>
+                        </a:rPr>
+                        <a:t>Informe final y presentación</a:t>
+                      </a:r>
+                    </a:p>
+                  </a:txBody>
+                  <a:tcPr/>
+                </a:tc>
+                <a:tc>
+                  <a:txBody>
+                    <a:bodyPr/>
+                    <a:lstStyle/>
+                    <a:p>
+                      <a:pPr>
+                        <a:defRPr sz="1100"/>
+                      </a:pPr>
+                      <a:r>
+                        <a:rPr sz="1100">
+                          <a:latin typeface="Calibri"/>
+                        </a:rPr>
+                        <a:t>Semana 10-11</a:t>
+                      </a:r>
+                    </a:p>
+                  </a:txBody>
+                  <a:tcPr/>
+                </a:tc>
+                <a:tc>
+                  <a:txBody>
+                    <a:bodyPr/>
+                    <a:lstStyle/>
+                    <a:p>
+                      <a:pPr>
+                        <a:defRPr sz="1100"/>
+                      </a:pPr>
+                      <a:r>
+                        <a:rPr sz="1100">
+                          <a:latin typeface="Calibri"/>
+                        </a:rPr>
+                        <a:t>Andrés Carrasco</a:t>
+                      </a:r>
+                    </a:p>
+                  </a:txBody>
+                  <a:tcPr/>
+                </a:tc>
+                <a:tc>
+                  <a:txBody>
+                    <a:bodyPr/>
+                    <a:lstStyle/>
+                    <a:p>
+                      <a:pPr>
+                        <a:defRPr sz="1100"/>
+                      </a:pPr>
+                      <a:r>
+                        <a:rPr sz="1100">
+                          <a:latin typeface="Calibri"/>
+                        </a:rPr>
+                        <a:t>Procesador de texto, fuentes</a:t>
+                      </a:r>
+                    </a:p>
+                  </a:txBody>
+                  <a:tcPr/>
+                </a:tc>
+              </a:tr>
+              <a:tr h="514290">
+                <a:tc>
+                  <a:txBody>
+                    <a:bodyPr/>
+                    <a:lstStyle/>
+                    <a:p>
+                      <a:pPr>
+                        <a:defRPr sz="1100"/>
+                      </a:pPr>
+                      <a:r>
+                        <a:rPr sz="1100">
+                          <a:latin typeface="Calibri"/>
+                        </a:rPr>
+                        <a:t>Grabar video y preparar entrega final</a:t>
+                      </a:r>
+                    </a:p>
+                  </a:txBody>
+                  <a:tcPr/>
+                </a:tc>
+                <a:tc>
+                  <a:txBody>
+                    <a:bodyPr/>
+                    <a:lstStyle/>
+                    <a:p>
+                      <a:pPr>
+                        <a:defRPr sz="1100"/>
+                      </a:pPr>
+                      <a:r>
+                        <a:rPr sz="1100">
+                          <a:latin typeface="Calibri"/>
+                        </a:rPr>
+                        <a:t>Video + PPT final</a:t>
+                      </a:r>
+                    </a:p>
+                  </a:txBody>
+                  <a:tcPr/>
+                </a:tc>
+                <a:tc>
+                  <a:txBody>
+                    <a:bodyPr/>
+                    <a:lstStyle/>
+                    <a:p>
+                      <a:pPr>
+                        <a:defRPr sz="1100"/>
+                      </a:pPr>
+                      <a:r>
+                        <a:rPr sz="1100">
+                          <a:latin typeface="Calibri"/>
+                        </a:rPr>
+                        <a:t>Semana 12</a:t>
+                      </a:r>
+                    </a:p>
+                  </a:txBody>
+                  <a:tcPr/>
+                </a:tc>
+                <a:tc>
+                  <a:txBody>
+                    <a:bodyPr/>
+                    <a:lstStyle/>
+                    <a:p>
+                      <a:pPr>
+                        <a:defRPr sz="1100"/>
+                      </a:pPr>
+                      <a:r>
+                        <a:rPr sz="1100">
+                          <a:latin typeface="Calibri"/>
+                        </a:rPr>
+                        <a:t>Andrés Carrasco</a:t>
+                      </a:r>
+                    </a:p>
+                  </a:txBody>
+                  <a:tcPr/>
+                </a:tc>
+                <a:tc>
+                  <a:txBody>
+                    <a:bodyPr/>
+                    <a:lstStyle/>
+                    <a:p>
+                      <a:pPr>
+                        <a:defRPr sz="1100"/>
+                      </a:pPr>
+                      <a:r>
+                        <a:rPr sz="1100">
+                          <a:latin typeface="Calibri"/>
+                        </a:rPr>
+                        <a:t>Guion, grabadora de audio, ffmpeg</a:t>
+                      </a:r>
+                    </a:p>
+                  </a:txBody>
+                  <a:tcPr/>
+                </a:tc>
+              </a:tr>
+            </a:tbl>
+          </a:graphicData>
+        </a:graphic>
+      </p:graphicFrame>
     </p:spTree>
     <p:extLst>
       <p:ext uri="{BB962C8B-B14F-4D97-AF65-F5344CB8AC3E}">
@@ -4719,8 +5522,8 @@
         </p:nvSpPr>
         <p:spPr>
           <a:xfrm>
-            <a:off x="805218" y="1524000"/>
-            <a:ext cx="9730260" cy="923330"/>
+            <a:off x="838200" y="365125"/>
+            <a:ext cx="10515600" cy="6192875"/>
           </a:xfrm>
           <a:prstGeom prst="rect">
             <a:avLst/>
@@ -4729,209 +5532,18 @@
         </p:spPr>
         <p:txBody>
           <a:bodyPr wrap="square" rtlCol="0">
-            <a:spAutoFit/>
+            <a:noAutofit/>
           </a:bodyPr>
           <a:lstStyle/>
           <a:p>
             <a:r>
-              <a:rPr lang="es-ES" sz="1800" dirty="0">
-                <a:effectLst/>
-                <a:latin typeface="Calibri" panose="020F0502020204030204" pitchFamily="34" charset="0"/>
-                <a:ea typeface="Calibri" panose="020F0502020204030204" pitchFamily="34" charset="0"/>
-              </a:rPr>
-              <a:t>Diapositiva</a:t>
-            </a:r>
-            <a:r>
-              <a:rPr lang="es-ES" sz="1800" spc="5" dirty="0">
-                <a:effectLst/>
-                <a:latin typeface="Calibri" panose="020F0502020204030204" pitchFamily="34" charset="0"/>
-                <a:ea typeface="Calibri" panose="020F0502020204030204" pitchFamily="34" charset="0"/>
-              </a:rPr>
-              <a:t> </a:t>
-            </a:r>
-            <a:r>
-              <a:rPr lang="es-ES" sz="1800" dirty="0">
-                <a:effectLst/>
-                <a:latin typeface="Calibri" panose="020F0502020204030204" pitchFamily="34" charset="0"/>
-                <a:ea typeface="Calibri" panose="020F0502020204030204" pitchFamily="34" charset="0"/>
-              </a:rPr>
-              <a:t>7:</a:t>
-            </a:r>
-            <a:r>
-              <a:rPr lang="es-ES" sz="1800" spc="5" dirty="0">
-                <a:effectLst/>
-                <a:latin typeface="Calibri" panose="020F0502020204030204" pitchFamily="34" charset="0"/>
-                <a:ea typeface="Calibri" panose="020F0502020204030204" pitchFamily="34" charset="0"/>
-              </a:rPr>
-              <a:t> </a:t>
-            </a:r>
-            <a:r>
-              <a:rPr lang="es-ES" sz="1800" dirty="0">
-                <a:effectLst/>
-                <a:latin typeface="Calibri" panose="020F0502020204030204" pitchFamily="34" charset="0"/>
-                <a:ea typeface="Calibri" panose="020F0502020204030204" pitchFamily="34" charset="0"/>
-              </a:rPr>
-              <a:t>Muestra</a:t>
-            </a:r>
-            <a:r>
-              <a:rPr lang="es-ES" sz="1800" spc="5" dirty="0">
-                <a:effectLst/>
-                <a:latin typeface="Calibri" panose="020F0502020204030204" pitchFamily="34" charset="0"/>
-                <a:ea typeface="Calibri" panose="020F0502020204030204" pitchFamily="34" charset="0"/>
-              </a:rPr>
-              <a:t> </a:t>
-            </a:r>
-            <a:r>
-              <a:rPr lang="es-ES" sz="1800" dirty="0">
-                <a:effectLst/>
-                <a:latin typeface="Calibri" panose="020F0502020204030204" pitchFamily="34" charset="0"/>
-                <a:ea typeface="Calibri" panose="020F0502020204030204" pitchFamily="34" charset="0"/>
-              </a:rPr>
-              <a:t>la</a:t>
-            </a:r>
-            <a:r>
-              <a:rPr lang="es-ES" sz="1800" spc="5" dirty="0">
-                <a:effectLst/>
-                <a:latin typeface="Calibri" panose="020F0502020204030204" pitchFamily="34" charset="0"/>
-                <a:ea typeface="Calibri" panose="020F0502020204030204" pitchFamily="34" charset="0"/>
-              </a:rPr>
-              <a:t> </a:t>
-            </a:r>
-            <a:r>
-              <a:rPr lang="es-ES" sz="1800" dirty="0">
-                <a:effectLst/>
-                <a:latin typeface="Calibri" panose="020F0502020204030204" pitchFamily="34" charset="0"/>
-                <a:ea typeface="Calibri" panose="020F0502020204030204" pitchFamily="34" charset="0"/>
-              </a:rPr>
-              <a:t>necesidad</a:t>
-            </a:r>
-            <a:r>
-              <a:rPr lang="es-ES" sz="1800" spc="5" dirty="0">
-                <a:effectLst/>
-                <a:latin typeface="Calibri" panose="020F0502020204030204" pitchFamily="34" charset="0"/>
-                <a:ea typeface="Calibri" panose="020F0502020204030204" pitchFamily="34" charset="0"/>
-              </a:rPr>
-              <a:t> </a:t>
-            </a:r>
-            <a:r>
-              <a:rPr lang="es-ES" sz="1800" dirty="0">
-                <a:effectLst/>
-                <a:latin typeface="Calibri" panose="020F0502020204030204" pitchFamily="34" charset="0"/>
-                <a:ea typeface="Calibri" panose="020F0502020204030204" pitchFamily="34" charset="0"/>
-              </a:rPr>
-              <a:t>de</a:t>
-            </a:r>
-            <a:r>
-              <a:rPr lang="es-ES" sz="1800" spc="5" dirty="0">
-                <a:effectLst/>
-                <a:latin typeface="Calibri" panose="020F0502020204030204" pitchFamily="34" charset="0"/>
-                <a:ea typeface="Calibri" panose="020F0502020204030204" pitchFamily="34" charset="0"/>
-              </a:rPr>
-              <a:t> </a:t>
-            </a:r>
-            <a:r>
-              <a:rPr lang="es-ES" sz="1800" dirty="0">
-                <a:effectLst/>
-                <a:latin typeface="Calibri" panose="020F0502020204030204" pitchFamily="34" charset="0"/>
-                <a:ea typeface="Calibri" panose="020F0502020204030204" pitchFamily="34" charset="0"/>
-              </a:rPr>
-              <a:t>incorporación</a:t>
-            </a:r>
-            <a:r>
-              <a:rPr lang="es-ES" sz="1800" spc="5" dirty="0">
-                <a:effectLst/>
-                <a:latin typeface="Calibri" panose="020F0502020204030204" pitchFamily="34" charset="0"/>
-                <a:ea typeface="Calibri" panose="020F0502020204030204" pitchFamily="34" charset="0"/>
-              </a:rPr>
-              <a:t> </a:t>
-            </a:r>
-            <a:r>
-              <a:rPr lang="es-ES" sz="1800" dirty="0">
-                <a:effectLst/>
-                <a:latin typeface="Calibri" panose="020F0502020204030204" pitchFamily="34" charset="0"/>
-                <a:ea typeface="Calibri" panose="020F0502020204030204" pitchFamily="34" charset="0"/>
-              </a:rPr>
-              <a:t>de</a:t>
-            </a:r>
-            <a:r>
-              <a:rPr lang="es-ES" sz="1800" spc="5" dirty="0">
-                <a:effectLst/>
-                <a:latin typeface="Calibri" panose="020F0502020204030204" pitchFamily="34" charset="0"/>
-                <a:ea typeface="Calibri" panose="020F0502020204030204" pitchFamily="34" charset="0"/>
-              </a:rPr>
-              <a:t> </a:t>
-            </a:r>
-            <a:r>
-              <a:rPr lang="es-ES" sz="1800" dirty="0">
-                <a:effectLst/>
-                <a:latin typeface="Calibri" panose="020F0502020204030204" pitchFamily="34" charset="0"/>
-                <a:ea typeface="Calibri" panose="020F0502020204030204" pitchFamily="34" charset="0"/>
-              </a:rPr>
-              <a:t>herramientas</a:t>
-            </a:r>
-            <a:r>
-              <a:rPr lang="es-ES" sz="1800" spc="5" dirty="0">
-                <a:effectLst/>
-                <a:latin typeface="Calibri" panose="020F0502020204030204" pitchFamily="34" charset="0"/>
-                <a:ea typeface="Calibri" panose="020F0502020204030204" pitchFamily="34" charset="0"/>
-              </a:rPr>
-              <a:t> </a:t>
-            </a:r>
-            <a:r>
-              <a:rPr lang="es-ES" sz="1800" dirty="0">
-                <a:effectLst/>
-                <a:latin typeface="Calibri" panose="020F0502020204030204" pitchFamily="34" charset="0"/>
-                <a:ea typeface="Calibri" panose="020F0502020204030204" pitchFamily="34" charset="0"/>
-              </a:rPr>
-              <a:t>tecnológicas</a:t>
-            </a:r>
-            <a:r>
-              <a:rPr lang="es-ES" sz="1800" spc="5" dirty="0">
-                <a:effectLst/>
-                <a:latin typeface="Calibri" panose="020F0502020204030204" pitchFamily="34" charset="0"/>
-                <a:ea typeface="Calibri" panose="020F0502020204030204" pitchFamily="34" charset="0"/>
-              </a:rPr>
-              <a:t> </a:t>
-            </a:r>
-            <a:r>
-              <a:rPr lang="es-ES" sz="1800" dirty="0">
-                <a:effectLst/>
-                <a:latin typeface="Calibri" panose="020F0502020204030204" pitchFamily="34" charset="0"/>
-                <a:ea typeface="Calibri" panose="020F0502020204030204" pitchFamily="34" charset="0"/>
-              </a:rPr>
-              <a:t>y</a:t>
-            </a:r>
-            <a:r>
-              <a:rPr lang="es-ES" sz="1800" spc="5" dirty="0">
-                <a:effectLst/>
-                <a:latin typeface="Calibri" panose="020F0502020204030204" pitchFamily="34" charset="0"/>
-                <a:ea typeface="Calibri" panose="020F0502020204030204" pitchFamily="34" charset="0"/>
-              </a:rPr>
-              <a:t> </a:t>
-            </a:r>
-            <a:r>
-              <a:rPr lang="es-ES" sz="1800" dirty="0">
-                <a:effectLst/>
-                <a:latin typeface="Calibri" panose="020F0502020204030204" pitchFamily="34" charset="0"/>
-                <a:ea typeface="Calibri" panose="020F0502020204030204" pitchFamily="34" charset="0"/>
-              </a:rPr>
-              <a:t>justifican su</a:t>
-            </a:r>
-            <a:r>
-              <a:rPr lang="es-ES" sz="1800" spc="-5" dirty="0">
-                <a:effectLst/>
-                <a:latin typeface="Calibri" panose="020F0502020204030204" pitchFamily="34" charset="0"/>
-                <a:ea typeface="Calibri" panose="020F0502020204030204" pitchFamily="34" charset="0"/>
-              </a:rPr>
-              <a:t> </a:t>
-            </a:r>
-            <a:r>
-              <a:rPr lang="es-ES" sz="1800" dirty="0">
-                <a:effectLst/>
-                <a:latin typeface="Calibri" panose="020F0502020204030204" pitchFamily="34" charset="0"/>
-                <a:ea typeface="Calibri" panose="020F0502020204030204" pitchFamily="34" charset="0"/>
-              </a:rPr>
-              <a:t>elección.</a:t>
+              <a:rPr sz="2600" b="1">
+                <a:solidFill>
+                  <a:srgbClr val="222222"/>
+                </a:solidFill>
+                <a:latin typeface="Calibri"/>
+              </a:rPr>
+              <a:t>Justificación de herramientas tecnológicas</a:t>
             </a:r>
             <a:endParaRPr lang="es-CL" sz="1800" dirty="0">
               <a:effectLst/>
@@ -4940,7 +5552,48 @@
             </a:endParaRPr>
           </a:p>
           <a:p>
-            <a:endParaRPr lang="es-CL" dirty="0"/>
+            <a:r>
+              <a:rPr sz="1800" b="0">
+                <a:solidFill>
+                  <a:srgbClr val="222222"/>
+                </a:solidFill>
+                <a:latin typeface="Calibri"/>
+              </a:rPr>
+              <a:t>•  Se utilizó un simulador web interactivo (HTML, CSS, JavaScript y la librería Plotly.js) en lugar de solo cálculos manuales.</a:t>
+            </a:r>
+          </a:p>
+          <a:p>
+            <a:r>
+              <a:rPr sz="1800" b="0">
+                <a:solidFill>
+                  <a:srgbClr val="222222"/>
+                </a:solidFill>
+                <a:latin typeface="Calibri"/>
+              </a:rPr>
+              <a:t>•  Permite visualizar en tiempo real la curva de costo C(x) y su derivada C'(x), y modificar parámetros del modelo.</a:t>
+            </a:r>
+          </a:p>
+          <a:p>
+            <a:r>
+              <a:rPr sz="1800" b="0">
+                <a:solidFill>
+                  <a:srgbClr val="222222"/>
+                </a:solidFill>
+                <a:latin typeface="Calibri"/>
+              </a:rPr>
+              <a:t>•  Facilita comprender de forma visual el concepto de punto crítico y optimización, algo difícil de transmitir solo con álgebra.</a:t>
+            </a:r>
+          </a:p>
+          <a:p>
+            <a:r>
+              <a:rPr sz="1800" b="0">
+                <a:solidFill>
+                  <a:srgbClr val="222222"/>
+                </a:solidFill>
+                <a:latin typeface="Calibri"/>
+              </a:rPr>
+              <a:t>•  El sitio se publicó en la nube (Vercel), reforzando la coherencia entre el tema del proyecto (costos cloud) y la herramienta usada para exponerlo.</a:t>
+            </a:r>
           </a:p>
         </p:txBody>
       </p:sp>
@@ -4988,8 +5641,8 @@
         </p:nvSpPr>
         <p:spPr>
           <a:xfrm>
-            <a:off x="423081" y="1524000"/>
-            <a:ext cx="10960536" cy="923330"/>
+            <a:off x="838200" y="365125"/>
+            <a:ext cx="10515600" cy="6192875"/>
           </a:xfrm>
           <a:prstGeom prst="rect">
             <a:avLst/>
@@ -4998,272 +5651,18 @@
         </p:spPr>
         <p:txBody>
           <a:bodyPr wrap="square" rtlCol="0">
-            <a:spAutoFit/>
+            <a:noAutofit/>
           </a:bodyPr>
           <a:lstStyle/>
           <a:p>
             <a:r>
-              <a:rPr lang="es-ES" sz="1800" dirty="0">
-                <a:effectLst/>
-                <a:latin typeface="Calibri" panose="020F0502020204030204" pitchFamily="34" charset="0"/>
-                <a:ea typeface="Calibri" panose="020F0502020204030204" pitchFamily="34" charset="0"/>
-              </a:rPr>
-              <a:t>Diapositivas</a:t>
-            </a:r>
-            <a:r>
-              <a:rPr lang="es-ES" sz="1800" spc="-50" dirty="0">
-                <a:effectLst/>
-                <a:latin typeface="Calibri" panose="020F0502020204030204" pitchFamily="34" charset="0"/>
-                <a:ea typeface="Calibri" panose="020F0502020204030204" pitchFamily="34" charset="0"/>
-              </a:rPr>
-              <a:t> </a:t>
-            </a:r>
-            <a:r>
-              <a:rPr lang="es-ES" sz="1800" dirty="0">
-                <a:effectLst/>
-                <a:latin typeface="Calibri" panose="020F0502020204030204" pitchFamily="34" charset="0"/>
-                <a:ea typeface="Calibri" panose="020F0502020204030204" pitchFamily="34" charset="0"/>
-              </a:rPr>
-              <a:t>8,</a:t>
-            </a:r>
-            <a:r>
-              <a:rPr lang="es-ES" sz="1800" spc="-40" dirty="0">
-                <a:effectLst/>
-                <a:latin typeface="Calibri" panose="020F0502020204030204" pitchFamily="34" charset="0"/>
-                <a:ea typeface="Calibri" panose="020F0502020204030204" pitchFamily="34" charset="0"/>
-              </a:rPr>
-              <a:t> </a:t>
-            </a:r>
-            <a:r>
-              <a:rPr lang="es-ES" sz="1800" dirty="0">
-                <a:effectLst/>
-                <a:latin typeface="Calibri" panose="020F0502020204030204" pitchFamily="34" charset="0"/>
-                <a:ea typeface="Calibri" panose="020F0502020204030204" pitchFamily="34" charset="0"/>
-              </a:rPr>
-              <a:t>9</a:t>
-            </a:r>
-            <a:r>
-              <a:rPr lang="es-ES" sz="1800" spc="-45" dirty="0">
-                <a:effectLst/>
-                <a:latin typeface="Calibri" panose="020F0502020204030204" pitchFamily="34" charset="0"/>
-                <a:ea typeface="Calibri" panose="020F0502020204030204" pitchFamily="34" charset="0"/>
-              </a:rPr>
-              <a:t> </a:t>
-            </a:r>
-            <a:r>
-              <a:rPr lang="es-ES" sz="1800" dirty="0">
-                <a:effectLst/>
-                <a:latin typeface="Calibri" panose="020F0502020204030204" pitchFamily="34" charset="0"/>
-                <a:ea typeface="Calibri" panose="020F0502020204030204" pitchFamily="34" charset="0"/>
-              </a:rPr>
-              <a:t>y</a:t>
-            </a:r>
-            <a:r>
-              <a:rPr lang="es-ES" sz="1800" spc="-35" dirty="0">
-                <a:effectLst/>
-                <a:latin typeface="Calibri" panose="020F0502020204030204" pitchFamily="34" charset="0"/>
-                <a:ea typeface="Calibri" panose="020F0502020204030204" pitchFamily="34" charset="0"/>
-              </a:rPr>
-              <a:t> </a:t>
-            </a:r>
-            <a:r>
-              <a:rPr lang="es-ES" sz="1800" dirty="0">
-                <a:effectLst/>
-                <a:latin typeface="Calibri" panose="020F0502020204030204" pitchFamily="34" charset="0"/>
-                <a:ea typeface="Calibri" panose="020F0502020204030204" pitchFamily="34" charset="0"/>
-              </a:rPr>
-              <a:t>10:</a:t>
-            </a:r>
-            <a:r>
-              <a:rPr lang="es-ES" sz="1800" spc="-45" dirty="0">
-                <a:effectLst/>
-                <a:latin typeface="Calibri" panose="020F0502020204030204" pitchFamily="34" charset="0"/>
-                <a:ea typeface="Calibri" panose="020F0502020204030204" pitchFamily="34" charset="0"/>
-              </a:rPr>
-              <a:t> </a:t>
-            </a:r>
-            <a:r>
-              <a:rPr lang="es-ES" sz="1800" dirty="0">
-                <a:effectLst/>
-                <a:latin typeface="Calibri" panose="020F0502020204030204" pitchFamily="34" charset="0"/>
-                <a:ea typeface="Calibri" panose="020F0502020204030204" pitchFamily="34" charset="0"/>
-              </a:rPr>
-              <a:t>Resumen</a:t>
-            </a:r>
-            <a:r>
-              <a:rPr lang="es-ES" sz="1800" spc="-35" dirty="0">
-                <a:effectLst/>
-                <a:latin typeface="Calibri" panose="020F0502020204030204" pitchFamily="34" charset="0"/>
-                <a:ea typeface="Calibri" panose="020F0502020204030204" pitchFamily="34" charset="0"/>
-              </a:rPr>
-              <a:t> </a:t>
-            </a:r>
-            <a:r>
-              <a:rPr lang="es-ES" sz="1800" dirty="0">
-                <a:effectLst/>
-                <a:latin typeface="Calibri" panose="020F0502020204030204" pitchFamily="34" charset="0"/>
-                <a:ea typeface="Calibri" panose="020F0502020204030204" pitchFamily="34" charset="0"/>
-              </a:rPr>
-              <a:t>información</a:t>
-            </a:r>
-            <a:r>
-              <a:rPr lang="es-ES" sz="1800" spc="-40" dirty="0">
-                <a:effectLst/>
-                <a:latin typeface="Calibri" panose="020F0502020204030204" pitchFamily="34" charset="0"/>
-                <a:ea typeface="Calibri" panose="020F0502020204030204" pitchFamily="34" charset="0"/>
-              </a:rPr>
-              <a:t> </a:t>
-            </a:r>
-            <a:r>
-              <a:rPr lang="es-ES" sz="1800" dirty="0">
-                <a:effectLst/>
-                <a:latin typeface="Calibri" panose="020F0502020204030204" pitchFamily="34" charset="0"/>
-                <a:ea typeface="Calibri" panose="020F0502020204030204" pitchFamily="34" charset="0"/>
-              </a:rPr>
-              <a:t>de</a:t>
-            </a:r>
-            <a:r>
-              <a:rPr lang="es-ES" sz="1800" spc="-55" dirty="0">
-                <a:effectLst/>
-                <a:latin typeface="Calibri" panose="020F0502020204030204" pitchFamily="34" charset="0"/>
-                <a:ea typeface="Calibri" panose="020F0502020204030204" pitchFamily="34" charset="0"/>
-              </a:rPr>
-              <a:t> </a:t>
-            </a:r>
-            <a:r>
-              <a:rPr lang="es-ES" sz="1800" dirty="0">
-                <a:effectLst/>
-                <a:latin typeface="Calibri" panose="020F0502020204030204" pitchFamily="34" charset="0"/>
-                <a:ea typeface="Calibri" panose="020F0502020204030204" pitchFamily="34" charset="0"/>
-              </a:rPr>
-              <a:t>diversas</a:t>
-            </a:r>
-            <a:r>
-              <a:rPr lang="es-ES" sz="1800" spc="-35" dirty="0">
-                <a:effectLst/>
-                <a:latin typeface="Calibri" panose="020F0502020204030204" pitchFamily="34" charset="0"/>
-                <a:ea typeface="Calibri" panose="020F0502020204030204" pitchFamily="34" charset="0"/>
-              </a:rPr>
-              <a:t> </a:t>
-            </a:r>
-            <a:r>
-              <a:rPr lang="es-ES" sz="1800" dirty="0">
-                <a:effectLst/>
-                <a:latin typeface="Calibri" panose="020F0502020204030204" pitchFamily="34" charset="0"/>
-                <a:ea typeface="Calibri" panose="020F0502020204030204" pitchFamily="34" charset="0"/>
-              </a:rPr>
-              <a:t>fuentes</a:t>
-            </a:r>
-            <a:r>
-              <a:rPr lang="es-ES" sz="1800" spc="-40" dirty="0">
-                <a:effectLst/>
-                <a:latin typeface="Calibri" panose="020F0502020204030204" pitchFamily="34" charset="0"/>
-                <a:ea typeface="Calibri" panose="020F0502020204030204" pitchFamily="34" charset="0"/>
-              </a:rPr>
-              <a:t> </a:t>
-            </a:r>
-            <a:r>
-              <a:rPr lang="es-ES" sz="1800" dirty="0">
-                <a:effectLst/>
-                <a:latin typeface="Calibri" panose="020F0502020204030204" pitchFamily="34" charset="0"/>
-                <a:ea typeface="Calibri" panose="020F0502020204030204" pitchFamily="34" charset="0"/>
-              </a:rPr>
-              <a:t>que</a:t>
-            </a:r>
-            <a:r>
-              <a:rPr lang="es-ES" sz="1800" spc="-40" dirty="0">
-                <a:effectLst/>
-                <a:latin typeface="Calibri" panose="020F0502020204030204" pitchFamily="34" charset="0"/>
-                <a:ea typeface="Calibri" panose="020F0502020204030204" pitchFamily="34" charset="0"/>
-              </a:rPr>
-              <a:t> </a:t>
-            </a:r>
-            <a:r>
-              <a:rPr lang="es-ES" sz="1800" dirty="0">
-                <a:effectLst/>
-                <a:latin typeface="Calibri" panose="020F0502020204030204" pitchFamily="34" charset="0"/>
-                <a:ea typeface="Calibri" panose="020F0502020204030204" pitchFamily="34" charset="0"/>
-              </a:rPr>
-              <a:t>permiten</a:t>
-            </a:r>
-            <a:r>
-              <a:rPr lang="es-ES" sz="1800" spc="-40" dirty="0">
-                <a:effectLst/>
-                <a:latin typeface="Calibri" panose="020F0502020204030204" pitchFamily="34" charset="0"/>
-                <a:ea typeface="Calibri" panose="020F0502020204030204" pitchFamily="34" charset="0"/>
-              </a:rPr>
-              <a:t> </a:t>
-            </a:r>
-            <a:r>
-              <a:rPr lang="es-ES" sz="1800" dirty="0">
-                <a:effectLst/>
-                <a:latin typeface="Calibri" panose="020F0502020204030204" pitchFamily="34" charset="0"/>
-                <a:ea typeface="Calibri" panose="020F0502020204030204" pitchFamily="34" charset="0"/>
-              </a:rPr>
-              <a:t>responder</a:t>
-            </a:r>
-            <a:r>
-              <a:rPr lang="es-ES" sz="1800" spc="-40" dirty="0">
-                <a:effectLst/>
-                <a:latin typeface="Calibri" panose="020F0502020204030204" pitchFamily="34" charset="0"/>
-                <a:ea typeface="Calibri" panose="020F0502020204030204" pitchFamily="34" charset="0"/>
-              </a:rPr>
-              <a:t> </a:t>
-            </a:r>
-            <a:r>
-              <a:rPr lang="es-ES" sz="1800" dirty="0">
-                <a:effectLst/>
-                <a:latin typeface="Calibri" panose="020F0502020204030204" pitchFamily="34" charset="0"/>
-                <a:ea typeface="Calibri" panose="020F0502020204030204" pitchFamily="34" charset="0"/>
-              </a:rPr>
-              <a:t>las</a:t>
-            </a:r>
-            <a:r>
-              <a:rPr lang="es-ES" sz="1800" spc="-260" dirty="0">
-                <a:effectLst/>
-                <a:latin typeface="Calibri" panose="020F0502020204030204" pitchFamily="34" charset="0"/>
-                <a:ea typeface="Calibri" panose="020F0502020204030204" pitchFamily="34" charset="0"/>
-              </a:rPr>
-              <a:t> </a:t>
-            </a:r>
-            <a:r>
-              <a:rPr lang="es-ES" sz="1800" dirty="0">
-                <a:effectLst/>
-                <a:latin typeface="Calibri" panose="020F0502020204030204" pitchFamily="34" charset="0"/>
-                <a:ea typeface="Calibri" panose="020F0502020204030204" pitchFamily="34" charset="0"/>
-              </a:rPr>
-              <a:t>preguntas, integrando los conceptos matemáticos involucrados de </a:t>
-            </a:r>
-            <a:r>
-              <a:rPr lang="es-ES" dirty="0">
-                <a:latin typeface="Calibri" panose="020F0502020204030204" pitchFamily="34" charset="0"/>
-                <a:ea typeface="Calibri" panose="020F0502020204030204" pitchFamily="34" charset="0"/>
-              </a:rPr>
-              <a:t>todas las unidades </a:t>
-            </a:r>
-            <a:r>
-              <a:rPr lang="es-ES" sz="1800" dirty="0">
-                <a:effectLst/>
-                <a:latin typeface="Calibri" panose="020F0502020204030204" pitchFamily="34" charset="0"/>
-                <a:ea typeface="Calibri" panose="020F0502020204030204" pitchFamily="34" charset="0"/>
-              </a:rPr>
-              <a:t>u otras</a:t>
-            </a:r>
-            <a:r>
-              <a:rPr lang="es-ES" sz="1800" spc="5" dirty="0">
-                <a:effectLst/>
-                <a:latin typeface="Calibri" panose="020F0502020204030204" pitchFamily="34" charset="0"/>
-                <a:ea typeface="Calibri" panose="020F0502020204030204" pitchFamily="34" charset="0"/>
-              </a:rPr>
-              <a:t> </a:t>
-            </a:r>
-            <a:r>
-              <a:rPr lang="es-ES" sz="1800" dirty="0">
-                <a:effectLst/>
-                <a:latin typeface="Calibri" panose="020F0502020204030204" pitchFamily="34" charset="0"/>
-                <a:ea typeface="Calibri" panose="020F0502020204030204" pitchFamily="34" charset="0"/>
-              </a:rPr>
-              <a:t>nociones.</a:t>
+              <a:rPr sz="2600" b="1">
+                <a:solidFill>
+                  <a:srgbClr val="222222"/>
+                </a:solidFill>
+                <a:latin typeface="Calibri"/>
+              </a:rPr>
+              <a:t>Marco teórico I: Funciones y modelo de costo</a:t>
             </a:r>
             <a:endParaRPr lang="es-CL" sz="1800" dirty="0">
               <a:effectLst/>
@@ -5272,7 +5671,37 @@
             </a:endParaRPr>
           </a:p>
           <a:p>
-            <a:endParaRPr lang="es-CL" dirty="0"/>
+            <a:r>
+              <a:rPr sz="1800" b="0">
+                <a:solidFill>
+                  <a:srgbClr val="222222"/>
+                </a:solidFill>
+                <a:latin typeface="Calibri"/>
+              </a:rPr>
+              <a:t>•  Una función cuadrática C(x) = a·x² + (b+c)·x + d permite representar el costo total en función de la cantidad de recursos (x).</a:t>
+            </a:r>
+          </a:p>
+          <a:p>
+            <a:r>
+              <a:rPr sz="1800" b="0">
+                <a:solidFill>
+                  <a:srgbClr val="222222"/>
+                </a:solidFill>
+                <a:latin typeface="Calibri"/>
+              </a:rPr>
+              <a:t>•  El coeficiente a &gt; 0 refleja que, a partir de cierto punto, agregar más instancias aumenta el costo (sobreaprovisionamiento).</a:t>
+            </a:r>
+          </a:p>
+          <a:p>
+            <a:r>
+              <a:rPr sz="1800" b="0">
+                <a:solidFill>
+                  <a:srgbClr val="222222"/>
+                </a:solidFill>
+                <a:latin typeface="Calibri"/>
+              </a:rPr>
+              <a:t>•  Referencias: Stewart, J. (2018). Cálculo: Trascendentes tempranas; Larson, R. y Edwards, B. (2018). Cálculo.</a:t>
+            </a:r>
           </a:p>
         </p:txBody>
       </p:sp>
@@ -5320,8 +5749,8 @@
         </p:nvSpPr>
         <p:spPr>
           <a:xfrm>
-            <a:off x="662609" y="1470991"/>
-            <a:ext cx="10126762" cy="923330"/>
+            <a:off x="838200" y="365125"/>
+            <a:ext cx="10515600" cy="6192875"/>
           </a:xfrm>
           <a:prstGeom prst="rect">
             <a:avLst/>
@@ -5330,272 +5759,18 @@
         </p:spPr>
         <p:txBody>
           <a:bodyPr wrap="square" rtlCol="0">
-            <a:spAutoFit/>
+            <a:noAutofit/>
           </a:bodyPr>
           <a:lstStyle/>
           <a:p>
             <a:r>
-              <a:rPr lang="es-ES" sz="1800" dirty="0">
-                <a:effectLst/>
-                <a:latin typeface="Calibri" panose="020F0502020204030204" pitchFamily="34" charset="0"/>
-                <a:ea typeface="Calibri" panose="020F0502020204030204" pitchFamily="34" charset="0"/>
-              </a:rPr>
-              <a:t>Diapositivas</a:t>
-            </a:r>
-            <a:r>
-              <a:rPr lang="es-ES" sz="1800" spc="-50" dirty="0">
-                <a:effectLst/>
-                <a:latin typeface="Calibri" panose="020F0502020204030204" pitchFamily="34" charset="0"/>
-                <a:ea typeface="Calibri" panose="020F0502020204030204" pitchFamily="34" charset="0"/>
-              </a:rPr>
-              <a:t> </a:t>
-            </a:r>
-            <a:r>
-              <a:rPr lang="es-ES" sz="1800" dirty="0">
-                <a:effectLst/>
-                <a:latin typeface="Calibri" panose="020F0502020204030204" pitchFamily="34" charset="0"/>
-                <a:ea typeface="Calibri" panose="020F0502020204030204" pitchFamily="34" charset="0"/>
-              </a:rPr>
-              <a:t>8,</a:t>
-            </a:r>
-            <a:r>
-              <a:rPr lang="es-ES" sz="1800" spc="-40" dirty="0">
-                <a:effectLst/>
-                <a:latin typeface="Calibri" panose="020F0502020204030204" pitchFamily="34" charset="0"/>
-                <a:ea typeface="Calibri" panose="020F0502020204030204" pitchFamily="34" charset="0"/>
-              </a:rPr>
-              <a:t> </a:t>
-            </a:r>
-            <a:r>
-              <a:rPr lang="es-ES" sz="1800" dirty="0">
-                <a:effectLst/>
-                <a:latin typeface="Calibri" panose="020F0502020204030204" pitchFamily="34" charset="0"/>
-                <a:ea typeface="Calibri" panose="020F0502020204030204" pitchFamily="34" charset="0"/>
-              </a:rPr>
-              <a:t>9</a:t>
-            </a:r>
-            <a:r>
-              <a:rPr lang="es-ES" sz="1800" spc="-45" dirty="0">
-                <a:effectLst/>
-                <a:latin typeface="Calibri" panose="020F0502020204030204" pitchFamily="34" charset="0"/>
-                <a:ea typeface="Calibri" panose="020F0502020204030204" pitchFamily="34" charset="0"/>
-              </a:rPr>
-              <a:t> </a:t>
-            </a:r>
-            <a:r>
-              <a:rPr lang="es-ES" sz="1800" dirty="0">
-                <a:effectLst/>
-                <a:latin typeface="Calibri" panose="020F0502020204030204" pitchFamily="34" charset="0"/>
-                <a:ea typeface="Calibri" panose="020F0502020204030204" pitchFamily="34" charset="0"/>
-              </a:rPr>
-              <a:t>y</a:t>
-            </a:r>
-            <a:r>
-              <a:rPr lang="es-ES" sz="1800" spc="-35" dirty="0">
-                <a:effectLst/>
-                <a:latin typeface="Calibri" panose="020F0502020204030204" pitchFamily="34" charset="0"/>
-                <a:ea typeface="Calibri" panose="020F0502020204030204" pitchFamily="34" charset="0"/>
-              </a:rPr>
-              <a:t> </a:t>
-            </a:r>
-            <a:r>
-              <a:rPr lang="es-ES" sz="1800" dirty="0">
-                <a:effectLst/>
-                <a:latin typeface="Calibri" panose="020F0502020204030204" pitchFamily="34" charset="0"/>
-                <a:ea typeface="Calibri" panose="020F0502020204030204" pitchFamily="34" charset="0"/>
-              </a:rPr>
-              <a:t>10:</a:t>
-            </a:r>
-            <a:r>
-              <a:rPr lang="es-ES" sz="1800" spc="-45" dirty="0">
-                <a:effectLst/>
-                <a:latin typeface="Calibri" panose="020F0502020204030204" pitchFamily="34" charset="0"/>
-                <a:ea typeface="Calibri" panose="020F0502020204030204" pitchFamily="34" charset="0"/>
-              </a:rPr>
-              <a:t> </a:t>
-            </a:r>
-            <a:r>
-              <a:rPr lang="es-ES" sz="1800" dirty="0">
-                <a:effectLst/>
-                <a:latin typeface="Calibri" panose="020F0502020204030204" pitchFamily="34" charset="0"/>
-                <a:ea typeface="Calibri" panose="020F0502020204030204" pitchFamily="34" charset="0"/>
-              </a:rPr>
-              <a:t>Resumen</a:t>
-            </a:r>
-            <a:r>
-              <a:rPr lang="es-ES" sz="1800" spc="-35" dirty="0">
-                <a:effectLst/>
-                <a:latin typeface="Calibri" panose="020F0502020204030204" pitchFamily="34" charset="0"/>
-                <a:ea typeface="Calibri" panose="020F0502020204030204" pitchFamily="34" charset="0"/>
-              </a:rPr>
-              <a:t> </a:t>
-            </a:r>
-            <a:r>
-              <a:rPr lang="es-ES" sz="1800" dirty="0">
-                <a:effectLst/>
-                <a:latin typeface="Calibri" panose="020F0502020204030204" pitchFamily="34" charset="0"/>
-                <a:ea typeface="Calibri" panose="020F0502020204030204" pitchFamily="34" charset="0"/>
-              </a:rPr>
-              <a:t>información</a:t>
-            </a:r>
-            <a:r>
-              <a:rPr lang="es-ES" sz="1800" spc="-40" dirty="0">
-                <a:effectLst/>
-                <a:latin typeface="Calibri" panose="020F0502020204030204" pitchFamily="34" charset="0"/>
-                <a:ea typeface="Calibri" panose="020F0502020204030204" pitchFamily="34" charset="0"/>
-              </a:rPr>
-              <a:t> </a:t>
-            </a:r>
-            <a:r>
-              <a:rPr lang="es-ES" sz="1800" dirty="0">
-                <a:effectLst/>
-                <a:latin typeface="Calibri" panose="020F0502020204030204" pitchFamily="34" charset="0"/>
-                <a:ea typeface="Calibri" panose="020F0502020204030204" pitchFamily="34" charset="0"/>
-              </a:rPr>
-              <a:t>de</a:t>
-            </a:r>
-            <a:r>
-              <a:rPr lang="es-ES" sz="1800" spc="-55" dirty="0">
-                <a:effectLst/>
-                <a:latin typeface="Calibri" panose="020F0502020204030204" pitchFamily="34" charset="0"/>
-                <a:ea typeface="Calibri" panose="020F0502020204030204" pitchFamily="34" charset="0"/>
-              </a:rPr>
-              <a:t> </a:t>
-            </a:r>
-            <a:r>
-              <a:rPr lang="es-ES" sz="1800" dirty="0">
-                <a:effectLst/>
-                <a:latin typeface="Calibri" panose="020F0502020204030204" pitchFamily="34" charset="0"/>
-                <a:ea typeface="Calibri" panose="020F0502020204030204" pitchFamily="34" charset="0"/>
-              </a:rPr>
-              <a:t>diversas</a:t>
-            </a:r>
-            <a:r>
-              <a:rPr lang="es-ES" sz="1800" spc="-35" dirty="0">
-                <a:effectLst/>
-                <a:latin typeface="Calibri" panose="020F0502020204030204" pitchFamily="34" charset="0"/>
-                <a:ea typeface="Calibri" panose="020F0502020204030204" pitchFamily="34" charset="0"/>
-              </a:rPr>
-              <a:t> </a:t>
-            </a:r>
-            <a:r>
-              <a:rPr lang="es-ES" sz="1800" dirty="0">
-                <a:effectLst/>
-                <a:latin typeface="Calibri" panose="020F0502020204030204" pitchFamily="34" charset="0"/>
-                <a:ea typeface="Calibri" panose="020F0502020204030204" pitchFamily="34" charset="0"/>
-              </a:rPr>
-              <a:t>fuentes</a:t>
-            </a:r>
-            <a:r>
-              <a:rPr lang="es-ES" sz="1800" spc="-40" dirty="0">
-                <a:effectLst/>
-                <a:latin typeface="Calibri" panose="020F0502020204030204" pitchFamily="34" charset="0"/>
-                <a:ea typeface="Calibri" panose="020F0502020204030204" pitchFamily="34" charset="0"/>
-              </a:rPr>
-              <a:t> </a:t>
-            </a:r>
-            <a:r>
-              <a:rPr lang="es-ES" sz="1800" dirty="0">
-                <a:effectLst/>
-                <a:latin typeface="Calibri" panose="020F0502020204030204" pitchFamily="34" charset="0"/>
-                <a:ea typeface="Calibri" panose="020F0502020204030204" pitchFamily="34" charset="0"/>
-              </a:rPr>
-              <a:t>que</a:t>
-            </a:r>
-            <a:r>
-              <a:rPr lang="es-ES" sz="1800" spc="-40" dirty="0">
-                <a:effectLst/>
-                <a:latin typeface="Calibri" panose="020F0502020204030204" pitchFamily="34" charset="0"/>
-                <a:ea typeface="Calibri" panose="020F0502020204030204" pitchFamily="34" charset="0"/>
-              </a:rPr>
-              <a:t> </a:t>
-            </a:r>
-            <a:r>
-              <a:rPr lang="es-ES" sz="1800" dirty="0">
-                <a:effectLst/>
-                <a:latin typeface="Calibri" panose="020F0502020204030204" pitchFamily="34" charset="0"/>
-                <a:ea typeface="Calibri" panose="020F0502020204030204" pitchFamily="34" charset="0"/>
-              </a:rPr>
-              <a:t>permiten</a:t>
-            </a:r>
-            <a:r>
-              <a:rPr lang="es-ES" sz="1800" spc="-40" dirty="0">
-                <a:effectLst/>
-                <a:latin typeface="Calibri" panose="020F0502020204030204" pitchFamily="34" charset="0"/>
-                <a:ea typeface="Calibri" panose="020F0502020204030204" pitchFamily="34" charset="0"/>
-              </a:rPr>
-              <a:t> </a:t>
-            </a:r>
-            <a:r>
-              <a:rPr lang="es-ES" sz="1800" dirty="0">
-                <a:effectLst/>
-                <a:latin typeface="Calibri" panose="020F0502020204030204" pitchFamily="34" charset="0"/>
-                <a:ea typeface="Calibri" panose="020F0502020204030204" pitchFamily="34" charset="0"/>
-              </a:rPr>
-              <a:t>responder</a:t>
-            </a:r>
-            <a:r>
-              <a:rPr lang="es-ES" sz="1800" spc="-40" dirty="0">
-                <a:effectLst/>
-                <a:latin typeface="Calibri" panose="020F0502020204030204" pitchFamily="34" charset="0"/>
-                <a:ea typeface="Calibri" panose="020F0502020204030204" pitchFamily="34" charset="0"/>
-              </a:rPr>
-              <a:t> </a:t>
-            </a:r>
-            <a:r>
-              <a:rPr lang="es-ES" sz="1800" dirty="0">
-                <a:effectLst/>
-                <a:latin typeface="Calibri" panose="020F0502020204030204" pitchFamily="34" charset="0"/>
-                <a:ea typeface="Calibri" panose="020F0502020204030204" pitchFamily="34" charset="0"/>
-              </a:rPr>
-              <a:t>las</a:t>
-            </a:r>
-            <a:r>
-              <a:rPr lang="es-ES" sz="1800" spc="-260" dirty="0">
-                <a:effectLst/>
-                <a:latin typeface="Calibri" panose="020F0502020204030204" pitchFamily="34" charset="0"/>
-                <a:ea typeface="Calibri" panose="020F0502020204030204" pitchFamily="34" charset="0"/>
-              </a:rPr>
-              <a:t> </a:t>
-            </a:r>
-            <a:r>
-              <a:rPr lang="es-ES" sz="1800" dirty="0">
-                <a:effectLst/>
-                <a:latin typeface="Calibri" panose="020F0502020204030204" pitchFamily="34" charset="0"/>
-                <a:ea typeface="Calibri" panose="020F0502020204030204" pitchFamily="34" charset="0"/>
-              </a:rPr>
-              <a:t>preguntas, integrando los conceptos matemáticos involucrados </a:t>
-            </a:r>
-            <a:r>
-              <a:rPr lang="es-ES" dirty="0">
-                <a:latin typeface="Calibri" panose="020F0502020204030204" pitchFamily="34" charset="0"/>
-                <a:ea typeface="Calibri" panose="020F0502020204030204" pitchFamily="34" charset="0"/>
-              </a:rPr>
-              <a:t>todas las unidades </a:t>
-            </a:r>
-            <a:r>
-              <a:rPr lang="es-ES" sz="1800" dirty="0">
-                <a:effectLst/>
-                <a:latin typeface="Calibri" panose="020F0502020204030204" pitchFamily="34" charset="0"/>
-                <a:ea typeface="Calibri" panose="020F0502020204030204" pitchFamily="34" charset="0"/>
-              </a:rPr>
-              <a:t>u otras</a:t>
-            </a:r>
-            <a:r>
-              <a:rPr lang="es-ES" sz="1800" spc="5" dirty="0">
-                <a:effectLst/>
-                <a:latin typeface="Calibri" panose="020F0502020204030204" pitchFamily="34" charset="0"/>
-                <a:ea typeface="Calibri" panose="020F0502020204030204" pitchFamily="34" charset="0"/>
-              </a:rPr>
-              <a:t> </a:t>
-            </a:r>
-            <a:r>
-              <a:rPr lang="es-ES" sz="1800" dirty="0">
-                <a:effectLst/>
-                <a:latin typeface="Calibri" panose="020F0502020204030204" pitchFamily="34" charset="0"/>
-                <a:ea typeface="Calibri" panose="020F0502020204030204" pitchFamily="34" charset="0"/>
-              </a:rPr>
-              <a:t>nociones.</a:t>
+              <a:rPr sz="2600" b="1">
+                <a:solidFill>
+                  <a:srgbClr val="222222"/>
+                </a:solidFill>
+                <a:latin typeface="Calibri"/>
+              </a:rPr>
+              <a:t>Marco teórico II: Derivada y optimización</a:t>
             </a:r>
             <a:endParaRPr lang="es-CL" sz="1800" dirty="0">
               <a:effectLst/>
@@ -5604,7 +5779,48 @@
             </a:endParaRPr>
           </a:p>
           <a:p>
-            <a:endParaRPr lang="es-CL" dirty="0"/>
+            <a:r>
+              <a:rPr sz="1800" b="0">
+                <a:solidFill>
+                  <a:srgbClr val="222222"/>
+                </a:solidFill>
+                <a:latin typeface="Calibri"/>
+              </a:rPr>
+              <a:t>•  La derivada C'(x) representa la tasa de cambio del costo respecto al número de instancias (costo marginal).</a:t>
+            </a:r>
+          </a:p>
+          <a:p>
+            <a:r>
+              <a:rPr sz="1800" b="0">
+                <a:solidFill>
+                  <a:srgbClr val="222222"/>
+                </a:solidFill>
+                <a:latin typeface="Calibri"/>
+              </a:rPr>
+              <a:t>•  Un punto crítico se obtiene resolviendo C'(x) = 0.</a:t>
+            </a:r>
+          </a:p>
+          <a:p>
+            <a:r>
+              <a:rPr sz="1800" b="0">
+                <a:solidFill>
+                  <a:srgbClr val="222222"/>
+                </a:solidFill>
+                <a:latin typeface="Calibri"/>
+              </a:rPr>
+              <a:t>•  El criterio de la segunda derivada (C''(x) &gt; 0) confirma si ese punto corresponde a un mínimo.</a:t>
+            </a:r>
+          </a:p>
+          <a:p>
+            <a:r>
+              <a:rPr sz="1800" b="0">
+                <a:solidFill>
+                  <a:srgbClr val="222222"/>
+                </a:solidFill>
+                <a:latin typeface="Calibri"/>
+              </a:rPr>
+              <a:t>•  Estos conceptos corresponden a las unidades de límites, derivadas y aplicaciones de la derivada del curso.</a:t>
+            </a:r>
           </a:p>
         </p:txBody>
       </p:sp>

</xml_diff>

<commit_message>
Rediseno visual del PPT: paleta oscura del sitio (cian/violeta/teal), vinetas reales de PowerPoint en vez de texto '*', barra de acento y cronograma con fechas reales
</commit_message>
<xml_diff>
--- a/Presentación Proyecto.pptx
+++ b/Presentación Proyecto.pptx
@@ -3346,6 +3346,14 @@
 <file path=ppt/slides/slide1.xml><?xml version="1.0" encoding="utf-8"?>
 <p:sld xmlns:a="http://schemas.openxmlformats.org/drawingml/2006/main" xmlns:r="http://schemas.openxmlformats.org/officeDocument/2006/relationships" xmlns:p="http://schemas.openxmlformats.org/presentationml/2006/main">
   <p:cSld>
+    <p:bg>
+      <p:bgPr>
+        <a:solidFill>
+          <a:srgbClr val="050611"/>
+        </a:solidFill>
+        <a:effectLst/>
+      </p:bgPr>
+    </p:bg>
     <p:spTree>
       <p:nvGrpSpPr>
         <p:cNvPr id="1" name=""/>
@@ -3383,11 +3391,16 @@
           </a:bodyPr>
           <a:lstStyle/>
           <a:p>
-            <a:pPr algn="ctr"/>
+            <a:pPr algn="ctr">
+              <a:spcAft>
+                <a:spcPts val="1400"/>
+              </a:spcAft>
+              <a:buNone/>
+            </a:pPr>
             <a:r>
               <a:rPr sz="3400" b="1">
                 <a:solidFill>
-                  <a:srgbClr val="222222"/>
+                  <a:srgbClr val="22D3EE"/>
                 </a:solidFill>
                 <a:latin typeface="Calibri"/>
               </a:rPr>
@@ -3419,11 +3432,16 @@
           </a:bodyPr>
           <a:lstStyle/>
           <a:p>
-            <a:pPr algn="ctr"/>
+            <a:pPr algn="ctr">
+              <a:spcAft>
+                <a:spcPts val="400"/>
+              </a:spcAft>
+              <a:buNone/>
+            </a:pPr>
             <a:r>
               <a:rPr sz="2000">
                 <a:solidFill>
-                  <a:srgbClr val="555555"/>
+                  <a:srgbClr val="94A3B8"/>
                 </a:solidFill>
                 <a:latin typeface="Calibri"/>
               </a:rPr>
@@ -3431,11 +3449,16 @@
             </a:r>
           </a:p>
           <a:p>
-            <a:pPr algn="ctr"/>
+            <a:pPr algn="ctr">
+              <a:spcAft>
+                <a:spcPts val="400"/>
+              </a:spcAft>
+              <a:buNone/>
+            </a:pPr>
             <a:r>
               <a:rPr sz="2000">
                 <a:solidFill>
-                  <a:srgbClr val="555555"/>
+                  <a:srgbClr val="94A3B8"/>
                 </a:solidFill>
                 <a:latin typeface="Calibri"/>
               </a:rPr>
@@ -3443,11 +3466,16 @@
             </a:r>
           </a:p>
           <a:p>
-            <a:pPr algn="ctr"/>
+            <a:pPr algn="ctr">
+              <a:spcAft>
+                <a:spcPts val="400"/>
+              </a:spcAft>
+              <a:buNone/>
+            </a:pPr>
             <a:r>
               <a:rPr sz="2000">
                 <a:solidFill>
-                  <a:srgbClr val="555555"/>
+                  <a:srgbClr val="94A3B8"/>
                 </a:solidFill>
                 <a:latin typeface="Calibri"/>
               </a:rPr>
@@ -3455,16 +3483,73 @@
             </a:r>
           </a:p>
           <a:p>
-            <a:pPr algn="ctr"/>
+            <a:pPr algn="ctr">
+              <a:spcAft>
+                <a:spcPts val="400"/>
+              </a:spcAft>
+              <a:buNone/>
+            </a:pPr>
             <a:r>
               <a:rPr sz="2000">
                 <a:solidFill>
-                  <a:srgbClr val="555555"/>
+                  <a:srgbClr val="94A3B8"/>
                 </a:solidFill>
                 <a:latin typeface="Calibri"/>
               </a:rPr>
               <a:t>Carrera: Ingeniería en Informática</a:t>
             </a:r>
+          </a:p>
+        </p:txBody>
+      </p:sp>
+      <p:sp>
+        <p:nvSpPr>
+          <p:cNvPr id="4" name="Rectangle 3"/>
+          <p:cNvSpPr/>
+          <p:nvPr/>
+        </p:nvSpPr>
+        <p:spPr>
+          <a:xfrm>
+            <a:off x="0" y="0"/>
+            <a:ext cx="12192000" cy="45720"/>
+          </a:xfrm>
+          <a:prstGeom prst="rect">
+            <a:avLst/>
+          </a:prstGeom>
+          <a:gradFill rotWithShape="1">
+            <a:gsLst>
+              <a:gs pos="0">
+                <a:srgbClr val="22D3EE"/>
+              </a:gs>
+              <a:gs pos="100000">
+                <a:srgbClr val="A855F7"/>
+              </a:gs>
+            </a:gsLst>
+            <a:lin scaled="0" ang="0"/>
+          </a:gradFill>
+          <a:ln>
+            <a:noFill/>
+          </a:ln>
+          <a:effectLst/>
+        </p:spPr>
+        <p:style>
+          <a:lnRef idx="1">
+            <a:schemeClr val="accent1"/>
+          </a:lnRef>
+          <a:fillRef idx="3">
+            <a:schemeClr val="accent1"/>
+          </a:fillRef>
+          <a:effectRef idx="2">
+            <a:schemeClr val="accent1"/>
+          </a:effectRef>
+          <a:fontRef idx="minor">
+            <a:schemeClr val="lt1"/>
+          </a:fontRef>
+        </p:style>
+        <p:txBody>
+          <a:bodyPr rtlCol="0" anchor="ctr"/>
+          <a:lstStyle/>
+          <a:p>
+            <a:pPr algn="ctr"/>
           </a:p>
         </p:txBody>
       </p:sp>
@@ -3484,6 +3569,14 @@
 <file path=ppt/slides/slide10.xml><?xml version="1.0" encoding="utf-8"?>
 <p:sld xmlns:a="http://schemas.openxmlformats.org/drawingml/2006/main" xmlns:r="http://schemas.openxmlformats.org/officeDocument/2006/relationships" xmlns:p="http://schemas.openxmlformats.org/presentationml/2006/main">
   <p:cSld>
+    <p:bg>
+      <p:bgPr>
+        <a:solidFill>
+          <a:srgbClr val="050611"/>
+        </a:solidFill>
+        <a:effectLst/>
+      </p:bgPr>
+    </p:bg>
     <p:spTree>
       <p:nvGrpSpPr>
         <p:cNvPr id="1" name=""/>
@@ -3526,10 +3619,16 @@
           </a:bodyPr>
           <a:lstStyle/>
           <a:p>
+            <a:pPr>
+              <a:spcAft>
+                <a:spcPts val="1400"/>
+              </a:spcAft>
+              <a:buNone/>
+            </a:pPr>
             <a:r>
               <a:rPr sz="2600" b="1">
                 <a:solidFill>
-                  <a:srgbClr val="222222"/>
+                  <a:srgbClr val="22D3EE"/>
                 </a:solidFill>
                 <a:latin typeface="Calibri"/>
               </a:rPr>
@@ -3542,37 +3641,131 @@
             </a:endParaRPr>
           </a:p>
           <a:p>
-            <a:r>
-              <a:rPr sz="1800" b="0">
-                <a:solidFill>
-                  <a:srgbClr val="222222"/>
+            <a:pPr indent="-228600" marL="228600">
+              <a:lnSpc>
+                <a:spcPct val="115000"/>
+              </a:lnSpc>
+              <a:spcAft>
+                <a:spcPts val="600"/>
+              </a:spcAft>
+              <a:buClr>
+                <a:srgbClr val="5EEAD4"/>
+              </a:buClr>
+              <a:buSzPct val="80000"/>
+              <a:buFont typeface="Arial"/>
+              <a:buChar char="▪"/>
+            </a:pPr>
+            <a:r>
+              <a:rPr sz="1800">
+                <a:solidFill>
+                  <a:srgbClr val="E6EBF5"/>
                 </a:solidFill>
                 <a:latin typeface="Calibri"/>
               </a:rPr>
-              <a:t>•  Los proveedores cloud (AWS, Azure, Vercel) cobran según los recursos utilizados (instancias, cómputo, almacenamiento).</a:t>
-            </a:r>
-          </a:p>
-          <a:p>
-            <a:r>
-              <a:rPr sz="1800" b="0">
-                <a:solidFill>
-                  <a:srgbClr val="222222"/>
+              <a:t>Los proveedores cloud (AWS, Azure, Vercel) cobran según los recursos utilizados (instancias, cómputo, almacenamiento).</a:t>
+            </a:r>
+          </a:p>
+          <a:p>
+            <a:pPr indent="-228600" marL="228600">
+              <a:lnSpc>
+                <a:spcPct val="115000"/>
+              </a:lnSpc>
+              <a:spcAft>
+                <a:spcPts val="600"/>
+              </a:spcAft>
+              <a:buClr>
+                <a:srgbClr val="5EEAD4"/>
+              </a:buClr>
+              <a:buSzPct val="80000"/>
+              <a:buFont typeface="Arial"/>
+              <a:buChar char="▪"/>
+            </a:pPr>
+            <a:r>
+              <a:rPr sz="1800">
+                <a:solidFill>
+                  <a:srgbClr val="E6EBF5"/>
                 </a:solidFill>
                 <a:latin typeface="Calibri"/>
               </a:rPr>
-              <a:t>•  Un mal dimensionamiento de recursos es un problema real de la industria: sobrecostos o baja disponibilidad del servicio.</a:t>
-            </a:r>
-          </a:p>
-          <a:p>
-            <a:r>
-              <a:rPr sz="1800" b="0">
-                <a:solidFill>
-                  <a:srgbClr val="222222"/>
+              <a:t>Un mal dimensionamiento de recursos es un problema real de la industria: sobrecostos o baja disponibilidad del servicio.</a:t>
+            </a:r>
+          </a:p>
+          <a:p>
+            <a:pPr indent="-228600" marL="228600">
+              <a:lnSpc>
+                <a:spcPct val="115000"/>
+              </a:lnSpc>
+              <a:spcAft>
+                <a:spcPts val="600"/>
+              </a:spcAft>
+              <a:buClr>
+                <a:srgbClr val="5EEAD4"/>
+              </a:buClr>
+              <a:buSzPct val="80000"/>
+              <a:buFont typeface="Arial"/>
+              <a:buChar char="▪"/>
+            </a:pPr>
+            <a:r>
+              <a:rPr sz="1800">
+                <a:solidFill>
+                  <a:srgbClr val="E6EBF5"/>
                 </a:solidFill>
                 <a:latin typeface="Calibri"/>
               </a:rPr>
-              <a:t>•  Fuentes: documentación de precios de AWS y Azure, y buenas prácticas de "cost optimization" en la nube.</a:t>
-            </a:r>
+              <a:t>Fuentes: documentación de precios de AWS y Azure, y buenas prácticas de "cost optimization" en la nube.</a:t>
+            </a:r>
+          </a:p>
+        </p:txBody>
+      </p:sp>
+      <p:sp>
+        <p:nvSpPr>
+          <p:cNvPr id="5" name="Rectangle 4"/>
+          <p:cNvSpPr/>
+          <p:nvPr/>
+        </p:nvSpPr>
+        <p:spPr>
+          <a:xfrm>
+            <a:off x="0" y="0"/>
+            <a:ext cx="12192000" cy="45720"/>
+          </a:xfrm>
+          <a:prstGeom prst="rect">
+            <a:avLst/>
+          </a:prstGeom>
+          <a:gradFill rotWithShape="1">
+            <a:gsLst>
+              <a:gs pos="0">
+                <a:srgbClr val="22D3EE"/>
+              </a:gs>
+              <a:gs pos="100000">
+                <a:srgbClr val="A855F7"/>
+              </a:gs>
+            </a:gsLst>
+            <a:lin scaled="0" ang="0"/>
+          </a:gradFill>
+          <a:ln>
+            <a:noFill/>
+          </a:ln>
+          <a:effectLst/>
+        </p:spPr>
+        <p:style>
+          <a:lnRef idx="1">
+            <a:schemeClr val="accent1"/>
+          </a:lnRef>
+          <a:fillRef idx="3">
+            <a:schemeClr val="accent1"/>
+          </a:fillRef>
+          <a:effectRef idx="2">
+            <a:schemeClr val="accent1"/>
+          </a:effectRef>
+          <a:fontRef idx="minor">
+            <a:schemeClr val="lt1"/>
+          </a:fontRef>
+        </p:style>
+        <p:txBody>
+          <a:bodyPr rtlCol="0" anchor="ctr"/>
+          <a:lstStyle/>
+          <a:p>
+            <a:pPr algn="ctr"/>
           </a:p>
         </p:txBody>
       </p:sp>
@@ -3592,6 +3785,14 @@
 <file path=ppt/slides/slide11.xml><?xml version="1.0" encoding="utf-8"?>
 <p:sld xmlns:a="http://schemas.openxmlformats.org/drawingml/2006/main" xmlns:r="http://schemas.openxmlformats.org/officeDocument/2006/relationships" xmlns:p="http://schemas.openxmlformats.org/presentationml/2006/main">
   <p:cSld>
+    <p:bg>
+      <p:bgPr>
+        <a:solidFill>
+          <a:srgbClr val="050611"/>
+        </a:solidFill>
+        <a:effectLst/>
+      </p:bgPr>
+    </p:bg>
     <p:spTree>
       <p:nvGrpSpPr>
         <p:cNvPr id="1" name=""/>
@@ -3634,10 +3835,16 @@
           </a:bodyPr>
           <a:lstStyle/>
           <a:p>
+            <a:pPr>
+              <a:spcAft>
+                <a:spcPts val="1400"/>
+              </a:spcAft>
+              <a:buNone/>
+            </a:pPr>
             <a:r>
               <a:rPr sz="2600" b="1">
                 <a:solidFill>
-                  <a:srgbClr val="222222"/>
+                  <a:srgbClr val="22D3EE"/>
                 </a:solidFill>
                 <a:latin typeface="Calibri"/>
               </a:rPr>
@@ -3646,48 +3853,156 @@
             <a:endParaRPr lang="es-CL" dirty="0"/>
           </a:p>
           <a:p>
-            <a:r>
-              <a:rPr sz="1800" b="0">
-                <a:solidFill>
-                  <a:srgbClr val="222222"/>
+            <a:pPr indent="-228600" marL="228600">
+              <a:lnSpc>
+                <a:spcPct val="115000"/>
+              </a:lnSpc>
+              <a:spcAft>
+                <a:spcPts val="600"/>
+              </a:spcAft>
+              <a:buClr>
+                <a:srgbClr val="5EEAD4"/>
+              </a:buClr>
+              <a:buSzPct val="80000"/>
+              <a:buFont typeface="Arial"/>
+              <a:buChar char="▪"/>
+            </a:pPr>
+            <a:r>
+              <a:rPr sz="1800">
+                <a:solidFill>
+                  <a:srgbClr val="E6EBF5"/>
                 </a:solidFill>
                 <a:latin typeface="Calibri"/>
               </a:rPr>
-              <a:t>•  Se evaluaron distintos modelos de costo (lineal y cuadrático), optando por un modelo cuadrático simplificado que resume infraestructura + operación.</a:t>
-            </a:r>
-          </a:p>
-          <a:p>
-            <a:r>
-              <a:rPr sz="1800" b="0">
-                <a:solidFill>
-                  <a:srgbClr val="222222"/>
+              <a:t>Se evaluaron distintos modelos de costo (lineal y cuadrático), optando por un modelo cuadrático simplificado que resume infraestructura + operación.</a:t>
+            </a:r>
+          </a:p>
+          <a:p>
+            <a:pPr indent="-228600" marL="228600">
+              <a:lnSpc>
+                <a:spcPct val="115000"/>
+              </a:lnSpc>
+              <a:spcAft>
+                <a:spcPts val="600"/>
+              </a:spcAft>
+              <a:buClr>
+                <a:srgbClr val="5EEAD4"/>
+              </a:buClr>
+              <a:buSzPct val="80000"/>
+              <a:buFont typeface="Arial"/>
+              <a:buChar char="▪"/>
+            </a:pPr>
+            <a:r>
+              <a:rPr sz="1800">
+                <a:solidFill>
+                  <a:srgbClr val="E6EBF5"/>
                 </a:solidFill>
                 <a:latin typeface="Calibri"/>
               </a:rPr>
-              <a:t>•  Se derivó el modelo, se resolvió C'(x) = 0 y se verificó el mínimo con la segunda derivada.</a:t>
-            </a:r>
-          </a:p>
-          <a:p>
-            <a:r>
-              <a:rPr sz="1800" b="0">
-                <a:solidFill>
-                  <a:srgbClr val="222222"/>
+              <a:t>Se derivó el modelo, se resolvió C'(x) = 0 y se verificó el mínimo con la segunda derivada.</a:t>
+            </a:r>
+          </a:p>
+          <a:p>
+            <a:pPr indent="-228600" marL="228600">
+              <a:lnSpc>
+                <a:spcPct val="115000"/>
+              </a:lnSpc>
+              <a:spcAft>
+                <a:spcPts val="600"/>
+              </a:spcAft>
+              <a:buClr>
+                <a:srgbClr val="5EEAD4"/>
+              </a:buClr>
+              <a:buSzPct val="80000"/>
+              <a:buFont typeface="Arial"/>
+              <a:buChar char="▪"/>
+            </a:pPr>
+            <a:r>
+              <a:rPr sz="1800">
+                <a:solidFill>
+                  <a:srgbClr val="E6EBF5"/>
                 </a:solidFill>
                 <a:latin typeface="Calibri"/>
               </a:rPr>
-              <a:t>•  Se decidió comunicar el resultado mediante un producto tecnológico -un sitio web con simulador interactivo- en vez de solo un informe estático.</a:t>
-            </a:r>
-          </a:p>
-          <a:p>
-            <a:r>
-              <a:rPr sz="1800" b="0">
-                <a:solidFill>
-                  <a:srgbClr val="222222"/>
+              <a:t>Se decidió comunicar el resultado mediante un producto tecnológico -un sitio web con simulador interactivo- en vez de solo un informe estático.</a:t>
+            </a:r>
+          </a:p>
+          <a:p>
+            <a:pPr indent="-228600" marL="228600">
+              <a:lnSpc>
+                <a:spcPct val="115000"/>
+              </a:lnSpc>
+              <a:spcAft>
+                <a:spcPts val="600"/>
+              </a:spcAft>
+              <a:buClr>
+                <a:srgbClr val="5EEAD4"/>
+              </a:buClr>
+              <a:buSzPct val="80000"/>
+              <a:buFont typeface="Arial"/>
+              <a:buChar char="▪"/>
+            </a:pPr>
+            <a:r>
+              <a:rPr sz="1800">
+                <a:solidFill>
+                  <a:srgbClr val="E6EBF5"/>
                 </a:solidFill>
                 <a:latin typeface="Calibri"/>
               </a:rPr>
-              <a:t>•  El simulador permite ingresar distintos parámetros (a, b+c, d) y observar cómo cambia el punto óptimo.</a:t>
-            </a:r>
+              <a:t>El simulador permite ingresar distintos parámetros (a, b+c, d) y observar cómo cambia el punto óptimo.</a:t>
+            </a:r>
+          </a:p>
+        </p:txBody>
+      </p:sp>
+      <p:sp>
+        <p:nvSpPr>
+          <p:cNvPr id="5" name="Rectangle 4"/>
+          <p:cNvSpPr/>
+          <p:nvPr/>
+        </p:nvSpPr>
+        <p:spPr>
+          <a:xfrm>
+            <a:off x="0" y="0"/>
+            <a:ext cx="12192000" cy="45720"/>
+          </a:xfrm>
+          <a:prstGeom prst="rect">
+            <a:avLst/>
+          </a:prstGeom>
+          <a:gradFill rotWithShape="1">
+            <a:gsLst>
+              <a:gs pos="0">
+                <a:srgbClr val="22D3EE"/>
+              </a:gs>
+              <a:gs pos="100000">
+                <a:srgbClr val="A855F7"/>
+              </a:gs>
+            </a:gsLst>
+            <a:lin scaled="0" ang="0"/>
+          </a:gradFill>
+          <a:ln>
+            <a:noFill/>
+          </a:ln>
+          <a:effectLst/>
+        </p:spPr>
+        <p:style>
+          <a:lnRef idx="1">
+            <a:schemeClr val="accent1"/>
+          </a:lnRef>
+          <a:fillRef idx="3">
+            <a:schemeClr val="accent1"/>
+          </a:fillRef>
+          <a:effectRef idx="2">
+            <a:schemeClr val="accent1"/>
+          </a:effectRef>
+          <a:fontRef idx="minor">
+            <a:schemeClr val="lt1"/>
+          </a:fontRef>
+        </p:style>
+        <p:txBody>
+          <a:bodyPr rtlCol="0" anchor="ctr"/>
+          <a:lstStyle/>
+          <a:p>
+            <a:pPr algn="ctr"/>
           </a:p>
         </p:txBody>
       </p:sp>
@@ -3707,6 +4022,14 @@
 <file path=ppt/slides/slide12.xml><?xml version="1.0" encoding="utf-8"?>
 <p:sld xmlns:a="http://schemas.openxmlformats.org/drawingml/2006/main" xmlns:r="http://schemas.openxmlformats.org/officeDocument/2006/relationships" xmlns:p="http://schemas.openxmlformats.org/presentationml/2006/main">
   <p:cSld>
+    <p:bg>
+      <p:bgPr>
+        <a:solidFill>
+          <a:srgbClr val="050611"/>
+        </a:solidFill>
+        <a:effectLst/>
+      </p:bgPr>
+    </p:bg>
     <p:spTree>
       <p:nvGrpSpPr>
         <p:cNvPr id="1" name=""/>
@@ -3749,11 +4072,16 @@
           </a:bodyPr>
           <a:lstStyle/>
           <a:p>
-            <a:pPr marR="31115"/>
+            <a:pPr marR="31115">
+              <a:spcAft>
+                <a:spcPts val="1400"/>
+              </a:spcAft>
+              <a:buNone/>
+            </a:pPr>
             <a:r>
               <a:rPr sz="2400" b="1">
                 <a:solidFill>
-                  <a:srgbClr val="222222"/>
+                  <a:srgbClr val="22D3EE"/>
                 </a:solidFill>
                 <a:latin typeface="Calibri"/>
               </a:rPr>
@@ -3789,19 +4117,27 @@
           </a:bodyPr>
           <a:lstStyle/>
           <a:p>
+            <a:pPr>
+              <a:spcAft>
+                <a:spcPts val="400"/>
+              </a:spcAft>
+              <a:buNone/>
+            </a:pPr>
             <a:r>
               <a:rPr sz="1400">
                 <a:solidFill>
-                  <a:srgbClr val="333333"/>
-                </a:solidFill>
+                  <a:srgbClr val="E6EBF5"/>
+                </a:solidFill>
+                <a:latin typeface="Calibri"/>
               </a:rPr>
               <a:t>Sitio web del proyecto (incluye simulador interactivo): </a:t>
             </a:r>
             <a:r>
               <a:rPr sz="1400" b="1">
                 <a:solidFill>
-                  <a:srgbClr val="2263EB"/>
-                </a:solidFill>
+                  <a:srgbClr val="A855F7"/>
+                </a:solidFill>
+                <a:latin typeface="Calibri"/>
                 <a:hlinkClick r:id="rId2"/>
               </a:rPr>
               <a:t>https://proyecto-calculo-optimizacion-cloud.vercel.app</a:t>
@@ -3832,37 +4168,131 @@
           <a:lstStyle/>
           <a:p/>
           <a:p>
-            <a:r>
-              <a:rPr sz="1800" b="0">
-                <a:solidFill>
-                  <a:srgbClr val="222222"/>
+            <a:pPr indent="-228600" marL="228600">
+              <a:lnSpc>
+                <a:spcPct val="115000"/>
+              </a:lnSpc>
+              <a:spcAft>
+                <a:spcPts val="600"/>
+              </a:spcAft>
+              <a:buClr>
+                <a:srgbClr val="5EEAD4"/>
+              </a:buClr>
+              <a:buSzPct val="80000"/>
+              <a:buFont typeface="Arial"/>
+              <a:buChar char="▪"/>
+            </a:pPr>
+            <a:r>
+              <a:rPr sz="1800">
+                <a:solidFill>
+                  <a:srgbClr val="E6EBF5"/>
                 </a:solidFill>
                 <a:latin typeface="Calibri"/>
               </a:rPr>
-              <a:t>•  Producto: sitio web (HTML, CSS, JavaScript) con un simulador interactivo construido con Plotly.js.</a:t>
-            </a:r>
-          </a:p>
-          <a:p>
-            <a:r>
-              <a:rPr sz="1800" b="0">
-                <a:solidFill>
-                  <a:srgbClr val="222222"/>
+              <a:t>Producto: sitio web (HTML, CSS, JavaScript) con un simulador interactivo construido con Plotly.js.</a:t>
+            </a:r>
+          </a:p>
+          <a:p>
+            <a:pPr indent="-228600" marL="228600">
+              <a:lnSpc>
+                <a:spcPct val="115000"/>
+              </a:lnSpc>
+              <a:spcAft>
+                <a:spcPts val="600"/>
+              </a:spcAft>
+              <a:buClr>
+                <a:srgbClr val="5EEAD4"/>
+              </a:buClr>
+              <a:buSzPct val="80000"/>
+              <a:buFont typeface="Arial"/>
+              <a:buChar char="▪"/>
+            </a:pPr>
+            <a:r>
+              <a:rPr sz="1800">
+                <a:solidFill>
+                  <a:srgbClr val="E6EBF5"/>
                 </a:solidFill>
                 <a:latin typeface="Calibri"/>
               </a:rPr>
-              <a:t>•  Grafica en tiempo real la función de costo C(x) y su derivada C'(x), marcando el punto donde C'(x) = 0.</a:t>
-            </a:r>
-          </a:p>
-          <a:p>
-            <a:r>
-              <a:rPr sz="1800" b="0">
-                <a:solidFill>
-                  <a:srgbClr val="222222"/>
+              <a:t>Grafica en tiempo real la función de costo C(x) y su derivada C'(x), marcando el punto donde C'(x) = 0.</a:t>
+            </a:r>
+          </a:p>
+          <a:p>
+            <a:pPr indent="-228600" marL="228600">
+              <a:lnSpc>
+                <a:spcPct val="115000"/>
+              </a:lnSpc>
+              <a:spcAft>
+                <a:spcPts val="600"/>
+              </a:spcAft>
+              <a:buClr>
+                <a:srgbClr val="5EEAD4"/>
+              </a:buClr>
+              <a:buSzPct val="80000"/>
+              <a:buFont typeface="Arial"/>
+              <a:buChar char="▪"/>
+            </a:pPr>
+            <a:r>
+              <a:rPr sz="1800">
+                <a:solidFill>
+                  <a:srgbClr val="E6EBF5"/>
                 </a:solidFill>
                 <a:latin typeface="Calibri"/>
               </a:rPr>
-              <a:t>•  Publicado en la nube mediante Vercel, con despliegue continuo desde GitHub.</a:t>
-            </a:r>
+              <a:t>Publicado en la nube mediante Vercel, con despliegue continuo desde GitHub.</a:t>
+            </a:r>
+          </a:p>
+        </p:txBody>
+      </p:sp>
+      <p:sp>
+        <p:nvSpPr>
+          <p:cNvPr id="7" name="Rectangle 6"/>
+          <p:cNvSpPr/>
+          <p:nvPr/>
+        </p:nvSpPr>
+        <p:spPr>
+          <a:xfrm>
+            <a:off x="0" y="0"/>
+            <a:ext cx="12192000" cy="45720"/>
+          </a:xfrm>
+          <a:prstGeom prst="rect">
+            <a:avLst/>
+          </a:prstGeom>
+          <a:gradFill rotWithShape="1">
+            <a:gsLst>
+              <a:gs pos="0">
+                <a:srgbClr val="22D3EE"/>
+              </a:gs>
+              <a:gs pos="100000">
+                <a:srgbClr val="A855F7"/>
+              </a:gs>
+            </a:gsLst>
+            <a:lin scaled="0" ang="0"/>
+          </a:gradFill>
+          <a:ln>
+            <a:noFill/>
+          </a:ln>
+          <a:effectLst/>
+        </p:spPr>
+        <p:style>
+          <a:lnRef idx="1">
+            <a:schemeClr val="accent1"/>
+          </a:lnRef>
+          <a:fillRef idx="3">
+            <a:schemeClr val="accent1"/>
+          </a:fillRef>
+          <a:effectRef idx="2">
+            <a:schemeClr val="accent1"/>
+          </a:effectRef>
+          <a:fontRef idx="minor">
+            <a:schemeClr val="lt1"/>
+          </a:fontRef>
+        </p:style>
+        <p:txBody>
+          <a:bodyPr rtlCol="0" anchor="ctr"/>
+          <a:lstStyle/>
+          <a:p>
+            <a:pPr algn="ctr"/>
           </a:p>
         </p:txBody>
       </p:sp>
@@ -3882,6 +4312,14 @@
 <file path=ppt/slides/slide13.xml><?xml version="1.0" encoding="utf-8"?>
 <p:sld xmlns:a="http://schemas.openxmlformats.org/drawingml/2006/main" xmlns:r="http://schemas.openxmlformats.org/officeDocument/2006/relationships" xmlns:p="http://schemas.openxmlformats.org/presentationml/2006/main">
   <p:cSld>
+    <p:bg>
+      <p:bgPr>
+        <a:solidFill>
+          <a:srgbClr val="050611"/>
+        </a:solidFill>
+        <a:effectLst/>
+      </p:bgPr>
+    </p:bg>
     <p:spTree>
       <p:nvGrpSpPr>
         <p:cNvPr id="1" name=""/>
@@ -3924,11 +4362,16 @@
           </a:bodyPr>
           <a:lstStyle/>
           <a:p>
-            <a:pPr marR="31115"/>
+            <a:pPr marR="31115">
+              <a:spcAft>
+                <a:spcPts val="1400"/>
+              </a:spcAft>
+              <a:buNone/>
+            </a:pPr>
             <a:r>
               <a:rPr sz="2600" b="1">
                 <a:solidFill>
-                  <a:srgbClr val="222222"/>
+                  <a:srgbClr val="22D3EE"/>
                 </a:solidFill>
                 <a:latin typeface="Calibri"/>
               </a:rPr>
@@ -3941,70 +4384,139 @@
             </a:endParaRPr>
           </a:p>
           <a:p>
-            <a:r>
-              <a:rPr sz="1800" b="1">
-                <a:solidFill>
-                  <a:srgbClr val="222222"/>
-                </a:solidFill>
-                <a:latin typeface="Calibri"/>
-              </a:rPr>
-              <a:t>Resultados:</a:t>
-            </a:r>
-          </a:p>
-          <a:p>
-            <a:r>
-              <a:rPr sz="1800" b="0">
-                <a:solidFill>
-                  <a:srgbClr val="222222"/>
-                </a:solidFill>
-                <a:latin typeface="Calibri"/>
-              </a:rPr>
-              <a:t>•  Modelo: C(x) = 0.5x² − 20x + 500  ;  C'(x) = x − 20</a:t>
-            </a:r>
-          </a:p>
-          <a:p>
-            <a:r>
-              <a:rPr sz="1800" b="0">
-                <a:solidFill>
-                  <a:srgbClr val="222222"/>
-                </a:solidFill>
-                <a:latin typeface="Calibri"/>
-              </a:rPr>
-              <a:t>•  Punto crítico: x = 20  ;  C''(x) = 1 &gt; 0 → mínimo</a:t>
-            </a:r>
-          </a:p>
-          <a:p>
-            <a:r>
-              <a:rPr sz="1800" b="0">
-                <a:solidFill>
-                  <a:srgbClr val="222222"/>
-                </a:solidFill>
-                <a:latin typeface="Calibri"/>
-              </a:rPr>
-              <a:t>•  Costo mínimo: C(20) = 300 USD/mes</a:t>
-            </a:r>
-          </a:p>
-          <a:p>
-            <a:r>
-              <a:rPr sz="1800" b="0">
-                <a:solidFill>
-                  <a:srgbClr val="222222"/>
-                </a:solidFill>
-                <a:latin typeface="Calibri"/>
-              </a:rPr>
-              <a:t>•  Comparación: 5 instancias → 412,5 USD ; 20 instancias (óptimo) → 300 USD ; 35 instancias → 412,5 USD (ahorro ≈ 27%)</a:t>
-            </a:r>
-          </a:p>
-          <a:p>
             <a:pPr>
               <a:spcBef>
                 <a:spcPts val="1000"/>
               </a:spcBef>
+              <a:spcAft>
+                <a:spcPts val="400"/>
+              </a:spcAft>
+              <a:buNone/>
             </a:pPr>
             <a:r>
               <a:rPr sz="1800" b="1">
                 <a:solidFill>
-                  <a:srgbClr val="222222"/>
+                  <a:srgbClr val="A855F7"/>
+                </a:solidFill>
+                <a:latin typeface="Calibri"/>
+              </a:rPr>
+              <a:t>Resultados:</a:t>
+            </a:r>
+          </a:p>
+          <a:p>
+            <a:pPr indent="-228600" marL="228600">
+              <a:lnSpc>
+                <a:spcPct val="115000"/>
+              </a:lnSpc>
+              <a:spcAft>
+                <a:spcPts val="600"/>
+              </a:spcAft>
+              <a:buClr>
+                <a:srgbClr val="5EEAD4"/>
+              </a:buClr>
+              <a:buSzPct val="80000"/>
+              <a:buFont typeface="Arial"/>
+              <a:buChar char="▪"/>
+            </a:pPr>
+            <a:r>
+              <a:rPr sz="1800">
+                <a:solidFill>
+                  <a:srgbClr val="E6EBF5"/>
+                </a:solidFill>
+                <a:latin typeface="Calibri"/>
+              </a:rPr>
+              <a:t>Modelo: C(x) = 0.5x² − 20x + 500  ;  C'(x) = x − 20</a:t>
+            </a:r>
+          </a:p>
+          <a:p>
+            <a:pPr indent="-228600" marL="228600">
+              <a:lnSpc>
+                <a:spcPct val="115000"/>
+              </a:lnSpc>
+              <a:spcAft>
+                <a:spcPts val="600"/>
+              </a:spcAft>
+              <a:buClr>
+                <a:srgbClr val="5EEAD4"/>
+              </a:buClr>
+              <a:buSzPct val="80000"/>
+              <a:buFont typeface="Arial"/>
+              <a:buChar char="▪"/>
+            </a:pPr>
+            <a:r>
+              <a:rPr sz="1800">
+                <a:solidFill>
+                  <a:srgbClr val="E6EBF5"/>
+                </a:solidFill>
+                <a:latin typeface="Calibri"/>
+              </a:rPr>
+              <a:t>Punto crítico: x = 20  ;  C''(x) = 1 &gt; 0 → mínimo</a:t>
+            </a:r>
+          </a:p>
+          <a:p>
+            <a:pPr indent="-228600" marL="228600">
+              <a:lnSpc>
+                <a:spcPct val="115000"/>
+              </a:lnSpc>
+              <a:spcAft>
+                <a:spcPts val="600"/>
+              </a:spcAft>
+              <a:buClr>
+                <a:srgbClr val="5EEAD4"/>
+              </a:buClr>
+              <a:buSzPct val="80000"/>
+              <a:buFont typeface="Arial"/>
+              <a:buChar char="▪"/>
+            </a:pPr>
+            <a:r>
+              <a:rPr sz="1800">
+                <a:solidFill>
+                  <a:srgbClr val="E6EBF5"/>
+                </a:solidFill>
+                <a:latin typeface="Calibri"/>
+              </a:rPr>
+              <a:t>Costo mínimo: C(20) = 300 USD/mes</a:t>
+            </a:r>
+          </a:p>
+          <a:p>
+            <a:pPr indent="-228600" marL="228600">
+              <a:lnSpc>
+                <a:spcPct val="115000"/>
+              </a:lnSpc>
+              <a:spcAft>
+                <a:spcPts val="600"/>
+              </a:spcAft>
+              <a:buClr>
+                <a:srgbClr val="5EEAD4"/>
+              </a:buClr>
+              <a:buSzPct val="80000"/>
+              <a:buFont typeface="Arial"/>
+              <a:buChar char="▪"/>
+            </a:pPr>
+            <a:r>
+              <a:rPr sz="1800">
+                <a:solidFill>
+                  <a:srgbClr val="E6EBF5"/>
+                </a:solidFill>
+                <a:latin typeface="Calibri"/>
+              </a:rPr>
+              <a:t>Comparación: 5 instancias → 412,5 USD ; 20 instancias (óptimo) → 300 USD ; 35 instancias → 412,5 USD (ahorro ≈ 27%)</a:t>
+            </a:r>
+          </a:p>
+          <a:p>
+            <a:pPr>
+              <a:spcBef>
+                <a:spcPts val="1000"/>
+              </a:spcBef>
+              <a:spcAft>
+                <a:spcPts val="400"/>
+              </a:spcAft>
+              <a:buNone/>
+            </a:pPr>
+            <a:r>
+              <a:rPr sz="1800" b="1">
+                <a:solidFill>
+                  <a:srgbClr val="A855F7"/>
                 </a:solidFill>
                 <a:latin typeface="Calibri"/>
               </a:rPr>
@@ -4012,15 +4524,81 @@
             </a:r>
           </a:p>
           <a:p>
-            <a:r>
-              <a:rPr sz="1800" b="0">
-                <a:solidFill>
-                  <a:srgbClr val="222222"/>
+            <a:pPr indent="-228600" marL="228600">
+              <a:lnSpc>
+                <a:spcPct val="115000"/>
+              </a:lnSpc>
+              <a:spcAft>
+                <a:spcPts val="600"/>
+              </a:spcAft>
+              <a:buClr>
+                <a:srgbClr val="5EEAD4"/>
+              </a:buClr>
+              <a:buSzPct val="80000"/>
+              <a:buFont typeface="Arial"/>
+              <a:buChar char="▪"/>
+            </a:pPr>
+            <a:r>
+              <a:rPr sz="1800">
+                <a:solidFill>
+                  <a:srgbClr val="E6EBF5"/>
                 </a:solidFill>
                 <a:latin typeface="Calibri"/>
               </a:rPr>
-              <a:t>•  La derivada permite tomar decisiones de arquitectura de software basadas en evidencia matemática, y no en estimaciones arbitrarias.</a:t>
-            </a:r>
+              <a:t>La derivada permite tomar decisiones de arquitectura de software basadas en evidencia matemática, y no en estimaciones arbitrarias.</a:t>
+            </a:r>
+          </a:p>
+        </p:txBody>
+      </p:sp>
+      <p:sp>
+        <p:nvSpPr>
+          <p:cNvPr id="5" name="Rectangle 4"/>
+          <p:cNvSpPr/>
+          <p:nvPr/>
+        </p:nvSpPr>
+        <p:spPr>
+          <a:xfrm>
+            <a:off x="0" y="0"/>
+            <a:ext cx="12192000" cy="45720"/>
+          </a:xfrm>
+          <a:prstGeom prst="rect">
+            <a:avLst/>
+          </a:prstGeom>
+          <a:gradFill rotWithShape="1">
+            <a:gsLst>
+              <a:gs pos="0">
+                <a:srgbClr val="22D3EE"/>
+              </a:gs>
+              <a:gs pos="100000">
+                <a:srgbClr val="A855F7"/>
+              </a:gs>
+            </a:gsLst>
+            <a:lin scaled="0" ang="0"/>
+          </a:gradFill>
+          <a:ln>
+            <a:noFill/>
+          </a:ln>
+          <a:effectLst/>
+        </p:spPr>
+        <p:style>
+          <a:lnRef idx="1">
+            <a:schemeClr val="accent1"/>
+          </a:lnRef>
+          <a:fillRef idx="3">
+            <a:schemeClr val="accent1"/>
+          </a:fillRef>
+          <a:effectRef idx="2">
+            <a:schemeClr val="accent1"/>
+          </a:effectRef>
+          <a:fontRef idx="minor">
+            <a:schemeClr val="lt1"/>
+          </a:fontRef>
+        </p:style>
+        <p:txBody>
+          <a:bodyPr rtlCol="0" anchor="ctr"/>
+          <a:lstStyle/>
+          <a:p>
+            <a:pPr algn="ctr"/>
           </a:p>
         </p:txBody>
       </p:sp>
@@ -4040,6 +4618,14 @@
 <file path=ppt/slides/slide14.xml><?xml version="1.0" encoding="utf-8"?>
 <p:sld xmlns:a="http://schemas.openxmlformats.org/drawingml/2006/main" xmlns:r="http://schemas.openxmlformats.org/officeDocument/2006/relationships" xmlns:p="http://schemas.openxmlformats.org/presentationml/2006/main">
   <p:cSld>
+    <p:bg>
+      <p:bgPr>
+        <a:solidFill>
+          <a:srgbClr val="050611"/>
+        </a:solidFill>
+        <a:effectLst/>
+      </p:bgPr>
+    </p:bg>
     <p:spTree>
       <p:nvGrpSpPr>
         <p:cNvPr id="1" name=""/>
@@ -4086,11 +4672,15 @@
               <a:lnSpc>
                 <a:spcPts val="1465"/>
               </a:lnSpc>
+              <a:spcAft>
+                <a:spcPts val="1400"/>
+              </a:spcAft>
+              <a:buNone/>
             </a:pPr>
             <a:r>
               <a:rPr sz="2600" b="1">
                 <a:solidFill>
-                  <a:srgbClr val="222222"/>
+                  <a:srgbClr val="22D3EE"/>
                 </a:solidFill>
                 <a:latin typeface="Calibri"/>
               </a:rPr>
@@ -4103,70 +4693,206 @@
             </a:endParaRPr>
           </a:p>
           <a:p>
-            <a:r>
-              <a:rPr sz="1600" b="0">
-                <a:solidFill>
-                  <a:srgbClr val="222222"/>
+            <a:pPr indent="-228600" marL="228600">
+              <a:lnSpc>
+                <a:spcPct val="115000"/>
+              </a:lnSpc>
+              <a:spcAft>
+                <a:spcPts val="600"/>
+              </a:spcAft>
+              <a:buClr>
+                <a:srgbClr val="5EEAD4"/>
+              </a:buClr>
+              <a:buSzPct val="80000"/>
+              <a:buFont typeface="Arial"/>
+              <a:buChar char="▪"/>
+            </a:pPr>
+            <a:r>
+              <a:rPr sz="1600">
+                <a:solidFill>
+                  <a:srgbClr val="E6EBF5"/>
                 </a:solidFill>
                 <a:latin typeface="Calibri"/>
               </a:rPr>
-              <a:t>•  Stewart, J. (2018). Cálculo de una variable: Trascendentes tempranas (8ª ed.). Cengage Learning.</a:t>
-            </a:r>
-          </a:p>
-          <a:p>
-            <a:r>
-              <a:rPr sz="1600" b="0">
-                <a:solidFill>
-                  <a:srgbClr val="222222"/>
+              <a:t>Stewart, J. (2018). Cálculo de una variable: Trascendentes tempranas (8ª ed.). Cengage Learning.</a:t>
+            </a:r>
+          </a:p>
+          <a:p>
+            <a:pPr indent="-228600" marL="228600">
+              <a:lnSpc>
+                <a:spcPct val="115000"/>
+              </a:lnSpc>
+              <a:spcAft>
+                <a:spcPts val="600"/>
+              </a:spcAft>
+              <a:buClr>
+                <a:srgbClr val="5EEAD4"/>
+              </a:buClr>
+              <a:buSzPct val="80000"/>
+              <a:buFont typeface="Arial"/>
+              <a:buChar char="▪"/>
+            </a:pPr>
+            <a:r>
+              <a:rPr sz="1600">
+                <a:solidFill>
+                  <a:srgbClr val="E6EBF5"/>
                 </a:solidFill>
                 <a:latin typeface="Calibri"/>
               </a:rPr>
-              <a:t>•  Larson, R., &amp; Edwards, B. (2018). Cálculo (10ª ed.). McGraw-Hill.</a:t>
-            </a:r>
-          </a:p>
-          <a:p>
-            <a:r>
-              <a:rPr sz="1600" b="0">
-                <a:solidFill>
-                  <a:srgbClr val="222222"/>
+              <a:t>Larson, R., &amp; Edwards, B. (2018). Cálculo (10ª ed.). McGraw-Hill.</a:t>
+            </a:r>
+          </a:p>
+          <a:p>
+            <a:pPr indent="-228600" marL="228600">
+              <a:lnSpc>
+                <a:spcPct val="115000"/>
+              </a:lnSpc>
+              <a:spcAft>
+                <a:spcPts val="600"/>
+              </a:spcAft>
+              <a:buClr>
+                <a:srgbClr val="5EEAD4"/>
+              </a:buClr>
+              <a:buSzPct val="80000"/>
+              <a:buFont typeface="Arial"/>
+              <a:buChar char="▪"/>
+            </a:pPr>
+            <a:r>
+              <a:rPr sz="1600">
+                <a:solidFill>
+                  <a:srgbClr val="E6EBF5"/>
                 </a:solidFill>
                 <a:latin typeface="Calibri"/>
               </a:rPr>
-              <a:t>•  Amazon Web Services. (2024). Cloud economics and pricing. https://aws.amazon.com/economics/</a:t>
-            </a:r>
-          </a:p>
-          <a:p>
-            <a:r>
-              <a:rPr sz="1600" b="0">
-                <a:solidFill>
-                  <a:srgbClr val="222222"/>
+              <a:t>Amazon Web Services. (2024). Cloud economics and pricing. https://aws.amazon.com/economics/</a:t>
+            </a:r>
+          </a:p>
+          <a:p>
+            <a:pPr indent="-228600" marL="228600">
+              <a:lnSpc>
+                <a:spcPct val="115000"/>
+              </a:lnSpc>
+              <a:spcAft>
+                <a:spcPts val="600"/>
+              </a:spcAft>
+              <a:buClr>
+                <a:srgbClr val="5EEAD4"/>
+              </a:buClr>
+              <a:buSzPct val="80000"/>
+              <a:buFont typeface="Arial"/>
+              <a:buChar char="▪"/>
+            </a:pPr>
+            <a:r>
+              <a:rPr sz="1600">
+                <a:solidFill>
+                  <a:srgbClr val="E6EBF5"/>
                 </a:solidFill>
                 <a:latin typeface="Calibri"/>
               </a:rPr>
-              <a:t>•  Microsoft Azure. (2024). Pricing calculator y documentación de cost management. https://azure.microsoft.com/pricing/</a:t>
-            </a:r>
-          </a:p>
-          <a:p>
-            <a:r>
-              <a:rPr sz="1600" b="0">
-                <a:solidFill>
-                  <a:srgbClr val="222222"/>
+              <a:t>Microsoft Azure. (2024). Pricing calculator y documentación de cost management. https://azure.microsoft.com/pricing/</a:t>
+            </a:r>
+          </a:p>
+          <a:p>
+            <a:pPr indent="-228600" marL="228600">
+              <a:lnSpc>
+                <a:spcPct val="115000"/>
+              </a:lnSpc>
+              <a:spcAft>
+                <a:spcPts val="600"/>
+              </a:spcAft>
+              <a:buClr>
+                <a:srgbClr val="5EEAD4"/>
+              </a:buClr>
+              <a:buSzPct val="80000"/>
+              <a:buFont typeface="Arial"/>
+              <a:buChar char="▪"/>
+            </a:pPr>
+            <a:r>
+              <a:rPr sz="1600">
+                <a:solidFill>
+                  <a:srgbClr val="E6EBF5"/>
                 </a:solidFill>
                 <a:latin typeface="Calibri"/>
               </a:rPr>
-              <a:t>•  Vercel Inc. (2024). Vercel pricing documentation. https://vercel.com/pricing</a:t>
-            </a:r>
-          </a:p>
-          <a:p>
-            <a:r>
-              <a:rPr sz="1600" b="0">
-                <a:solidFill>
-                  <a:srgbClr val="222222"/>
+              <a:t>Vercel Inc. (2024). Vercel pricing documentation. https://vercel.com/pricing</a:t>
+            </a:r>
+          </a:p>
+          <a:p>
+            <a:pPr indent="-228600" marL="228600">
+              <a:lnSpc>
+                <a:spcPct val="115000"/>
+              </a:lnSpc>
+              <a:spcAft>
+                <a:spcPts val="600"/>
+              </a:spcAft>
+              <a:buClr>
+                <a:srgbClr val="5EEAD4"/>
+              </a:buClr>
+              <a:buSzPct val="80000"/>
+              <a:buFont typeface="Arial"/>
+              <a:buChar char="▪"/>
+            </a:pPr>
+            <a:r>
+              <a:rPr sz="1600">
+                <a:solidFill>
+                  <a:srgbClr val="E6EBF5"/>
                 </a:solidFill>
                 <a:latin typeface="Calibri"/>
               </a:rPr>
-              <a:t>•  Sitio del proyecto: https://proyecto-calculo-optimizacion-cloud.vercel.app</a:t>
-            </a:r>
+              <a:t>Sitio del proyecto: https://proyecto-calculo-optimizacion-cloud.vercel.app</a:t>
+            </a:r>
+          </a:p>
+        </p:txBody>
+      </p:sp>
+      <p:sp>
+        <p:nvSpPr>
+          <p:cNvPr id="5" name="Rectangle 4"/>
+          <p:cNvSpPr/>
+          <p:nvPr/>
+        </p:nvSpPr>
+        <p:spPr>
+          <a:xfrm>
+            <a:off x="0" y="0"/>
+            <a:ext cx="12192000" cy="45720"/>
+          </a:xfrm>
+          <a:prstGeom prst="rect">
+            <a:avLst/>
+          </a:prstGeom>
+          <a:gradFill rotWithShape="1">
+            <a:gsLst>
+              <a:gs pos="0">
+                <a:srgbClr val="22D3EE"/>
+              </a:gs>
+              <a:gs pos="100000">
+                <a:srgbClr val="A855F7"/>
+              </a:gs>
+            </a:gsLst>
+            <a:lin scaled="0" ang="0"/>
+          </a:gradFill>
+          <a:ln>
+            <a:noFill/>
+          </a:ln>
+          <a:effectLst/>
+        </p:spPr>
+        <p:style>
+          <a:lnRef idx="1">
+            <a:schemeClr val="accent1"/>
+          </a:lnRef>
+          <a:fillRef idx="3">
+            <a:schemeClr val="accent1"/>
+          </a:fillRef>
+          <a:effectRef idx="2">
+            <a:schemeClr val="accent1"/>
+          </a:effectRef>
+          <a:fontRef idx="minor">
+            <a:schemeClr val="lt1"/>
+          </a:fontRef>
+        </p:style>
+        <p:txBody>
+          <a:bodyPr rtlCol="0" anchor="ctr"/>
+          <a:lstStyle/>
+          <a:p>
+            <a:pPr algn="ctr"/>
           </a:p>
         </p:txBody>
       </p:sp>
@@ -4186,6 +4912,14 @@
 <file path=ppt/slides/slide2.xml><?xml version="1.0" encoding="utf-8"?>
 <p:sld xmlns:a="http://schemas.openxmlformats.org/drawingml/2006/main" xmlns:r="http://schemas.openxmlformats.org/officeDocument/2006/relationships" xmlns:p="http://schemas.openxmlformats.org/presentationml/2006/main">
   <p:cSld>
+    <p:bg>
+      <p:bgPr>
+        <a:solidFill>
+          <a:srgbClr val="050611"/>
+        </a:solidFill>
+        <a:effectLst/>
+      </p:bgPr>
+    </p:bg>
     <p:spTree>
       <p:nvGrpSpPr>
         <p:cNvPr id="1" name=""/>
@@ -4228,10 +4962,16 @@
           </a:bodyPr>
           <a:lstStyle/>
           <a:p>
+            <a:pPr>
+              <a:spcAft>
+                <a:spcPts val="1400"/>
+              </a:spcAft>
+              <a:buNone/>
+            </a:pPr>
             <a:r>
               <a:rPr sz="2600" b="1">
                 <a:solidFill>
-                  <a:srgbClr val="222222"/>
+                  <a:srgbClr val="22D3EE"/>
                 </a:solidFill>
                 <a:latin typeface="Calibri"/>
               </a:rPr>
@@ -4240,48 +4980,156 @@
             <a:endParaRPr lang="es-CL" dirty="0"/>
           </a:p>
           <a:p>
-            <a:r>
-              <a:rPr sz="1800" b="0">
-                <a:solidFill>
-                  <a:srgbClr val="222222"/>
+            <a:pPr indent="-228600" marL="228600">
+              <a:lnSpc>
+                <a:spcPct val="115000"/>
+              </a:lnSpc>
+              <a:spcAft>
+                <a:spcPts val="600"/>
+              </a:spcAft>
+              <a:buClr>
+                <a:srgbClr val="5EEAD4"/>
+              </a:buClr>
+              <a:buSzPct val="80000"/>
+              <a:buFont typeface="Arial"/>
+              <a:buChar char="▪"/>
+            </a:pPr>
+            <a:r>
+              <a:rPr sz="1800">
+                <a:solidFill>
+                  <a:srgbClr val="E6EBF5"/>
                 </a:solidFill>
                 <a:latin typeface="Calibri"/>
               </a:rPr>
-              <a:t>•  Proyecto de Aprendizaje Basado en Proyectos (ABPro) que aplica la derivada a un problema real de ingeniería de software.</a:t>
-            </a:r>
-          </a:p>
-          <a:p>
-            <a:r>
-              <a:rPr sz="1800" b="0">
-                <a:solidFill>
-                  <a:srgbClr val="222222"/>
+              <a:t>Proyecto de Aprendizaje Basado en Proyectos (ABPro) que aplica la derivada a un problema real de ingeniería de software.</a:t>
+            </a:r>
+          </a:p>
+          <a:p>
+            <a:pPr indent="-228600" marL="228600">
+              <a:lnSpc>
+                <a:spcPct val="115000"/>
+              </a:lnSpc>
+              <a:spcAft>
+                <a:spcPts val="600"/>
+              </a:spcAft>
+              <a:buClr>
+                <a:srgbClr val="5EEAD4"/>
+              </a:buClr>
+              <a:buSzPct val="80000"/>
+              <a:buFont typeface="Arial"/>
+              <a:buChar char="▪"/>
+            </a:pPr>
+            <a:r>
+              <a:rPr sz="1800">
+                <a:solidFill>
+                  <a:srgbClr val="E6EBF5"/>
                 </a:solidFill>
                 <a:latin typeface="Calibri"/>
               </a:rPr>
-              <a:t>•  Consiste en modelar el costo mensual de alojamiento en la nube en función del número de instancias contratadas.</a:t>
-            </a:r>
-          </a:p>
-          <a:p>
-            <a:r>
-              <a:rPr sz="1800" b="0">
-                <a:solidFill>
-                  <a:srgbClr val="222222"/>
+              <a:t>Consiste en modelar el costo mensual de alojamiento en la nube en función del número de instancias contratadas.</a:t>
+            </a:r>
+          </a:p>
+          <a:p>
+            <a:pPr indent="-228600" marL="228600">
+              <a:lnSpc>
+                <a:spcPct val="115000"/>
+              </a:lnSpc>
+              <a:spcAft>
+                <a:spcPts val="600"/>
+              </a:spcAft>
+              <a:buClr>
+                <a:srgbClr val="5EEAD4"/>
+              </a:buClr>
+              <a:buSzPct val="80000"/>
+              <a:buFont typeface="Arial"/>
+              <a:buChar char="▪"/>
+            </a:pPr>
+            <a:r>
+              <a:rPr sz="1800">
+                <a:solidFill>
+                  <a:srgbClr val="E6EBF5"/>
                 </a:solidFill>
                 <a:latin typeface="Calibri"/>
               </a:rPr>
-              <a:t>•  Mediante la derivada de esa función se determina el punto exacto donde el costo es mínimo.</a:t>
-            </a:r>
-          </a:p>
-          <a:p>
-            <a:r>
-              <a:rPr sz="1800" b="0">
-                <a:solidFill>
-                  <a:srgbClr val="222222"/>
+              <a:t>Mediante la derivada de esa función se determina el punto exacto donde el costo es mínimo.</a:t>
+            </a:r>
+          </a:p>
+          <a:p>
+            <a:pPr indent="-228600" marL="228600">
+              <a:lnSpc>
+                <a:spcPct val="115000"/>
+              </a:lnSpc>
+              <a:spcAft>
+                <a:spcPts val="600"/>
+              </a:spcAft>
+              <a:buClr>
+                <a:srgbClr val="5EEAD4"/>
+              </a:buClr>
+              <a:buSzPct val="80000"/>
+              <a:buFont typeface="Arial"/>
+              <a:buChar char="▪"/>
+            </a:pPr>
+            <a:r>
+              <a:rPr sz="1800">
+                <a:solidFill>
+                  <a:srgbClr val="E6EBF5"/>
                 </a:solidFill>
                 <a:latin typeface="Calibri"/>
               </a:rPr>
-              <a:t>•  El resultado se comunica a través de un sitio web con un simulador interactivo.</a:t>
-            </a:r>
+              <a:t>El resultado se comunica a través de un sitio web con un simulador interactivo.</a:t>
+            </a:r>
+          </a:p>
+        </p:txBody>
+      </p:sp>
+      <p:sp>
+        <p:nvSpPr>
+          <p:cNvPr id="3" name="Rectangle 2"/>
+          <p:cNvSpPr/>
+          <p:nvPr/>
+        </p:nvSpPr>
+        <p:spPr>
+          <a:xfrm>
+            <a:off x="0" y="0"/>
+            <a:ext cx="12192000" cy="45720"/>
+          </a:xfrm>
+          <a:prstGeom prst="rect">
+            <a:avLst/>
+          </a:prstGeom>
+          <a:gradFill rotWithShape="1">
+            <a:gsLst>
+              <a:gs pos="0">
+                <a:srgbClr val="22D3EE"/>
+              </a:gs>
+              <a:gs pos="100000">
+                <a:srgbClr val="A855F7"/>
+              </a:gs>
+            </a:gsLst>
+            <a:lin scaled="0" ang="0"/>
+          </a:gradFill>
+          <a:ln>
+            <a:noFill/>
+          </a:ln>
+          <a:effectLst/>
+        </p:spPr>
+        <p:style>
+          <a:lnRef idx="1">
+            <a:schemeClr val="accent1"/>
+          </a:lnRef>
+          <a:fillRef idx="3">
+            <a:schemeClr val="accent1"/>
+          </a:fillRef>
+          <a:effectRef idx="2">
+            <a:schemeClr val="accent1"/>
+          </a:effectRef>
+          <a:fontRef idx="minor">
+            <a:schemeClr val="lt1"/>
+          </a:fontRef>
+        </p:style>
+        <p:txBody>
+          <a:bodyPr rtlCol="0" anchor="ctr"/>
+          <a:lstStyle/>
+          <a:p>
+            <a:pPr algn="ctr"/>
           </a:p>
         </p:txBody>
       </p:sp>
@@ -4301,6 +5149,14 @@
 <file path=ppt/slides/slide3.xml><?xml version="1.0" encoding="utf-8"?>
 <p:sld xmlns:a="http://schemas.openxmlformats.org/drawingml/2006/main" xmlns:r="http://schemas.openxmlformats.org/officeDocument/2006/relationships" xmlns:p="http://schemas.openxmlformats.org/presentationml/2006/main">
   <p:cSld>
+    <p:bg>
+      <p:bgPr>
+        <a:solidFill>
+          <a:srgbClr val="050611"/>
+        </a:solidFill>
+        <a:effectLst/>
+      </p:bgPr>
+    </p:bg>
     <p:spTree>
       <p:nvGrpSpPr>
         <p:cNvPr id="1" name=""/>
@@ -4343,64 +5199,66 @@
           </a:bodyPr>
           <a:lstStyle/>
           <a:p>
+            <a:pPr>
+              <a:spcAft>
+                <a:spcPts val="1400"/>
+              </a:spcAft>
+              <a:buNone/>
+            </a:pPr>
             <a:r>
               <a:rPr sz="2600" b="1">
                 <a:solidFill>
-                  <a:srgbClr val="222222"/>
+                  <a:srgbClr val="22D3EE"/>
                 </a:solidFill>
                 <a:latin typeface="Calibri"/>
               </a:rPr>
               <a:t>Tema, nociones matemáticas y problemática</a:t>
             </a:r>
             <a:endParaRPr lang="es-CL" dirty="0"/>
-          </a:p>
-          <a:p>
-            <a:r>
-              <a:rPr sz="1800" b="1">
-                <a:solidFill>
-                  <a:srgbClr val="222222"/>
-                </a:solidFill>
-                <a:latin typeface="Calibri"/>
-              </a:rPr>
-              <a:t>Tema:</a:t>
-            </a:r>
-          </a:p>
-          <a:p>
-            <a:r>
-              <a:rPr sz="1800" b="0">
-                <a:solidFill>
-                  <a:srgbClr val="222222"/>
-                </a:solidFill>
-                <a:latin typeface="Calibri"/>
-              </a:rPr>
-              <a:t>•  Optimización de costos de infraestructura cloud mediante cálculo diferencial.</a:t>
-            </a:r>
           </a:p>
           <a:p>
             <a:pPr>
               <a:spcBef>
                 <a:spcPts val="1000"/>
               </a:spcBef>
+              <a:spcAft>
+                <a:spcPts val="400"/>
+              </a:spcAft>
+              <a:buNone/>
             </a:pPr>
             <a:r>
               <a:rPr sz="1800" b="1">
                 <a:solidFill>
-                  <a:srgbClr val="222222"/>
+                  <a:srgbClr val="A855F7"/>
                 </a:solidFill>
                 <a:latin typeface="Calibri"/>
               </a:rPr>
-              <a:t>Nociones matemáticas:</a:t>
-            </a:r>
-          </a:p>
-          <a:p>
-            <a:r>
-              <a:rPr sz="1800" b="0">
-                <a:solidFill>
-                  <a:srgbClr val="222222"/>
+              <a:t>Tema:</a:t>
+            </a:r>
+          </a:p>
+          <a:p>
+            <a:pPr indent="-228600" marL="228600">
+              <a:lnSpc>
+                <a:spcPct val="115000"/>
+              </a:lnSpc>
+              <a:spcAft>
+                <a:spcPts val="600"/>
+              </a:spcAft>
+              <a:buClr>
+                <a:srgbClr val="5EEAD4"/>
+              </a:buClr>
+              <a:buSzPct val="80000"/>
+              <a:buFont typeface="Arial"/>
+              <a:buChar char="▪"/>
+            </a:pPr>
+            <a:r>
+              <a:rPr sz="1800">
+                <a:solidFill>
+                  <a:srgbClr val="E6EBF5"/>
                 </a:solidFill>
                 <a:latin typeface="Calibri"/>
               </a:rPr>
-              <a:t>•  Funciones cuadráticas, derivada, puntos críticos y criterio de la segunda derivada.</a:t>
+              <a:t>Optimización de costos de infraestructura cloud mediante cálculo diferencial.</a:t>
             </a:r>
           </a:p>
           <a:p>
@@ -4408,11 +5266,60 @@
               <a:spcBef>
                 <a:spcPts val="1000"/>
               </a:spcBef>
+              <a:spcAft>
+                <a:spcPts val="400"/>
+              </a:spcAft>
+              <a:buNone/>
             </a:pPr>
             <a:r>
               <a:rPr sz="1800" b="1">
                 <a:solidFill>
-                  <a:srgbClr val="222222"/>
+                  <a:srgbClr val="A855F7"/>
+                </a:solidFill>
+                <a:latin typeface="Calibri"/>
+              </a:rPr>
+              <a:t>Nociones matemáticas:</a:t>
+            </a:r>
+          </a:p>
+          <a:p>
+            <a:pPr indent="-228600" marL="228600">
+              <a:lnSpc>
+                <a:spcPct val="115000"/>
+              </a:lnSpc>
+              <a:spcAft>
+                <a:spcPts val="600"/>
+              </a:spcAft>
+              <a:buClr>
+                <a:srgbClr val="5EEAD4"/>
+              </a:buClr>
+              <a:buSzPct val="80000"/>
+              <a:buFont typeface="Arial"/>
+              <a:buChar char="▪"/>
+            </a:pPr>
+            <a:r>
+              <a:rPr sz="1800">
+                <a:solidFill>
+                  <a:srgbClr val="E6EBF5"/>
+                </a:solidFill>
+                <a:latin typeface="Calibri"/>
+              </a:rPr>
+              <a:t>Funciones cuadráticas, derivada, puntos críticos y criterio de la segunda derivada.</a:t>
+            </a:r>
+          </a:p>
+          <a:p>
+            <a:pPr>
+              <a:spcBef>
+                <a:spcPts val="1000"/>
+              </a:spcBef>
+              <a:spcAft>
+                <a:spcPts val="400"/>
+              </a:spcAft>
+              <a:buNone/>
+            </a:pPr>
+            <a:r>
+              <a:rPr sz="1800" b="1">
+                <a:solidFill>
+                  <a:srgbClr val="A855F7"/>
                 </a:solidFill>
                 <a:latin typeface="Calibri"/>
               </a:rPr>
@@ -4420,26 +5327,106 @@
             </a:r>
           </a:p>
           <a:p>
-            <a:r>
-              <a:rPr sz="1800" b="0">
-                <a:solidFill>
-                  <a:srgbClr val="222222"/>
+            <a:pPr indent="-228600" marL="228600">
+              <a:lnSpc>
+                <a:spcPct val="115000"/>
+              </a:lnSpc>
+              <a:spcAft>
+                <a:spcPts val="600"/>
+              </a:spcAft>
+              <a:buClr>
+                <a:srgbClr val="5EEAD4"/>
+              </a:buClr>
+              <a:buSzPct val="80000"/>
+              <a:buFont typeface="Arial"/>
+              <a:buChar char="▪"/>
+            </a:pPr>
+            <a:r>
+              <a:rPr sz="1800">
+                <a:solidFill>
+                  <a:srgbClr val="E6EBF5"/>
                 </a:solidFill>
                 <a:latin typeface="Calibri"/>
               </a:rPr>
-              <a:t>•  Sobredimensionar recursos implica pagar de más; subdimensionarlos afecta el rendimiento del servicio.</a:t>
-            </a:r>
-          </a:p>
-          <a:p>
-            <a:r>
-              <a:rPr sz="1800" b="0">
-                <a:solidFill>
-                  <a:srgbClr val="222222"/>
+              <a:t>Sobredimensionar recursos implica pagar de más; subdimensionarlos afecta el rendimiento del servicio.</a:t>
+            </a:r>
+          </a:p>
+          <a:p>
+            <a:pPr indent="-228600" marL="228600">
+              <a:lnSpc>
+                <a:spcPct val="115000"/>
+              </a:lnSpc>
+              <a:spcAft>
+                <a:spcPts val="600"/>
+              </a:spcAft>
+              <a:buClr>
+                <a:srgbClr val="5EEAD4"/>
+              </a:buClr>
+              <a:buSzPct val="80000"/>
+              <a:buFont typeface="Arial"/>
+              <a:buChar char="▪"/>
+            </a:pPr>
+            <a:r>
+              <a:rPr sz="1800">
+                <a:solidFill>
+                  <a:srgbClr val="E6EBF5"/>
                 </a:solidFill>
                 <a:latin typeface="Calibri"/>
               </a:rPr>
-              <a:t>•  Pregunta central: ¿cómo determinar matemáticamente el número de instancias que minimiza el costo?</a:t>
-            </a:r>
+              <a:t>Pregunta central: ¿cómo determinar matemáticamente el número de instancias que minimiza el costo?</a:t>
+            </a:r>
+          </a:p>
+        </p:txBody>
+      </p:sp>
+      <p:sp>
+        <p:nvSpPr>
+          <p:cNvPr id="3" name="Rectangle 2"/>
+          <p:cNvSpPr/>
+          <p:nvPr/>
+        </p:nvSpPr>
+        <p:spPr>
+          <a:xfrm>
+            <a:off x="0" y="0"/>
+            <a:ext cx="12192000" cy="45720"/>
+          </a:xfrm>
+          <a:prstGeom prst="rect">
+            <a:avLst/>
+          </a:prstGeom>
+          <a:gradFill rotWithShape="1">
+            <a:gsLst>
+              <a:gs pos="0">
+                <a:srgbClr val="22D3EE"/>
+              </a:gs>
+              <a:gs pos="100000">
+                <a:srgbClr val="A855F7"/>
+              </a:gs>
+            </a:gsLst>
+            <a:lin scaled="0" ang="0"/>
+          </a:gradFill>
+          <a:ln>
+            <a:noFill/>
+          </a:ln>
+          <a:effectLst/>
+        </p:spPr>
+        <p:style>
+          <a:lnRef idx="1">
+            <a:schemeClr val="accent1"/>
+          </a:lnRef>
+          <a:fillRef idx="3">
+            <a:schemeClr val="accent1"/>
+          </a:fillRef>
+          <a:effectRef idx="2">
+            <a:schemeClr val="accent1"/>
+          </a:effectRef>
+          <a:fontRef idx="minor">
+            <a:schemeClr val="lt1"/>
+          </a:fontRef>
+        </p:style>
+        <p:txBody>
+          <a:bodyPr rtlCol="0" anchor="ctr"/>
+          <a:lstStyle/>
+          <a:p>
+            <a:pPr algn="ctr"/>
           </a:p>
         </p:txBody>
       </p:sp>
@@ -4459,6 +5446,14 @@
 <file path=ppt/slides/slide4.xml><?xml version="1.0" encoding="utf-8"?>
 <p:sld xmlns:a="http://schemas.openxmlformats.org/drawingml/2006/main" xmlns:r="http://schemas.openxmlformats.org/officeDocument/2006/relationships" xmlns:p="http://schemas.openxmlformats.org/presentationml/2006/main">
   <p:cSld>
+    <p:bg>
+      <p:bgPr>
+        <a:solidFill>
+          <a:srgbClr val="050611"/>
+        </a:solidFill>
+        <a:effectLst/>
+      </p:bgPr>
+    </p:bg>
     <p:spTree>
       <p:nvGrpSpPr>
         <p:cNvPr id="1" name=""/>
@@ -4501,97 +5496,66 @@
           </a:bodyPr>
           <a:lstStyle/>
           <a:p>
+            <a:pPr>
+              <a:spcAft>
+                <a:spcPts val="1400"/>
+              </a:spcAft>
+              <a:buNone/>
+            </a:pPr>
             <a:r>
               <a:rPr sz="2600" b="1">
                 <a:solidFill>
-                  <a:srgbClr val="222222"/>
+                  <a:srgbClr val="22D3EE"/>
                 </a:solidFill>
                 <a:latin typeface="Calibri"/>
               </a:rPr>
               <a:t>Objetivos y preguntas de investigación</a:t>
             </a:r>
             <a:endParaRPr lang="es-CL" dirty="0"/>
-          </a:p>
-          <a:p>
-            <a:r>
-              <a:rPr sz="1800" b="1">
-                <a:solidFill>
-                  <a:srgbClr val="222222"/>
-                </a:solidFill>
-                <a:latin typeface="Calibri"/>
-              </a:rPr>
-              <a:t>Objetivo general:</a:t>
-            </a:r>
-          </a:p>
-          <a:p>
-            <a:r>
-              <a:rPr sz="1800" b="0">
-                <a:solidFill>
-                  <a:srgbClr val="222222"/>
-                </a:solidFill>
-                <a:latin typeface="Calibri"/>
-              </a:rPr>
-              <a:t>•  Modelar el costo de infraestructura cloud como función del número de instancias y aplicar la derivada para hallar el costo mínimo.</a:t>
-            </a:r>
           </a:p>
           <a:p>
             <a:pPr>
               <a:spcBef>
                 <a:spcPts val="1000"/>
               </a:spcBef>
+              <a:spcAft>
+                <a:spcPts val="400"/>
+              </a:spcAft>
+              <a:buNone/>
             </a:pPr>
             <a:r>
               <a:rPr sz="1800" b="1">
                 <a:solidFill>
-                  <a:srgbClr val="222222"/>
+                  <a:srgbClr val="A855F7"/>
                 </a:solidFill>
                 <a:latin typeface="Calibri"/>
               </a:rPr>
-              <a:t>Objetivos específicos:</a:t>
-            </a:r>
-          </a:p>
-          <a:p>
-            <a:r>
-              <a:rPr sz="1800" b="0">
-                <a:solidFill>
-                  <a:srgbClr val="222222"/>
+              <a:t>Objetivo general:</a:t>
+            </a:r>
+          </a:p>
+          <a:p>
+            <a:pPr indent="-228600" marL="228600">
+              <a:lnSpc>
+                <a:spcPct val="115000"/>
+              </a:lnSpc>
+              <a:spcAft>
+                <a:spcPts val="600"/>
+              </a:spcAft>
+              <a:buClr>
+                <a:srgbClr val="5EEAD4"/>
+              </a:buClr>
+              <a:buSzPct val="80000"/>
+              <a:buFont typeface="Arial"/>
+              <a:buChar char="▪"/>
+            </a:pPr>
+            <a:r>
+              <a:rPr sz="1800">
+                <a:solidFill>
+                  <a:srgbClr val="E6EBF5"/>
                 </a:solidFill>
                 <a:latin typeface="Calibri"/>
               </a:rPr>
-              <a:t>•  Construir la función de costo C(x).</a:t>
-            </a:r>
-          </a:p>
-          <a:p>
-            <a:r>
-              <a:rPr sz="1800" b="0">
-                <a:solidFill>
-                  <a:srgbClr val="222222"/>
-                </a:solidFill>
-                <a:latin typeface="Calibri"/>
-              </a:rPr>
-              <a:t>•  Calcular C'(x) e identificar sus puntos críticos.</a:t>
-            </a:r>
-          </a:p>
-          <a:p>
-            <a:r>
-              <a:rPr sz="1800" b="0">
-                <a:solidFill>
-                  <a:srgbClr val="222222"/>
-                </a:solidFill>
-                <a:latin typeface="Calibri"/>
-              </a:rPr>
-              <a:t>•  Verificar el mínimo con el criterio de la segunda derivada.</a:t>
-            </a:r>
-          </a:p>
-          <a:p>
-            <a:r>
-              <a:rPr sz="1800" b="0">
-                <a:solidFill>
-                  <a:srgbClr val="222222"/>
-                </a:solidFill>
-                <a:latin typeface="Calibri"/>
-              </a:rPr>
-              <a:t>•  Desarrollar un simulador interactivo que visualice C(x) y C'(x).</a:t>
+              <a:t>Modelar el costo de infraestructura cloud como función del número de instancias y aplicar la derivada para hallar el costo mínimo.</a:t>
             </a:r>
           </a:p>
           <a:p>
@@ -4599,11 +5563,135 @@
               <a:spcBef>
                 <a:spcPts val="1000"/>
               </a:spcBef>
+              <a:spcAft>
+                <a:spcPts val="400"/>
+              </a:spcAft>
+              <a:buNone/>
             </a:pPr>
             <a:r>
               <a:rPr sz="1800" b="1">
                 <a:solidFill>
-                  <a:srgbClr val="222222"/>
+                  <a:srgbClr val="A855F7"/>
+                </a:solidFill>
+                <a:latin typeface="Calibri"/>
+              </a:rPr>
+              <a:t>Objetivos específicos:</a:t>
+            </a:r>
+          </a:p>
+          <a:p>
+            <a:pPr indent="-228600" marL="228600">
+              <a:lnSpc>
+                <a:spcPct val="115000"/>
+              </a:lnSpc>
+              <a:spcAft>
+                <a:spcPts val="600"/>
+              </a:spcAft>
+              <a:buClr>
+                <a:srgbClr val="5EEAD4"/>
+              </a:buClr>
+              <a:buSzPct val="80000"/>
+              <a:buFont typeface="Arial"/>
+              <a:buChar char="▪"/>
+            </a:pPr>
+            <a:r>
+              <a:rPr sz="1800">
+                <a:solidFill>
+                  <a:srgbClr val="E6EBF5"/>
+                </a:solidFill>
+                <a:latin typeface="Calibri"/>
+              </a:rPr>
+              <a:t>Construir la función de costo C(x).</a:t>
+            </a:r>
+          </a:p>
+          <a:p>
+            <a:pPr indent="-228600" marL="228600">
+              <a:lnSpc>
+                <a:spcPct val="115000"/>
+              </a:lnSpc>
+              <a:spcAft>
+                <a:spcPts val="600"/>
+              </a:spcAft>
+              <a:buClr>
+                <a:srgbClr val="5EEAD4"/>
+              </a:buClr>
+              <a:buSzPct val="80000"/>
+              <a:buFont typeface="Arial"/>
+              <a:buChar char="▪"/>
+            </a:pPr>
+            <a:r>
+              <a:rPr sz="1800">
+                <a:solidFill>
+                  <a:srgbClr val="E6EBF5"/>
+                </a:solidFill>
+                <a:latin typeface="Calibri"/>
+              </a:rPr>
+              <a:t>Calcular C'(x) e identificar sus puntos críticos.</a:t>
+            </a:r>
+          </a:p>
+          <a:p>
+            <a:pPr indent="-228600" marL="228600">
+              <a:lnSpc>
+                <a:spcPct val="115000"/>
+              </a:lnSpc>
+              <a:spcAft>
+                <a:spcPts val="600"/>
+              </a:spcAft>
+              <a:buClr>
+                <a:srgbClr val="5EEAD4"/>
+              </a:buClr>
+              <a:buSzPct val="80000"/>
+              <a:buFont typeface="Arial"/>
+              <a:buChar char="▪"/>
+            </a:pPr>
+            <a:r>
+              <a:rPr sz="1800">
+                <a:solidFill>
+                  <a:srgbClr val="E6EBF5"/>
+                </a:solidFill>
+                <a:latin typeface="Calibri"/>
+              </a:rPr>
+              <a:t>Verificar el mínimo con el criterio de la segunda derivada.</a:t>
+            </a:r>
+          </a:p>
+          <a:p>
+            <a:pPr indent="-228600" marL="228600">
+              <a:lnSpc>
+                <a:spcPct val="115000"/>
+              </a:lnSpc>
+              <a:spcAft>
+                <a:spcPts val="600"/>
+              </a:spcAft>
+              <a:buClr>
+                <a:srgbClr val="5EEAD4"/>
+              </a:buClr>
+              <a:buSzPct val="80000"/>
+              <a:buFont typeface="Arial"/>
+              <a:buChar char="▪"/>
+            </a:pPr>
+            <a:r>
+              <a:rPr sz="1800">
+                <a:solidFill>
+                  <a:srgbClr val="E6EBF5"/>
+                </a:solidFill>
+                <a:latin typeface="Calibri"/>
+              </a:rPr>
+              <a:t>Desarrollar un simulador interactivo que visualice C(x) y C'(x).</a:t>
+            </a:r>
+          </a:p>
+          <a:p>
+            <a:pPr>
+              <a:spcBef>
+                <a:spcPts val="1000"/>
+              </a:spcBef>
+              <a:spcAft>
+                <a:spcPts val="400"/>
+              </a:spcAft>
+              <a:buNone/>
+            </a:pPr>
+            <a:r>
+              <a:rPr sz="1800" b="1">
+                <a:solidFill>
+                  <a:srgbClr val="A855F7"/>
                 </a:solidFill>
                 <a:latin typeface="Calibri"/>
               </a:rPr>
@@ -4611,15 +5699,81 @@
             </a:r>
           </a:p>
           <a:p>
-            <a:r>
-              <a:rPr sz="1800" b="0">
-                <a:solidFill>
-                  <a:srgbClr val="222222"/>
+            <a:pPr indent="-228600" marL="228600">
+              <a:lnSpc>
+                <a:spcPct val="115000"/>
+              </a:lnSpc>
+              <a:spcAft>
+                <a:spcPts val="600"/>
+              </a:spcAft>
+              <a:buClr>
+                <a:srgbClr val="5EEAD4"/>
+              </a:buClr>
+              <a:buSzPct val="80000"/>
+              <a:buFont typeface="Arial"/>
+              <a:buChar char="▪"/>
+            </a:pPr>
+            <a:r>
+              <a:rPr sz="1800">
+                <a:solidFill>
+                  <a:srgbClr val="E6EBF5"/>
                 </a:solidFill>
                 <a:latin typeface="Calibri"/>
               </a:rPr>
-              <a:t>•  ¿Cuál es el número óptimo de instancias que minimiza el costo mensual, y cómo se determina usando la derivada?</a:t>
-            </a:r>
+              <a:t>¿Cuál es el número óptimo de instancias que minimiza el costo mensual, y cómo se determina usando la derivada?</a:t>
+            </a:r>
+          </a:p>
+        </p:txBody>
+      </p:sp>
+      <p:sp>
+        <p:nvSpPr>
+          <p:cNvPr id="3" name="Rectangle 2"/>
+          <p:cNvSpPr/>
+          <p:nvPr/>
+        </p:nvSpPr>
+        <p:spPr>
+          <a:xfrm>
+            <a:off x="0" y="0"/>
+            <a:ext cx="12192000" cy="45720"/>
+          </a:xfrm>
+          <a:prstGeom prst="rect">
+            <a:avLst/>
+          </a:prstGeom>
+          <a:gradFill rotWithShape="1">
+            <a:gsLst>
+              <a:gs pos="0">
+                <a:srgbClr val="22D3EE"/>
+              </a:gs>
+              <a:gs pos="100000">
+                <a:srgbClr val="A855F7"/>
+              </a:gs>
+            </a:gsLst>
+            <a:lin scaled="0" ang="0"/>
+          </a:gradFill>
+          <a:ln>
+            <a:noFill/>
+          </a:ln>
+          <a:effectLst/>
+        </p:spPr>
+        <p:style>
+          <a:lnRef idx="1">
+            <a:schemeClr val="accent1"/>
+          </a:lnRef>
+          <a:fillRef idx="3">
+            <a:schemeClr val="accent1"/>
+          </a:fillRef>
+          <a:effectRef idx="2">
+            <a:schemeClr val="accent1"/>
+          </a:effectRef>
+          <a:fontRef idx="minor">
+            <a:schemeClr val="lt1"/>
+          </a:fontRef>
+        </p:style>
+        <p:txBody>
+          <a:bodyPr rtlCol="0" anchor="ctr"/>
+          <a:lstStyle/>
+          <a:p>
+            <a:pPr algn="ctr"/>
           </a:p>
         </p:txBody>
       </p:sp>
@@ -4639,6 +5793,14 @@
 <file path=ppt/slides/slide5.xml><?xml version="1.0" encoding="utf-8"?>
 <p:sld xmlns:a="http://schemas.openxmlformats.org/drawingml/2006/main" xmlns:r="http://schemas.openxmlformats.org/officeDocument/2006/relationships" xmlns:p="http://schemas.openxmlformats.org/presentationml/2006/main">
   <p:cSld>
+    <p:bg>
+      <p:bgPr>
+        <a:solidFill>
+          <a:srgbClr val="050611"/>
+        </a:solidFill>
+        <a:effectLst/>
+      </p:bgPr>
+    </p:bg>
     <p:spTree>
       <p:nvGrpSpPr>
         <p:cNvPr id="1" name=""/>
@@ -4681,10 +5843,16 @@
           </a:bodyPr>
           <a:lstStyle/>
           <a:p>
+            <a:pPr>
+              <a:spcAft>
+                <a:spcPts val="1400"/>
+              </a:spcAft>
+              <a:buNone/>
+            </a:pPr>
             <a:r>
               <a:rPr sz="2600" b="1">
                 <a:solidFill>
-                  <a:srgbClr val="222222"/>
+                  <a:srgbClr val="22D3EE"/>
                 </a:solidFill>
                 <a:latin typeface="Calibri"/>
               </a:rPr>
@@ -4693,59 +5861,181 @@
             <a:endParaRPr lang="es-CL" dirty="0"/>
           </a:p>
           <a:p>
-            <a:r>
-              <a:rPr sz="1800" b="0">
-                <a:solidFill>
-                  <a:srgbClr val="222222"/>
+            <a:pPr indent="-228600" marL="228600">
+              <a:lnSpc>
+                <a:spcPct val="115000"/>
+              </a:lnSpc>
+              <a:spcAft>
+                <a:spcPts val="600"/>
+              </a:spcAft>
+              <a:buClr>
+                <a:srgbClr val="5EEAD4"/>
+              </a:buClr>
+              <a:buSzPct val="80000"/>
+              <a:buFont typeface="Arial"/>
+              <a:buChar char="▪"/>
+            </a:pPr>
+            <a:r>
+              <a:rPr sz="1800">
+                <a:solidFill>
+                  <a:srgbClr val="E6EBF5"/>
                 </a:solidFill>
                 <a:latin typeface="Calibri"/>
               </a:rPr>
-              <a:t>•  Funciones polinomiales (función cuadrática de costo).</a:t>
-            </a:r>
-          </a:p>
-          <a:p>
-            <a:r>
-              <a:rPr sz="1800" b="0">
-                <a:solidFill>
-                  <a:srgbClr val="222222"/>
+              <a:t>Funciones polinomiales (función cuadrática de costo).</a:t>
+            </a:r>
+          </a:p>
+          <a:p>
+            <a:pPr indent="-228600" marL="228600">
+              <a:lnSpc>
+                <a:spcPct val="115000"/>
+              </a:lnSpc>
+              <a:spcAft>
+                <a:spcPts val="600"/>
+              </a:spcAft>
+              <a:buClr>
+                <a:srgbClr val="5EEAD4"/>
+              </a:buClr>
+              <a:buSzPct val="80000"/>
+              <a:buFont typeface="Arial"/>
+              <a:buChar char="▪"/>
+            </a:pPr>
+            <a:r>
+              <a:rPr sz="1800">
+                <a:solidFill>
+                  <a:srgbClr val="E6EBF5"/>
                 </a:solidFill>
                 <a:latin typeface="Calibri"/>
               </a:rPr>
-              <a:t>•  Límites y continuidad.</a:t>
-            </a:r>
-          </a:p>
-          <a:p>
-            <a:r>
-              <a:rPr sz="1800" b="0">
-                <a:solidFill>
-                  <a:srgbClr val="222222"/>
+              <a:t>Límites y continuidad.</a:t>
+            </a:r>
+          </a:p>
+          <a:p>
+            <a:pPr indent="-228600" marL="228600">
+              <a:lnSpc>
+                <a:spcPct val="115000"/>
+              </a:lnSpc>
+              <a:spcAft>
+                <a:spcPts val="600"/>
+              </a:spcAft>
+              <a:buClr>
+                <a:srgbClr val="5EEAD4"/>
+              </a:buClr>
+              <a:buSzPct val="80000"/>
+              <a:buFont typeface="Arial"/>
+              <a:buChar char="▪"/>
+            </a:pPr>
+            <a:r>
+              <a:rPr sz="1800">
+                <a:solidFill>
+                  <a:srgbClr val="E6EBF5"/>
                 </a:solidFill>
                 <a:latin typeface="Calibri"/>
               </a:rPr>
-              <a:t>•  Reglas de derivación.</a:t>
-            </a:r>
-          </a:p>
-          <a:p>
-            <a:r>
-              <a:rPr sz="1800" b="0">
-                <a:solidFill>
-                  <a:srgbClr val="222222"/>
+              <a:t>Reglas de derivación.</a:t>
+            </a:r>
+          </a:p>
+          <a:p>
+            <a:pPr indent="-228600" marL="228600">
+              <a:lnSpc>
+                <a:spcPct val="115000"/>
+              </a:lnSpc>
+              <a:spcAft>
+                <a:spcPts val="600"/>
+              </a:spcAft>
+              <a:buClr>
+                <a:srgbClr val="5EEAD4"/>
+              </a:buClr>
+              <a:buSzPct val="80000"/>
+              <a:buFont typeface="Arial"/>
+              <a:buChar char="▪"/>
+            </a:pPr>
+            <a:r>
+              <a:rPr sz="1800">
+                <a:solidFill>
+                  <a:srgbClr val="E6EBF5"/>
                 </a:solidFill>
                 <a:latin typeface="Calibri"/>
               </a:rPr>
-              <a:t>•  Puntos críticos y criterio de la primera y segunda derivada.</a:t>
-            </a:r>
-          </a:p>
-          <a:p>
-            <a:r>
-              <a:rPr sz="1800" b="0">
-                <a:solidFill>
-                  <a:srgbClr val="222222"/>
+              <a:t>Puntos críticos y criterio de la primera y segunda derivada.</a:t>
+            </a:r>
+          </a:p>
+          <a:p>
+            <a:pPr indent="-228600" marL="228600">
+              <a:lnSpc>
+                <a:spcPct val="115000"/>
+              </a:lnSpc>
+              <a:spcAft>
+                <a:spcPts val="600"/>
+              </a:spcAft>
+              <a:buClr>
+                <a:srgbClr val="5EEAD4"/>
+              </a:buClr>
+              <a:buSzPct val="80000"/>
+              <a:buFont typeface="Arial"/>
+              <a:buChar char="▪"/>
+            </a:pPr>
+            <a:r>
+              <a:rPr sz="1800">
+                <a:solidFill>
+                  <a:srgbClr val="E6EBF5"/>
                 </a:solidFill>
                 <a:latin typeface="Calibri"/>
               </a:rPr>
-              <a:t>•  Optimización aplicada a problemas de ingeniería.</a:t>
-            </a:r>
+              <a:t>Optimización aplicada a problemas de ingeniería.</a:t>
+            </a:r>
+          </a:p>
+        </p:txBody>
+      </p:sp>
+      <p:sp>
+        <p:nvSpPr>
+          <p:cNvPr id="3" name="Rectangle 2"/>
+          <p:cNvSpPr/>
+          <p:nvPr/>
+        </p:nvSpPr>
+        <p:spPr>
+          <a:xfrm>
+            <a:off x="0" y="0"/>
+            <a:ext cx="12192000" cy="45720"/>
+          </a:xfrm>
+          <a:prstGeom prst="rect">
+            <a:avLst/>
+          </a:prstGeom>
+          <a:gradFill rotWithShape="1">
+            <a:gsLst>
+              <a:gs pos="0">
+                <a:srgbClr val="22D3EE"/>
+              </a:gs>
+              <a:gs pos="100000">
+                <a:srgbClr val="A855F7"/>
+              </a:gs>
+            </a:gsLst>
+            <a:lin scaled="0" ang="0"/>
+          </a:gradFill>
+          <a:ln>
+            <a:noFill/>
+          </a:ln>
+          <a:effectLst/>
+        </p:spPr>
+        <p:style>
+          <a:lnRef idx="1">
+            <a:schemeClr val="accent1"/>
+          </a:lnRef>
+          <a:fillRef idx="3">
+            <a:schemeClr val="accent1"/>
+          </a:fillRef>
+          <a:effectRef idx="2">
+            <a:schemeClr val="accent1"/>
+          </a:effectRef>
+          <a:fontRef idx="minor">
+            <a:schemeClr val="lt1"/>
+          </a:fontRef>
+        </p:style>
+        <p:txBody>
+          <a:bodyPr rtlCol="0" anchor="ctr"/>
+          <a:lstStyle/>
+          <a:p>
+            <a:pPr algn="ctr"/>
           </a:p>
         </p:txBody>
       </p:sp>
@@ -4765,6 +6055,14 @@
 <file path=ppt/slides/slide6.xml><?xml version="1.0" encoding="utf-8"?>
 <p:sld xmlns:a="http://schemas.openxmlformats.org/drawingml/2006/main" xmlns:r="http://schemas.openxmlformats.org/officeDocument/2006/relationships" xmlns:p="http://schemas.openxmlformats.org/presentationml/2006/main">
   <p:cSld>
+    <p:bg>
+      <p:bgPr>
+        <a:solidFill>
+          <a:srgbClr val="050611"/>
+        </a:solidFill>
+        <a:effectLst/>
+      </p:bgPr>
+    </p:bg>
     <p:spTree>
       <p:nvGrpSpPr>
         <p:cNvPr id="1" name=""/>
@@ -4807,10 +6105,16 @@
           </a:bodyPr>
           <a:lstStyle/>
           <a:p>
+            <a:pPr>
+              <a:spcAft>
+                <a:spcPts val="1400"/>
+              </a:spcAft>
+              <a:buNone/>
+            </a:pPr>
             <a:r>
               <a:rPr sz="2600" b="1">
                 <a:solidFill>
-                  <a:srgbClr val="222222"/>
+                  <a:srgbClr val="22D3EE"/>
                 </a:solidFill>
                 <a:latin typeface="Calibri"/>
               </a:rPr>
@@ -4851,75 +6155,125 @@
                     <a:bodyPr/>
                     <a:lstStyle/>
                     <a:p>
+                      <a:pPr>
+                        <a:buNone/>
+                      </a:pPr>
                       <a:r>
-                        <a:rPr b="1" sz="1300">
+                        <a:rPr b="1" sz="1200">
+                          <a:solidFill>
+                            <a:srgbClr val="22D3EE"/>
+                          </a:solidFill>
                           <a:latin typeface="Calibri"/>
                         </a:rPr>
                         <a:t>Tareas</a:t>
                       </a:r>
                     </a:p>
                   </a:txBody>
-                  <a:tcPr/>
+                  <a:tcPr>
+                    <a:solidFill>
+                      <a:srgbClr val="0D0F1E"/>
+                    </a:solidFill>
+                  </a:tcPr>
                 </a:tc>
                 <a:tc>
                   <a:txBody>
                     <a:bodyPr/>
                     <a:lstStyle/>
                     <a:p>
+                      <a:pPr>
+                        <a:buNone/>
+                      </a:pPr>
                       <a:r>
-                        <a:rPr b="1" sz="1300">
+                        <a:rPr b="1" sz="1200">
+                          <a:solidFill>
+                            <a:srgbClr val="22D3EE"/>
+                          </a:solidFill>
                           <a:latin typeface="Calibri"/>
                         </a:rPr>
                         <a:t>Productos</a:t>
                       </a:r>
                     </a:p>
                   </a:txBody>
-                  <a:tcPr/>
+                  <a:tcPr>
+                    <a:solidFill>
+                      <a:srgbClr val="0D0F1E"/>
+                    </a:solidFill>
+                  </a:tcPr>
                 </a:tc>
                 <a:tc>
                   <a:txBody>
                     <a:bodyPr/>
                     <a:lstStyle/>
                     <a:p>
+                      <a:pPr>
+                        <a:buNone/>
+                      </a:pPr>
                       <a:r>
-                        <a:rPr b="1" sz="1300">
+                        <a:rPr b="1" sz="1200">
+                          <a:solidFill>
+                            <a:srgbClr val="22D3EE"/>
+                          </a:solidFill>
                           <a:latin typeface="Calibri"/>
                         </a:rPr>
                         <a:t>Plazos</a:t>
                       </a:r>
                     </a:p>
                   </a:txBody>
-                  <a:tcPr/>
+                  <a:tcPr>
+                    <a:solidFill>
+                      <a:srgbClr val="0D0F1E"/>
+                    </a:solidFill>
+                  </a:tcPr>
                 </a:tc>
                 <a:tc>
                   <a:txBody>
                     <a:bodyPr/>
                     <a:lstStyle/>
                     <a:p>
+                      <a:pPr>
+                        <a:buNone/>
+                      </a:pPr>
                       <a:r>
-                        <a:rPr b="1" sz="1300">
+                        <a:rPr b="1" sz="1200">
+                          <a:solidFill>
+                            <a:srgbClr val="22D3EE"/>
+                          </a:solidFill>
                           <a:latin typeface="Calibri"/>
                         </a:rPr>
                         <a:t>Responsable(s)</a:t>
                       </a:r>
                     </a:p>
                   </a:txBody>
-                  <a:tcPr/>
+                  <a:tcPr>
+                    <a:solidFill>
+                      <a:srgbClr val="0D0F1E"/>
+                    </a:solidFill>
+                  </a:tcPr>
                 </a:tc>
                 <a:tc>
                   <a:txBody>
                     <a:bodyPr/>
                     <a:lstStyle/>
                     <a:p>
+                      <a:pPr>
+                        <a:buNone/>
+                      </a:pPr>
                       <a:r>
-                        <a:rPr b="1" sz="1300">
+                        <a:rPr b="1" sz="1200">
+                          <a:solidFill>
+                            <a:srgbClr val="22D3EE"/>
+                          </a:solidFill>
                           <a:latin typeface="Calibri"/>
                         </a:rPr>
                         <a:t>Insumos</a:t>
                       </a:r>
                     </a:p>
                   </a:txBody>
-                  <a:tcPr/>
+                  <a:tcPr>
+                    <a:solidFill>
+                      <a:srgbClr val="0D0F1E"/>
+                    </a:solidFill>
+                  </a:tcPr>
                 </a:tc>
               </a:tr>
               <a:tr h="514285">
@@ -4929,17 +6283,24 @@
                     <a:lstStyle/>
                     <a:p>
                       <a:pPr>
-                        <a:defRPr sz="1100"/>
+                        <a:buNone/>
                       </a:pPr>
                       <a:r>
                         <a:rPr sz="1100">
+                          <a:solidFill>
+                            <a:srgbClr val="94A3B8"/>
+                          </a:solidFill>
                           <a:latin typeface="Calibri"/>
                         </a:rPr>
-                        <a:t>Investigar problemática y definir tema</a:t>
+                        <a:t>Definir problema y objetivos</a:t>
                       </a:r>
                     </a:p>
                   </a:txBody>
-                  <a:tcPr/>
+                  <a:tcPr>
+                    <a:solidFill>
+                      <a:srgbClr val="050611"/>
+                    </a:solidFill>
+                  </a:tcPr>
                 </a:tc>
                 <a:tc>
                   <a:txBody>
@@ -4947,17 +6308,24 @@
                     <a:lstStyle/>
                     <a:p>
                       <a:pPr>
-                        <a:defRPr sz="1100"/>
+                        <a:buNone/>
                       </a:pPr>
                       <a:r>
                         <a:rPr sz="1100">
+                          <a:solidFill>
+                            <a:srgbClr val="94A3B8"/>
+                          </a:solidFill>
                           <a:latin typeface="Calibri"/>
                         </a:rPr>
-                        <a:t>Problemática y tema definidos</a:t>
+                        <a:t>Problemática y objetivos definidos</a:t>
                       </a:r>
                     </a:p>
                   </a:txBody>
-                  <a:tcPr/>
+                  <a:tcPr>
+                    <a:solidFill>
+                      <a:srgbClr val="050611"/>
+                    </a:solidFill>
+                  </a:tcPr>
                 </a:tc>
                 <a:tc>
                   <a:txBody>
@@ -4965,17 +6333,24 @@
                     <a:lstStyle/>
                     <a:p>
                       <a:pPr>
-                        <a:defRPr sz="1100"/>
+                        <a:buNone/>
                       </a:pPr>
                       <a:r>
                         <a:rPr sz="1100">
+                          <a:solidFill>
+                            <a:srgbClr val="5EEAD4"/>
+                          </a:solidFill>
                           <a:latin typeface="Calibri"/>
                         </a:rPr>
-                        <a:t>Semana 1-2</a:t>
+                        <a:t>7 julio</a:t>
                       </a:r>
                     </a:p>
                   </a:txBody>
-                  <a:tcPr/>
+                  <a:tcPr>
+                    <a:solidFill>
+                      <a:srgbClr val="050611"/>
+                    </a:solidFill>
+                  </a:tcPr>
                 </a:tc>
                 <a:tc>
                   <a:txBody>
@@ -4983,17 +6358,24 @@
                     <a:lstStyle/>
                     <a:p>
                       <a:pPr>
-                        <a:defRPr sz="1100"/>
+                        <a:buNone/>
                       </a:pPr>
                       <a:r>
                         <a:rPr sz="1100">
+                          <a:solidFill>
+                            <a:srgbClr val="94A3B8"/>
+                          </a:solidFill>
                           <a:latin typeface="Calibri"/>
                         </a:rPr>
                         <a:t>Andrés Carrasco</a:t>
                       </a:r>
                     </a:p>
                   </a:txBody>
-                  <a:tcPr/>
+                  <a:tcPr>
+                    <a:solidFill>
+                      <a:srgbClr val="050611"/>
+                    </a:solidFill>
+                  </a:tcPr>
                 </a:tc>
                 <a:tc>
                   <a:txBody>
@@ -5001,17 +6383,24 @@
                     <a:lstStyle/>
                     <a:p>
                       <a:pPr>
-                        <a:defRPr sz="1100"/>
+                        <a:buNone/>
                       </a:pPr>
                       <a:r>
                         <a:rPr sz="1100">
+                          <a:solidFill>
+                            <a:srgbClr val="94A3B8"/>
+                          </a:solidFill>
                           <a:latin typeface="Calibri"/>
                         </a:rPr>
-                        <a:t>Bibliografía de cálculo</a:t>
+                        <a:t>Apuntes de Cálculo Unidad 3</a:t>
                       </a:r>
                     </a:p>
                   </a:txBody>
-                  <a:tcPr/>
+                  <a:tcPr>
+                    <a:solidFill>
+                      <a:srgbClr val="050611"/>
+                    </a:solidFill>
+                  </a:tcPr>
                 </a:tc>
               </a:tr>
               <a:tr h="514285">
@@ -5021,17 +6410,24 @@
                     <a:lstStyle/>
                     <a:p>
                       <a:pPr>
-                        <a:defRPr sz="1100"/>
+                        <a:buNone/>
                       </a:pPr>
                       <a:r>
                         <a:rPr sz="1100">
+                          <a:solidFill>
+                            <a:srgbClr val="94A3B8"/>
+                          </a:solidFill>
                           <a:latin typeface="Calibri"/>
                         </a:rPr>
-                        <a:t>Formular objetivos y modelo matemático inicial</a:t>
+                        <a:t>Investigar costos reales de proveedores cloud y modelar C(x)</a:t>
                       </a:r>
                     </a:p>
                   </a:txBody>
-                  <a:tcPr/>
+                  <a:tcPr>
+                    <a:solidFill>
+                      <a:srgbClr val="050611"/>
+                    </a:solidFill>
+                  </a:tcPr>
                 </a:tc>
                 <a:tc>
                   <a:txBody>
@@ -5039,17 +6435,24 @@
                     <a:lstStyle/>
                     <a:p>
                       <a:pPr>
-                        <a:defRPr sz="1100"/>
+                        <a:buNone/>
                       </a:pPr>
                       <a:r>
                         <a:rPr sz="1100">
+                          <a:solidFill>
+                            <a:srgbClr val="94A3B8"/>
+                          </a:solidFill>
                           <a:latin typeface="Calibri"/>
                         </a:rPr>
                         <a:t>Función de costo C(x) planteada</a:t>
                       </a:r>
                     </a:p>
                   </a:txBody>
-                  <a:tcPr/>
+                  <a:tcPr>
+                    <a:solidFill>
+                      <a:srgbClr val="050611"/>
+                    </a:solidFill>
+                  </a:tcPr>
                 </a:tc>
                 <a:tc>
                   <a:txBody>
@@ -5057,17 +6460,24 @@
                     <a:lstStyle/>
                     <a:p>
                       <a:pPr>
-                        <a:defRPr sz="1100"/>
+                        <a:buNone/>
                       </a:pPr>
                       <a:r>
                         <a:rPr sz="1100">
+                          <a:solidFill>
+                            <a:srgbClr val="5EEAD4"/>
+                          </a:solidFill>
                           <a:latin typeface="Calibri"/>
                         </a:rPr>
-                        <a:t>Semana 3-4</a:t>
+                        <a:t>9 julio</a:t>
                       </a:r>
                     </a:p>
                   </a:txBody>
-                  <a:tcPr/>
+                  <a:tcPr>
+                    <a:solidFill>
+                      <a:srgbClr val="050611"/>
+                    </a:solidFill>
+                  </a:tcPr>
                 </a:tc>
                 <a:tc>
                   <a:txBody>
@@ -5075,17 +6485,24 @@
                     <a:lstStyle/>
                     <a:p>
                       <a:pPr>
-                        <a:defRPr sz="1100"/>
+                        <a:buNone/>
                       </a:pPr>
                       <a:r>
                         <a:rPr sz="1100">
+                          <a:solidFill>
+                            <a:srgbClr val="94A3B8"/>
+                          </a:solidFill>
                           <a:latin typeface="Calibri"/>
                         </a:rPr>
                         <a:t>Andrés Carrasco</a:t>
                       </a:r>
                     </a:p>
                   </a:txBody>
-                  <a:tcPr/>
+                  <a:tcPr>
+                    <a:solidFill>
+                      <a:srgbClr val="050611"/>
+                    </a:solidFill>
+                  </a:tcPr>
                 </a:tc>
                 <a:tc>
                   <a:txBody>
@@ -5093,17 +6510,24 @@
                     <a:lstStyle/>
                     <a:p>
                       <a:pPr>
-                        <a:defRPr sz="1100"/>
+                        <a:buNone/>
                       </a:pPr>
                       <a:r>
                         <a:rPr sz="1100">
+                          <a:solidFill>
+                            <a:srgbClr val="94A3B8"/>
+                          </a:solidFill>
                           <a:latin typeface="Calibri"/>
                         </a:rPr>
-                        <a:t>Apuntes de cálculo</a:t>
+                        <a:t>Documentación de precios AWS/Azure</a:t>
                       </a:r>
                     </a:p>
                   </a:txBody>
-                  <a:tcPr/>
+                  <a:tcPr>
+                    <a:solidFill>
+                      <a:srgbClr val="050611"/>
+                    </a:solidFill>
+                  </a:tcPr>
                 </a:tc>
               </a:tr>
               <a:tr h="514285">
@@ -5113,17 +6537,24 @@
                     <a:lstStyle/>
                     <a:p>
                       <a:pPr>
-                        <a:defRPr sz="1100"/>
+                        <a:buNone/>
                       </a:pPr>
                       <a:r>
                         <a:rPr sz="1100">
+                          <a:solidFill>
+                            <a:srgbClr val="94A3B8"/>
+                          </a:solidFill>
                           <a:latin typeface="Calibri"/>
                         </a:rPr>
-                        <a:t>Aplicar la derivada y validar el mínimo</a:t>
+                        <a:t>Aplicar la derivada, hallar el punto óptimo y construir el simulador</a:t>
                       </a:r>
                     </a:p>
                   </a:txBody>
-                  <a:tcPr/>
+                  <a:tcPr>
+                    <a:solidFill>
+                      <a:srgbClr val="050611"/>
+                    </a:solidFill>
+                  </a:tcPr>
                 </a:tc>
                 <a:tc>
                   <a:txBody>
@@ -5131,17 +6562,24 @@
                     <a:lstStyle/>
                     <a:p>
                       <a:pPr>
-                        <a:defRPr sz="1100"/>
+                        <a:buNone/>
                       </a:pPr>
                       <a:r>
                         <a:rPr sz="1100">
+                          <a:solidFill>
+                            <a:srgbClr val="94A3B8"/>
+                          </a:solidFill>
                           <a:latin typeface="Calibri"/>
                         </a:rPr>
-                        <a:t>Punto crítico verificado con C''(x)</a:t>
+                        <a:t>C'(x), punto crítico x=20 y simulador web</a:t>
                       </a:r>
                     </a:p>
                   </a:txBody>
-                  <a:tcPr/>
+                  <a:tcPr>
+                    <a:solidFill>
+                      <a:srgbClr val="050611"/>
+                    </a:solidFill>
+                  </a:tcPr>
                 </a:tc>
                 <a:tc>
                   <a:txBody>
@@ -5149,17 +6587,24 @@
                     <a:lstStyle/>
                     <a:p>
                       <a:pPr>
-                        <a:defRPr sz="1100"/>
+                        <a:buNone/>
                       </a:pPr>
                       <a:r>
                         <a:rPr sz="1100">
+                          <a:solidFill>
+                            <a:srgbClr val="5EEAD4"/>
+                          </a:solidFill>
                           <a:latin typeface="Calibri"/>
                         </a:rPr>
-                        <a:t>Semana 5-6</a:t>
+                        <a:t>14 julio</a:t>
                       </a:r>
                     </a:p>
                   </a:txBody>
-                  <a:tcPr/>
+                  <a:tcPr>
+                    <a:solidFill>
+                      <a:srgbClr val="050611"/>
+                    </a:solidFill>
+                  </a:tcPr>
                 </a:tc>
                 <a:tc>
                   <a:txBody>
@@ -5167,17 +6612,24 @@
                     <a:lstStyle/>
                     <a:p>
                       <a:pPr>
-                        <a:defRPr sz="1100"/>
+                        <a:buNone/>
                       </a:pPr>
                       <a:r>
                         <a:rPr sz="1100">
+                          <a:solidFill>
+                            <a:srgbClr val="94A3B8"/>
+                          </a:solidFill>
                           <a:latin typeface="Calibri"/>
                         </a:rPr>
                         <a:t>Andrés Carrasco</a:t>
                       </a:r>
                     </a:p>
                   </a:txBody>
-                  <a:tcPr/>
+                  <a:tcPr>
+                    <a:solidFill>
+                      <a:srgbClr val="050611"/>
+                    </a:solidFill>
+                  </a:tcPr>
                 </a:tc>
                 <a:tc>
                   <a:txBody>
@@ -5185,17 +6637,24 @@
                     <a:lstStyle/>
                     <a:p>
                       <a:pPr>
-                        <a:defRPr sz="1100"/>
+                        <a:buNone/>
                       </a:pPr>
                       <a:r>
                         <a:rPr sz="1100">
+                          <a:solidFill>
+                            <a:srgbClr val="94A3B8"/>
+                          </a:solidFill>
                           <a:latin typeface="Calibri"/>
                         </a:rPr>
-                        <a:t>Software de cálculo (GeoGebra/Python)</a:t>
+                        <a:t>Plotly.js, HTML/CSS/JS</a:t>
                       </a:r>
                     </a:p>
                   </a:txBody>
-                  <a:tcPr/>
+                  <a:tcPr>
+                    <a:solidFill>
+                      <a:srgbClr val="050611"/>
+                    </a:solidFill>
+                  </a:tcPr>
                 </a:tc>
               </a:tr>
               <a:tr h="514285">
@@ -5205,17 +6664,24 @@
                     <a:lstStyle/>
                     <a:p>
                       <a:pPr>
-                        <a:defRPr sz="1100"/>
+                        <a:buNone/>
                       </a:pPr>
                       <a:r>
                         <a:rPr sz="1100">
+                          <a:solidFill>
+                            <a:srgbClr val="94A3B8"/>
+                          </a:solidFill>
                           <a:latin typeface="Calibri"/>
                         </a:rPr>
-                        <a:t>Diseñar y programar el simulador web</a:t>
+                        <a:t>Elaborar PPT y grabar el video de presentación</a:t>
                       </a:r>
                     </a:p>
                   </a:txBody>
-                  <a:tcPr/>
+                  <a:tcPr>
+                    <a:solidFill>
+                      <a:srgbClr val="050611"/>
+                    </a:solidFill>
+                  </a:tcPr>
                 </a:tc>
                 <a:tc>
                   <a:txBody>
@@ -5223,17 +6689,24 @@
                     <a:lstStyle/>
                     <a:p>
                       <a:pPr>
-                        <a:defRPr sz="1100"/>
+                        <a:buNone/>
                       </a:pPr>
                       <a:r>
                         <a:rPr sz="1100">
+                          <a:solidFill>
+                            <a:srgbClr val="94A3B8"/>
+                          </a:solidFill>
                           <a:latin typeface="Calibri"/>
                         </a:rPr>
-                        <a:t>Sitio web + simulador interactivo</a:t>
+                        <a:t>PPT + video con guion</a:t>
                       </a:r>
                     </a:p>
                   </a:txBody>
-                  <a:tcPr/>
+                  <a:tcPr>
+                    <a:solidFill>
+                      <a:srgbClr val="050611"/>
+                    </a:solidFill>
+                  </a:tcPr>
                 </a:tc>
                 <a:tc>
                   <a:txBody>
@@ -5241,17 +6714,24 @@
                     <a:lstStyle/>
                     <a:p>
                       <a:pPr>
-                        <a:defRPr sz="1100"/>
+                        <a:buNone/>
                       </a:pPr>
                       <a:r>
                         <a:rPr sz="1100">
+                          <a:solidFill>
+                            <a:srgbClr val="5EEAD4"/>
+                          </a:solidFill>
                           <a:latin typeface="Calibri"/>
                         </a:rPr>
-                        <a:t>Semana 7-9</a:t>
+                        <a:t>14-20 julio</a:t>
                       </a:r>
                     </a:p>
                   </a:txBody>
-                  <a:tcPr/>
+                  <a:tcPr>
+                    <a:solidFill>
+                      <a:srgbClr val="050611"/>
+                    </a:solidFill>
+                  </a:tcPr>
                 </a:tc>
                 <a:tc>
                   <a:txBody>
@@ -5259,17 +6739,24 @@
                     <a:lstStyle/>
                     <a:p>
                       <a:pPr>
-                        <a:defRPr sz="1100"/>
+                        <a:buNone/>
                       </a:pPr>
                       <a:r>
                         <a:rPr sz="1100">
+                          <a:solidFill>
+                            <a:srgbClr val="94A3B8"/>
+                          </a:solidFill>
                           <a:latin typeface="Calibri"/>
                         </a:rPr>
                         <a:t>Andrés Carrasco</a:t>
                       </a:r>
                     </a:p>
                   </a:txBody>
-                  <a:tcPr/>
+                  <a:tcPr>
+                    <a:solidFill>
+                      <a:srgbClr val="050611"/>
+                    </a:solidFill>
+                  </a:tcPr>
                 </a:tc>
                 <a:tc>
                   <a:txBody>
@@ -5277,17 +6764,24 @@
                     <a:lstStyle/>
                     <a:p>
                       <a:pPr>
-                        <a:defRPr sz="1100"/>
+                        <a:buNone/>
                       </a:pPr>
                       <a:r>
                         <a:rPr sz="1100">
+                          <a:solidFill>
+                            <a:srgbClr val="94A3B8"/>
+                          </a:solidFill>
                           <a:latin typeface="Calibri"/>
                         </a:rPr>
-                        <a:t>HTML/CSS/JS, Plotly.js, Vercel</a:t>
+                        <a:t>Guion, grabadora de audio, ffmpeg</a:t>
                       </a:r>
                     </a:p>
                   </a:txBody>
-                  <a:tcPr/>
+                  <a:tcPr>
+                    <a:solidFill>
+                      <a:srgbClr val="050611"/>
+                    </a:solidFill>
+                  </a:tcPr>
                 </a:tc>
               </a:tr>
               <a:tr h="514285">
@@ -5297,17 +6791,24 @@
                     <a:lstStyle/>
                     <a:p>
                       <a:pPr>
-                        <a:defRPr sz="1100"/>
+                        <a:buNone/>
                       </a:pPr>
                       <a:r>
                         <a:rPr sz="1100">
+                          <a:solidFill>
+                            <a:srgbClr val="94A3B8"/>
+                          </a:solidFill>
                           <a:latin typeface="Calibri"/>
                         </a:rPr>
-                        <a:t>Redactar resultados, conclusiones y bibliografía</a:t>
+                        <a:t>Revisión final y entrega</a:t>
                       </a:r>
                     </a:p>
                   </a:txBody>
-                  <a:tcPr/>
+                  <a:tcPr>
+                    <a:solidFill>
+                      <a:srgbClr val="050611"/>
+                    </a:solidFill>
+                  </a:tcPr>
                 </a:tc>
                 <a:tc>
                   <a:txBody>
@@ -5315,17 +6816,24 @@
                     <a:lstStyle/>
                     <a:p>
                       <a:pPr>
-                        <a:defRPr sz="1100"/>
+                        <a:buNone/>
                       </a:pPr>
                       <a:r>
                         <a:rPr sz="1100">
+                          <a:solidFill>
+                            <a:srgbClr val="94A3B8"/>
+                          </a:solidFill>
                           <a:latin typeface="Calibri"/>
                         </a:rPr>
-                        <a:t>Informe final y presentación</a:t>
+                        <a:t>Proyecto completo entregado</a:t>
                       </a:r>
                     </a:p>
                   </a:txBody>
-                  <a:tcPr/>
+                  <a:tcPr>
+                    <a:solidFill>
+                      <a:srgbClr val="050611"/>
+                    </a:solidFill>
+                  </a:tcPr>
                 </a:tc>
                 <a:tc>
                   <a:txBody>
@@ -5333,17 +6841,24 @@
                     <a:lstStyle/>
                     <a:p>
                       <a:pPr>
-                        <a:defRPr sz="1100"/>
+                        <a:buNone/>
                       </a:pPr>
                       <a:r>
                         <a:rPr sz="1100">
+                          <a:solidFill>
+                            <a:srgbClr val="5EEAD4"/>
+                          </a:solidFill>
                           <a:latin typeface="Calibri"/>
                         </a:rPr>
-                        <a:t>Semana 10-11</a:t>
+                        <a:t>21 julio</a:t>
                       </a:r>
                     </a:p>
                   </a:txBody>
-                  <a:tcPr/>
+                  <a:tcPr>
+                    <a:solidFill>
+                      <a:srgbClr val="050611"/>
+                    </a:solidFill>
+                  </a:tcPr>
                 </a:tc>
                 <a:tc>
                   <a:txBody>
@@ -5351,17 +6866,24 @@
                     <a:lstStyle/>
                     <a:p>
                       <a:pPr>
-                        <a:defRPr sz="1100"/>
+                        <a:buNone/>
                       </a:pPr>
                       <a:r>
                         <a:rPr sz="1100">
+                          <a:solidFill>
+                            <a:srgbClr val="94A3B8"/>
+                          </a:solidFill>
                           <a:latin typeface="Calibri"/>
                         </a:rPr>
                         <a:t>Andrés Carrasco</a:t>
                       </a:r>
                     </a:p>
                   </a:txBody>
-                  <a:tcPr/>
+                  <a:tcPr>
+                    <a:solidFill>
+                      <a:srgbClr val="050611"/>
+                    </a:solidFill>
+                  </a:tcPr>
                 </a:tc>
                 <a:tc>
                   <a:txBody>
@@ -5369,115 +6891,82 @@
                     <a:lstStyle/>
                     <a:p>
                       <a:pPr>
-                        <a:defRPr sz="1100"/>
+                        <a:buNone/>
                       </a:pPr>
                       <a:r>
                         <a:rPr sz="1100">
+                          <a:solidFill>
+                            <a:srgbClr val="94A3B8"/>
+                          </a:solidFill>
                           <a:latin typeface="Calibri"/>
                         </a:rPr>
-                        <a:t>Procesador de texto, fuentes</a:t>
+                        <a:t>Sitio web publicado en Vercel</a:t>
                       </a:r>
                     </a:p>
                   </a:txBody>
-                  <a:tcPr/>
-                </a:tc>
-              </a:tr>
-              <a:tr h="514290">
-                <a:tc>
-                  <a:txBody>
-                    <a:bodyPr/>
-                    <a:lstStyle/>
-                    <a:p>
-                      <a:pPr>
-                        <a:defRPr sz="1100"/>
-                      </a:pPr>
-                      <a:r>
-                        <a:rPr sz="1100">
-                          <a:latin typeface="Calibri"/>
-                        </a:rPr>
-                        <a:t>Grabar video y preparar entrega final</a:t>
-                      </a:r>
-                    </a:p>
-                  </a:txBody>
-                  <a:tcPr/>
-                </a:tc>
-                <a:tc>
-                  <a:txBody>
-                    <a:bodyPr/>
-                    <a:lstStyle/>
-                    <a:p>
-                      <a:pPr>
-                        <a:defRPr sz="1100"/>
-                      </a:pPr>
-                      <a:r>
-                        <a:rPr sz="1100">
-                          <a:latin typeface="Calibri"/>
-                        </a:rPr>
-                        <a:t>Video + PPT final</a:t>
-                      </a:r>
-                    </a:p>
-                  </a:txBody>
-                  <a:tcPr/>
-                </a:tc>
-                <a:tc>
-                  <a:txBody>
-                    <a:bodyPr/>
-                    <a:lstStyle/>
-                    <a:p>
-                      <a:pPr>
-                        <a:defRPr sz="1100"/>
-                      </a:pPr>
-                      <a:r>
-                        <a:rPr sz="1100">
-                          <a:latin typeface="Calibri"/>
-                        </a:rPr>
-                        <a:t>Semana 12</a:t>
-                      </a:r>
-                    </a:p>
-                  </a:txBody>
-                  <a:tcPr/>
-                </a:tc>
-                <a:tc>
-                  <a:txBody>
-                    <a:bodyPr/>
-                    <a:lstStyle/>
-                    <a:p>
-                      <a:pPr>
-                        <a:defRPr sz="1100"/>
-                      </a:pPr>
-                      <a:r>
-                        <a:rPr sz="1100">
-                          <a:latin typeface="Calibri"/>
-                        </a:rPr>
-                        <a:t>Andrés Carrasco</a:t>
-                      </a:r>
-                    </a:p>
-                  </a:txBody>
-                  <a:tcPr/>
-                </a:tc>
-                <a:tc>
-                  <a:txBody>
-                    <a:bodyPr/>
-                    <a:lstStyle/>
-                    <a:p>
-                      <a:pPr>
-                        <a:defRPr sz="1100"/>
-                      </a:pPr>
-                      <a:r>
-                        <a:rPr sz="1100">
-                          <a:latin typeface="Calibri"/>
-                        </a:rPr>
-                        <a:t>Guion, grabadora de audio, ffmpeg</a:t>
-                      </a:r>
-                    </a:p>
-                  </a:txBody>
-                  <a:tcPr/>
+                  <a:tcPr>
+                    <a:solidFill>
+                      <a:srgbClr val="050611"/>
+                    </a:solidFill>
+                  </a:tcPr>
                 </a:tc>
               </a:tr>
             </a:tbl>
           </a:graphicData>
         </a:graphic>
       </p:graphicFrame>
+      <p:sp>
+        <p:nvSpPr>
+          <p:cNvPr id="4" name="Rectangle 3"/>
+          <p:cNvSpPr/>
+          <p:nvPr/>
+        </p:nvSpPr>
+        <p:spPr>
+          <a:xfrm>
+            <a:off x="0" y="0"/>
+            <a:ext cx="12192000" cy="45720"/>
+          </a:xfrm>
+          <a:prstGeom prst="rect">
+            <a:avLst/>
+          </a:prstGeom>
+          <a:gradFill rotWithShape="1">
+            <a:gsLst>
+              <a:gs pos="0">
+                <a:srgbClr val="22D3EE"/>
+              </a:gs>
+              <a:gs pos="100000">
+                <a:srgbClr val="A855F7"/>
+              </a:gs>
+            </a:gsLst>
+            <a:lin scaled="0" ang="0"/>
+          </a:gradFill>
+          <a:ln>
+            <a:noFill/>
+          </a:ln>
+          <a:effectLst/>
+        </p:spPr>
+        <p:style>
+          <a:lnRef idx="1">
+            <a:schemeClr val="accent1"/>
+          </a:lnRef>
+          <a:fillRef idx="3">
+            <a:schemeClr val="accent1"/>
+          </a:fillRef>
+          <a:effectRef idx="2">
+            <a:schemeClr val="accent1"/>
+          </a:effectRef>
+          <a:fontRef idx="minor">
+            <a:schemeClr val="lt1"/>
+          </a:fontRef>
+        </p:style>
+        <p:txBody>
+          <a:bodyPr rtlCol="0" anchor="ctr"/>
+          <a:lstStyle/>
+          <a:p>
+            <a:pPr algn="ctr"/>
+          </a:p>
+        </p:txBody>
+      </p:sp>
     </p:spTree>
     <p:extLst>
       <p:ext uri="{BB962C8B-B14F-4D97-AF65-F5344CB8AC3E}">
@@ -5494,6 +6983,14 @@
 <file path=ppt/slides/slide7.xml><?xml version="1.0" encoding="utf-8"?>
 <p:sld xmlns:a="http://schemas.openxmlformats.org/drawingml/2006/main" xmlns:r="http://schemas.openxmlformats.org/officeDocument/2006/relationships" xmlns:p="http://schemas.openxmlformats.org/presentationml/2006/main">
   <p:cSld>
+    <p:bg>
+      <p:bgPr>
+        <a:solidFill>
+          <a:srgbClr val="050611"/>
+        </a:solidFill>
+        <a:effectLst/>
+      </p:bgPr>
+    </p:bg>
     <p:spTree>
       <p:nvGrpSpPr>
         <p:cNvPr id="1" name=""/>
@@ -5536,10 +7033,16 @@
           </a:bodyPr>
           <a:lstStyle/>
           <a:p>
+            <a:pPr>
+              <a:spcAft>
+                <a:spcPts val="1400"/>
+              </a:spcAft>
+              <a:buNone/>
+            </a:pPr>
             <a:r>
               <a:rPr sz="2600" b="1">
                 <a:solidFill>
-                  <a:srgbClr val="222222"/>
+                  <a:srgbClr val="22D3EE"/>
                 </a:solidFill>
                 <a:latin typeface="Calibri"/>
               </a:rPr>
@@ -5552,48 +7055,156 @@
             </a:endParaRPr>
           </a:p>
           <a:p>
-            <a:r>
-              <a:rPr sz="1800" b="0">
-                <a:solidFill>
-                  <a:srgbClr val="222222"/>
+            <a:pPr indent="-228600" marL="228600">
+              <a:lnSpc>
+                <a:spcPct val="115000"/>
+              </a:lnSpc>
+              <a:spcAft>
+                <a:spcPts val="600"/>
+              </a:spcAft>
+              <a:buClr>
+                <a:srgbClr val="5EEAD4"/>
+              </a:buClr>
+              <a:buSzPct val="80000"/>
+              <a:buFont typeface="Arial"/>
+              <a:buChar char="▪"/>
+            </a:pPr>
+            <a:r>
+              <a:rPr sz="1800">
+                <a:solidFill>
+                  <a:srgbClr val="E6EBF5"/>
                 </a:solidFill>
                 <a:latin typeface="Calibri"/>
               </a:rPr>
-              <a:t>•  Se utilizó un simulador web interactivo (HTML, CSS, JavaScript y la librería Plotly.js) en lugar de solo cálculos manuales.</a:t>
-            </a:r>
-          </a:p>
-          <a:p>
-            <a:r>
-              <a:rPr sz="1800" b="0">
-                <a:solidFill>
-                  <a:srgbClr val="222222"/>
+              <a:t>Se utilizó un simulador web interactivo (HTML, CSS, JavaScript y la librería Plotly.js) en lugar de solo cálculos manuales.</a:t>
+            </a:r>
+          </a:p>
+          <a:p>
+            <a:pPr indent="-228600" marL="228600">
+              <a:lnSpc>
+                <a:spcPct val="115000"/>
+              </a:lnSpc>
+              <a:spcAft>
+                <a:spcPts val="600"/>
+              </a:spcAft>
+              <a:buClr>
+                <a:srgbClr val="5EEAD4"/>
+              </a:buClr>
+              <a:buSzPct val="80000"/>
+              <a:buFont typeface="Arial"/>
+              <a:buChar char="▪"/>
+            </a:pPr>
+            <a:r>
+              <a:rPr sz="1800">
+                <a:solidFill>
+                  <a:srgbClr val="E6EBF5"/>
                 </a:solidFill>
                 <a:latin typeface="Calibri"/>
               </a:rPr>
-              <a:t>•  Permite visualizar en tiempo real la curva de costo C(x) y su derivada C'(x), y modificar parámetros del modelo.</a:t>
-            </a:r>
-          </a:p>
-          <a:p>
-            <a:r>
-              <a:rPr sz="1800" b="0">
-                <a:solidFill>
-                  <a:srgbClr val="222222"/>
+              <a:t>Permite visualizar en tiempo real la curva de costo C(x) y su derivada C'(x), y modificar parámetros del modelo.</a:t>
+            </a:r>
+          </a:p>
+          <a:p>
+            <a:pPr indent="-228600" marL="228600">
+              <a:lnSpc>
+                <a:spcPct val="115000"/>
+              </a:lnSpc>
+              <a:spcAft>
+                <a:spcPts val="600"/>
+              </a:spcAft>
+              <a:buClr>
+                <a:srgbClr val="5EEAD4"/>
+              </a:buClr>
+              <a:buSzPct val="80000"/>
+              <a:buFont typeface="Arial"/>
+              <a:buChar char="▪"/>
+            </a:pPr>
+            <a:r>
+              <a:rPr sz="1800">
+                <a:solidFill>
+                  <a:srgbClr val="E6EBF5"/>
                 </a:solidFill>
                 <a:latin typeface="Calibri"/>
               </a:rPr>
-              <a:t>•  Facilita comprender de forma visual el concepto de punto crítico y optimización, algo difícil de transmitir solo con álgebra.</a:t>
-            </a:r>
-          </a:p>
-          <a:p>
-            <a:r>
-              <a:rPr sz="1800" b="0">
-                <a:solidFill>
-                  <a:srgbClr val="222222"/>
+              <a:t>Facilita comprender de forma visual el concepto de punto crítico y optimización, algo difícil de transmitir solo con álgebra.</a:t>
+            </a:r>
+          </a:p>
+          <a:p>
+            <a:pPr indent="-228600" marL="228600">
+              <a:lnSpc>
+                <a:spcPct val="115000"/>
+              </a:lnSpc>
+              <a:spcAft>
+                <a:spcPts val="600"/>
+              </a:spcAft>
+              <a:buClr>
+                <a:srgbClr val="5EEAD4"/>
+              </a:buClr>
+              <a:buSzPct val="80000"/>
+              <a:buFont typeface="Arial"/>
+              <a:buChar char="▪"/>
+            </a:pPr>
+            <a:r>
+              <a:rPr sz="1800">
+                <a:solidFill>
+                  <a:srgbClr val="E6EBF5"/>
                 </a:solidFill>
                 <a:latin typeface="Calibri"/>
               </a:rPr>
-              <a:t>•  El sitio se publicó en la nube (Vercel), reforzando la coherencia entre el tema del proyecto (costos cloud) y la herramienta usada para exponerlo.</a:t>
-            </a:r>
+              <a:t>El sitio se publicó en la nube (Vercel), reforzando la coherencia entre el tema del proyecto (costos cloud) y la herramienta usada para exponerlo.</a:t>
+            </a:r>
+          </a:p>
+        </p:txBody>
+      </p:sp>
+      <p:sp>
+        <p:nvSpPr>
+          <p:cNvPr id="6" name="Rectangle 5"/>
+          <p:cNvSpPr/>
+          <p:nvPr/>
+        </p:nvSpPr>
+        <p:spPr>
+          <a:xfrm>
+            <a:off x="0" y="0"/>
+            <a:ext cx="12192000" cy="45720"/>
+          </a:xfrm>
+          <a:prstGeom prst="rect">
+            <a:avLst/>
+          </a:prstGeom>
+          <a:gradFill rotWithShape="1">
+            <a:gsLst>
+              <a:gs pos="0">
+                <a:srgbClr val="22D3EE"/>
+              </a:gs>
+              <a:gs pos="100000">
+                <a:srgbClr val="A855F7"/>
+              </a:gs>
+            </a:gsLst>
+            <a:lin scaled="0" ang="0"/>
+          </a:gradFill>
+          <a:ln>
+            <a:noFill/>
+          </a:ln>
+          <a:effectLst/>
+        </p:spPr>
+        <p:style>
+          <a:lnRef idx="1">
+            <a:schemeClr val="accent1"/>
+          </a:lnRef>
+          <a:fillRef idx="3">
+            <a:schemeClr val="accent1"/>
+          </a:fillRef>
+          <a:effectRef idx="2">
+            <a:schemeClr val="accent1"/>
+          </a:effectRef>
+          <a:fontRef idx="minor">
+            <a:schemeClr val="lt1"/>
+          </a:fontRef>
+        </p:style>
+        <p:txBody>
+          <a:bodyPr rtlCol="0" anchor="ctr"/>
+          <a:lstStyle/>
+          <a:p>
+            <a:pPr algn="ctr"/>
           </a:p>
         </p:txBody>
       </p:sp>
@@ -5613,6 +7224,14 @@
 <file path=ppt/slides/slide8.xml><?xml version="1.0" encoding="utf-8"?>
 <p:sld xmlns:a="http://schemas.openxmlformats.org/drawingml/2006/main" xmlns:r="http://schemas.openxmlformats.org/officeDocument/2006/relationships" xmlns:p="http://schemas.openxmlformats.org/presentationml/2006/main">
   <p:cSld>
+    <p:bg>
+      <p:bgPr>
+        <a:solidFill>
+          <a:srgbClr val="050611"/>
+        </a:solidFill>
+        <a:effectLst/>
+      </p:bgPr>
+    </p:bg>
     <p:spTree>
       <p:nvGrpSpPr>
         <p:cNvPr id="1" name=""/>
@@ -5655,10 +7274,16 @@
           </a:bodyPr>
           <a:lstStyle/>
           <a:p>
+            <a:pPr>
+              <a:spcAft>
+                <a:spcPts val="1400"/>
+              </a:spcAft>
+              <a:buNone/>
+            </a:pPr>
             <a:r>
               <a:rPr sz="2600" b="1">
                 <a:solidFill>
-                  <a:srgbClr val="222222"/>
+                  <a:srgbClr val="22D3EE"/>
                 </a:solidFill>
                 <a:latin typeface="Calibri"/>
               </a:rPr>
@@ -5671,37 +7296,131 @@
             </a:endParaRPr>
           </a:p>
           <a:p>
-            <a:r>
-              <a:rPr sz="1800" b="0">
-                <a:solidFill>
-                  <a:srgbClr val="222222"/>
+            <a:pPr indent="-228600" marL="228600">
+              <a:lnSpc>
+                <a:spcPct val="115000"/>
+              </a:lnSpc>
+              <a:spcAft>
+                <a:spcPts val="600"/>
+              </a:spcAft>
+              <a:buClr>
+                <a:srgbClr val="5EEAD4"/>
+              </a:buClr>
+              <a:buSzPct val="80000"/>
+              <a:buFont typeface="Arial"/>
+              <a:buChar char="▪"/>
+            </a:pPr>
+            <a:r>
+              <a:rPr sz="1800">
+                <a:solidFill>
+                  <a:srgbClr val="E6EBF5"/>
                 </a:solidFill>
                 <a:latin typeface="Calibri"/>
               </a:rPr>
-              <a:t>•  Una función cuadrática C(x) = a·x² + (b+c)·x + d permite representar el costo total en función de la cantidad de recursos (x).</a:t>
-            </a:r>
-          </a:p>
-          <a:p>
-            <a:r>
-              <a:rPr sz="1800" b="0">
-                <a:solidFill>
-                  <a:srgbClr val="222222"/>
+              <a:t>Una función cuadrática C(x) = a·x² + (b+c)·x + d permite representar el costo total en función de la cantidad de recursos (x).</a:t>
+            </a:r>
+          </a:p>
+          <a:p>
+            <a:pPr indent="-228600" marL="228600">
+              <a:lnSpc>
+                <a:spcPct val="115000"/>
+              </a:lnSpc>
+              <a:spcAft>
+                <a:spcPts val="600"/>
+              </a:spcAft>
+              <a:buClr>
+                <a:srgbClr val="5EEAD4"/>
+              </a:buClr>
+              <a:buSzPct val="80000"/>
+              <a:buFont typeface="Arial"/>
+              <a:buChar char="▪"/>
+            </a:pPr>
+            <a:r>
+              <a:rPr sz="1800">
+                <a:solidFill>
+                  <a:srgbClr val="E6EBF5"/>
                 </a:solidFill>
                 <a:latin typeface="Calibri"/>
               </a:rPr>
-              <a:t>•  El coeficiente a &gt; 0 refleja que, a partir de cierto punto, agregar más instancias aumenta el costo (sobreaprovisionamiento).</a:t>
-            </a:r>
-          </a:p>
-          <a:p>
-            <a:r>
-              <a:rPr sz="1800" b="0">
-                <a:solidFill>
-                  <a:srgbClr val="222222"/>
+              <a:t>El coeficiente a &gt; 0 refleja que, a partir de cierto punto, agregar más instancias aumenta el costo (sobreaprovisionamiento).</a:t>
+            </a:r>
+          </a:p>
+          <a:p>
+            <a:pPr indent="-228600" marL="228600">
+              <a:lnSpc>
+                <a:spcPct val="115000"/>
+              </a:lnSpc>
+              <a:spcAft>
+                <a:spcPts val="600"/>
+              </a:spcAft>
+              <a:buClr>
+                <a:srgbClr val="5EEAD4"/>
+              </a:buClr>
+              <a:buSzPct val="80000"/>
+              <a:buFont typeface="Arial"/>
+              <a:buChar char="▪"/>
+            </a:pPr>
+            <a:r>
+              <a:rPr sz="1800">
+                <a:solidFill>
+                  <a:srgbClr val="E6EBF5"/>
                 </a:solidFill>
                 <a:latin typeface="Calibri"/>
               </a:rPr>
-              <a:t>•  Referencias: Stewart, J. (2018). Cálculo: Trascendentes tempranas; Larson, R. y Edwards, B. (2018). Cálculo.</a:t>
-            </a:r>
+              <a:t>Referencias: Stewart, J. (2018). Cálculo: Trascendentes tempranas; Larson, R. y Edwards, B. (2018). Cálculo.</a:t>
+            </a:r>
+          </a:p>
+        </p:txBody>
+      </p:sp>
+      <p:sp>
+        <p:nvSpPr>
+          <p:cNvPr id="5" name="Rectangle 4"/>
+          <p:cNvSpPr/>
+          <p:nvPr/>
+        </p:nvSpPr>
+        <p:spPr>
+          <a:xfrm>
+            <a:off x="0" y="0"/>
+            <a:ext cx="12192000" cy="45720"/>
+          </a:xfrm>
+          <a:prstGeom prst="rect">
+            <a:avLst/>
+          </a:prstGeom>
+          <a:gradFill rotWithShape="1">
+            <a:gsLst>
+              <a:gs pos="0">
+                <a:srgbClr val="22D3EE"/>
+              </a:gs>
+              <a:gs pos="100000">
+                <a:srgbClr val="A855F7"/>
+              </a:gs>
+            </a:gsLst>
+            <a:lin scaled="0" ang="0"/>
+          </a:gradFill>
+          <a:ln>
+            <a:noFill/>
+          </a:ln>
+          <a:effectLst/>
+        </p:spPr>
+        <p:style>
+          <a:lnRef idx="1">
+            <a:schemeClr val="accent1"/>
+          </a:lnRef>
+          <a:fillRef idx="3">
+            <a:schemeClr val="accent1"/>
+          </a:fillRef>
+          <a:effectRef idx="2">
+            <a:schemeClr val="accent1"/>
+          </a:effectRef>
+          <a:fontRef idx="minor">
+            <a:schemeClr val="lt1"/>
+          </a:fontRef>
+        </p:style>
+        <p:txBody>
+          <a:bodyPr rtlCol="0" anchor="ctr"/>
+          <a:lstStyle/>
+          <a:p>
+            <a:pPr algn="ctr"/>
           </a:p>
         </p:txBody>
       </p:sp>
@@ -5721,6 +7440,14 @@
 <file path=ppt/slides/slide9.xml><?xml version="1.0" encoding="utf-8"?>
 <p:sld xmlns:a="http://schemas.openxmlformats.org/drawingml/2006/main" xmlns:r="http://schemas.openxmlformats.org/officeDocument/2006/relationships" xmlns:p="http://schemas.openxmlformats.org/presentationml/2006/main">
   <p:cSld>
+    <p:bg>
+      <p:bgPr>
+        <a:solidFill>
+          <a:srgbClr val="050611"/>
+        </a:solidFill>
+        <a:effectLst/>
+      </p:bgPr>
+    </p:bg>
     <p:spTree>
       <p:nvGrpSpPr>
         <p:cNvPr id="1" name=""/>
@@ -5763,10 +7490,16 @@
           </a:bodyPr>
           <a:lstStyle/>
           <a:p>
+            <a:pPr>
+              <a:spcAft>
+                <a:spcPts val="1400"/>
+              </a:spcAft>
+              <a:buNone/>
+            </a:pPr>
             <a:r>
               <a:rPr sz="2600" b="1">
                 <a:solidFill>
-                  <a:srgbClr val="222222"/>
+                  <a:srgbClr val="22D3EE"/>
                 </a:solidFill>
                 <a:latin typeface="Calibri"/>
               </a:rPr>
@@ -5779,48 +7512,156 @@
             </a:endParaRPr>
           </a:p>
           <a:p>
-            <a:r>
-              <a:rPr sz="1800" b="0">
-                <a:solidFill>
-                  <a:srgbClr val="222222"/>
+            <a:pPr indent="-228600" marL="228600">
+              <a:lnSpc>
+                <a:spcPct val="115000"/>
+              </a:lnSpc>
+              <a:spcAft>
+                <a:spcPts val="600"/>
+              </a:spcAft>
+              <a:buClr>
+                <a:srgbClr val="5EEAD4"/>
+              </a:buClr>
+              <a:buSzPct val="80000"/>
+              <a:buFont typeface="Arial"/>
+              <a:buChar char="▪"/>
+            </a:pPr>
+            <a:r>
+              <a:rPr sz="1800">
+                <a:solidFill>
+                  <a:srgbClr val="E6EBF5"/>
                 </a:solidFill>
                 <a:latin typeface="Calibri"/>
               </a:rPr>
-              <a:t>•  La derivada C'(x) representa la tasa de cambio del costo respecto al número de instancias (costo marginal).</a:t>
-            </a:r>
-          </a:p>
-          <a:p>
-            <a:r>
-              <a:rPr sz="1800" b="0">
-                <a:solidFill>
-                  <a:srgbClr val="222222"/>
+              <a:t>La derivada C'(x) representa la tasa de cambio del costo respecto al número de instancias (costo marginal).</a:t>
+            </a:r>
+          </a:p>
+          <a:p>
+            <a:pPr indent="-228600" marL="228600">
+              <a:lnSpc>
+                <a:spcPct val="115000"/>
+              </a:lnSpc>
+              <a:spcAft>
+                <a:spcPts val="600"/>
+              </a:spcAft>
+              <a:buClr>
+                <a:srgbClr val="5EEAD4"/>
+              </a:buClr>
+              <a:buSzPct val="80000"/>
+              <a:buFont typeface="Arial"/>
+              <a:buChar char="▪"/>
+            </a:pPr>
+            <a:r>
+              <a:rPr sz="1800">
+                <a:solidFill>
+                  <a:srgbClr val="E6EBF5"/>
                 </a:solidFill>
                 <a:latin typeface="Calibri"/>
               </a:rPr>
-              <a:t>•  Un punto crítico se obtiene resolviendo C'(x) = 0.</a:t>
-            </a:r>
-          </a:p>
-          <a:p>
-            <a:r>
-              <a:rPr sz="1800" b="0">
-                <a:solidFill>
-                  <a:srgbClr val="222222"/>
+              <a:t>Un punto crítico se obtiene resolviendo C'(x) = 0.</a:t>
+            </a:r>
+          </a:p>
+          <a:p>
+            <a:pPr indent="-228600" marL="228600">
+              <a:lnSpc>
+                <a:spcPct val="115000"/>
+              </a:lnSpc>
+              <a:spcAft>
+                <a:spcPts val="600"/>
+              </a:spcAft>
+              <a:buClr>
+                <a:srgbClr val="5EEAD4"/>
+              </a:buClr>
+              <a:buSzPct val="80000"/>
+              <a:buFont typeface="Arial"/>
+              <a:buChar char="▪"/>
+            </a:pPr>
+            <a:r>
+              <a:rPr sz="1800">
+                <a:solidFill>
+                  <a:srgbClr val="E6EBF5"/>
                 </a:solidFill>
                 <a:latin typeface="Calibri"/>
               </a:rPr>
-              <a:t>•  El criterio de la segunda derivada (C''(x) &gt; 0) confirma si ese punto corresponde a un mínimo.</a:t>
-            </a:r>
-          </a:p>
-          <a:p>
-            <a:r>
-              <a:rPr sz="1800" b="0">
-                <a:solidFill>
-                  <a:srgbClr val="222222"/>
+              <a:t>El criterio de la segunda derivada (C''(x) &gt; 0) confirma si ese punto corresponde a un mínimo.</a:t>
+            </a:r>
+          </a:p>
+          <a:p>
+            <a:pPr indent="-228600" marL="228600">
+              <a:lnSpc>
+                <a:spcPct val="115000"/>
+              </a:lnSpc>
+              <a:spcAft>
+                <a:spcPts val="600"/>
+              </a:spcAft>
+              <a:buClr>
+                <a:srgbClr val="5EEAD4"/>
+              </a:buClr>
+              <a:buSzPct val="80000"/>
+              <a:buFont typeface="Arial"/>
+              <a:buChar char="▪"/>
+            </a:pPr>
+            <a:r>
+              <a:rPr sz="1800">
+                <a:solidFill>
+                  <a:srgbClr val="E6EBF5"/>
                 </a:solidFill>
                 <a:latin typeface="Calibri"/>
               </a:rPr>
-              <a:t>•  Estos conceptos corresponden a las unidades de límites, derivadas y aplicaciones de la derivada del curso.</a:t>
-            </a:r>
+              <a:t>Estos conceptos corresponden a las unidades de límites, derivadas y aplicaciones de la derivada del curso.</a:t>
+            </a:r>
+          </a:p>
+        </p:txBody>
+      </p:sp>
+      <p:sp>
+        <p:nvSpPr>
+          <p:cNvPr id="5" name="Rectangle 4"/>
+          <p:cNvSpPr/>
+          <p:nvPr/>
+        </p:nvSpPr>
+        <p:spPr>
+          <a:xfrm>
+            <a:off x="0" y="0"/>
+            <a:ext cx="12192000" cy="45720"/>
+          </a:xfrm>
+          <a:prstGeom prst="rect">
+            <a:avLst/>
+          </a:prstGeom>
+          <a:gradFill rotWithShape="1">
+            <a:gsLst>
+              <a:gs pos="0">
+                <a:srgbClr val="22D3EE"/>
+              </a:gs>
+              <a:gs pos="100000">
+                <a:srgbClr val="A855F7"/>
+              </a:gs>
+            </a:gsLst>
+            <a:lin scaled="0" ang="0"/>
+          </a:gradFill>
+          <a:ln>
+            <a:noFill/>
+          </a:ln>
+          <a:effectLst/>
+        </p:spPr>
+        <p:style>
+          <a:lnRef idx="1">
+            <a:schemeClr val="accent1"/>
+          </a:lnRef>
+          <a:fillRef idx="3">
+            <a:schemeClr val="accent1"/>
+          </a:fillRef>
+          <a:effectRef idx="2">
+            <a:schemeClr val="accent1"/>
+          </a:effectRef>
+          <a:fontRef idx="minor">
+            <a:schemeClr val="lt1"/>
+          </a:fontRef>
+        </p:style>
+        <p:txBody>
+          <a:bodyPr rtlCol="0" anchor="ctr"/>
+          <a:lstStyle/>
+          <a:p>
+            <a:pPr algn="ctr"/>
           </a:p>
         </p:txBody>
       </p:sp>

</xml_diff>

<commit_message>
PPT: mencionar que el video de presentación está publicado en el sitio web
</commit_message>
<xml_diff>
--- a/Presentación Proyecto.pptx
+++ b/Presentación Proyecto.pptx
@@ -4650,6 +4650,16 @@
                 <a:latin typeface="Calibri"/>
               </a:rPr>
               <a:t> GitHub.</a:t>
+            </a:r>
+          </a:p>
+          <a:p>
+            <a:r>
+              <a:rPr sz="1800">
+                <a:solidFill>
+                  <a:srgbClr val="E6EBF5"/>
+                </a:solidFill>
+              </a:rPr>
+              <a:t>El video de presentación (con narración) también está publicado en ese sitio web, en la sección 'Video de presentación'.</a:t>
             </a:r>
           </a:p>
         </p:txBody>

</xml_diff>